<commit_message>
Split Distributions slide into 2x2 per-variable charts
Replace the single 4-in-1 distributions strip with four separate, larger charts
(age, income, credit_score, tenure) laid out 2x2. Each uses a grey Real fill with
coloured step outlines per method, so the five series are readable and easy to
compare. Adds reports/dist_*.png.
</commit_message>
<xml_diff>
--- a/slides.pptx
+++ b/slides.pptx
@@ -3539,7 +3539,7 @@
       </p:sp>
       <p:pic>
         <p:nvPicPr>
-          <p:cNvPr id="4" name="Picture 3" descr="distributions_all_methods.png"/>
+          <p:cNvPr id="4" name="Picture 3" descr="dist_age.png"/>
           <p:cNvPicPr>
             <a:picLocks noChangeAspect="1"/>
           </p:cNvPicPr>
@@ -3553,17 +3553,89 @@
         </p:blipFill>
         <p:spPr>
           <a:xfrm>
-            <a:off x="731520" y="2380578"/>
-            <a:ext cx="10972800" cy="2736922"/>
+            <a:off x="1571625" y="1600200"/>
+            <a:ext cx="3600450" cy="2057400"/>
           </a:xfrm>
           <a:prstGeom prst="rect">
             <a:avLst/>
           </a:prstGeom>
         </p:spPr>
       </p:pic>
-      <p:sp>
-        <p:nvSpPr>
-          <p:cNvPr id="5" name="TextBox 4"/>
+      <p:pic>
+        <p:nvPicPr>
+          <p:cNvPr id="5" name="Picture 4" descr="dist_income.png"/>
+          <p:cNvPicPr>
+            <a:picLocks noChangeAspect="1"/>
+          </p:cNvPicPr>
+          <p:nvPr/>
+        </p:nvPicPr>
+        <p:blipFill>
+          <a:blip r:embed="rId3"/>
+          <a:stretch>
+            <a:fillRect/>
+          </a:stretch>
+        </p:blipFill>
+        <p:spPr>
+          <a:xfrm>
+            <a:off x="6989444" y="1600200"/>
+            <a:ext cx="3600450" cy="2057400"/>
+          </a:xfrm>
+          <a:prstGeom prst="rect">
+            <a:avLst/>
+          </a:prstGeom>
+        </p:spPr>
+      </p:pic>
+      <p:pic>
+        <p:nvPicPr>
+          <p:cNvPr id="6" name="Picture 5" descr="dist_credit.png"/>
+          <p:cNvPicPr>
+            <a:picLocks noChangeAspect="1"/>
+          </p:cNvPicPr>
+          <p:nvPr/>
+        </p:nvPicPr>
+        <p:blipFill>
+          <a:blip r:embed="rId4"/>
+          <a:stretch>
+            <a:fillRect/>
+          </a:stretch>
+        </p:blipFill>
+        <p:spPr>
+          <a:xfrm>
+            <a:off x="1573666" y="3886200"/>
+            <a:ext cx="3596367" cy="2057400"/>
+          </a:xfrm>
+          <a:prstGeom prst="rect">
+            <a:avLst/>
+          </a:prstGeom>
+        </p:spPr>
+      </p:pic>
+      <p:pic>
+        <p:nvPicPr>
+          <p:cNvPr id="7" name="Picture 6" descr="dist_tenure.png"/>
+          <p:cNvPicPr>
+            <a:picLocks noChangeAspect="1"/>
+          </p:cNvPicPr>
+          <p:nvPr/>
+        </p:nvPicPr>
+        <p:blipFill>
+          <a:blip r:embed="rId5"/>
+          <a:stretch>
+            <a:fillRect/>
+          </a:stretch>
+        </p:blipFill>
+        <p:spPr>
+          <a:xfrm>
+            <a:off x="6989444" y="3886200"/>
+            <a:ext cx="3600450" cy="2057400"/>
+          </a:xfrm>
+          <a:prstGeom prst="rect">
+            <a:avLst/>
+          </a:prstGeom>
+        </p:spPr>
+      </p:pic>
+      <p:sp>
+        <p:nvSpPr>
+          <p:cNvPr id="8" name="TextBox 7"/>
           <p:cNvSpPr txBox="1"/>
           <p:nvPr/>
         </p:nvSpPr>
@@ -3591,7 +3663,7 @@
                 </a:solidFill>
                 <a:latin typeface="Calibri"/>
               </a:rPr>
-              <a:t>Real vs each method on age, income, credit score, tenure.</a:t>
+              <a:t>Real (grey fill) vs each method (coloured outline) — per variable for easier comparison.</a:t>
             </a:r>
           </a:p>
         </p:txBody>

</xml_diff>

<commit_message>
Redesign comparison dashboard as per-metric small multiples
The single 5×7 grouped-bar chart crammed all methods together and was hard to
read. Replace it with one small panel per metric (raw values, own y-scale, value
labels, best highlighted with a black edge) plus an M1–M5 legend. Regenerate
comparison_dashboard.png and rebuild slides.pptx.
</commit_message>
<xml_diff>
--- a/slides.pptx
+++ b/slides.pptx
@@ -9826,8 +9826,8 @@
         </p:blipFill>
         <p:spPr>
           <a:xfrm>
-            <a:off x="731520" y="1771590"/>
-            <a:ext cx="10972800" cy="3863459"/>
+            <a:off x="1603721" y="1554480"/>
+            <a:ext cx="9228396" cy="4297680"/>
           </a:xfrm>
           <a:prstGeom prst="rect">
             <a:avLst/>

</xml_diff>

<commit_message>
Add within-table (customer) correlation charts
Cross-table correlation is weak for every method, so add the more discriminating
within-customer view: Pearson correlation matrices (income/credit/age/tenure/
dependents) for Real vs each method, plus a per-method MAE ranking. Reveals that
M1's Gaussian Copula reproduces the correlation structure 3–5× better than the
others (MAE 0.040), while M5/SmartNoise — the marginal-fidelity winner — is the
worst on correlation (0.212), the cost of DP noise + spanning-tree marginals.
New notebook section + reports/in_table_correlation.png, in_table_corr_error.png,
and a matching slide.
</commit_message>
<xml_diff>
--- a/slides.pptx
+++ b/slides.pptx
@@ -19,6 +19,7 @@
     <p:sldId id="267" r:id="rId18"/>
     <p:sldId id="268" r:id="rId19"/>
     <p:sldId id="269" r:id="rId20"/>
+    <p:sldId id="270" r:id="rId21"/>
   </p:sldIdLst>
   <p:sldSz cx="12191695" cy="6858000" type="screen4x3"/>
   <p:notesSz cx="6858000" cy="9144000"/>
@@ -3416,7 +3417,7 @@
                 </a:solidFill>
                 <a:latin typeface="Calibri"/>
               </a:rPr>
-              <a:t>Feature→category Spearman correlations. The closer each method's grid matches 'Real', the lower its cross-table MAD.</a:t>
+              <a:t>Feature→category Spearman correlations. Weak for every method — the cross-table signal is the hardest to keep.</a:t>
             </a:r>
           </a:p>
         </p:txBody>
@@ -3430,6 +3431,308 @@
 </file>
 
 <file path=ppt/slides/slide11.xml><?xml version="1.0" encoding="utf-8"?>
+<p:sld xmlns:a="http://schemas.openxmlformats.org/drawingml/2006/main" xmlns:p="http://schemas.openxmlformats.org/presentationml/2006/main" xmlns:r="http://schemas.openxmlformats.org/officeDocument/2006/relationships">
+  <p:cSld>
+    <p:bg>
+      <p:bgPr>
+        <a:solidFill>
+          <a:srgbClr val="FFFFFF"/>
+        </a:solidFill>
+        <a:effectLst/>
+      </p:bgPr>
+    </p:bg>
+    <p:spTree>
+      <p:nvGrpSpPr>
+        <p:cNvPr id="1" name=""/>
+        <p:cNvGrpSpPr/>
+        <p:nvPr/>
+      </p:nvGrpSpPr>
+      <p:grpSpPr/>
+      <p:sp>
+        <p:nvSpPr>
+          <p:cNvPr id="2" name="Rectangle 1"/>
+          <p:cNvSpPr/>
+          <p:nvPr/>
+        </p:nvSpPr>
+        <p:spPr>
+          <a:xfrm>
+            <a:off x="0" y="0"/>
+            <a:ext cx="201168" cy="6858000"/>
+          </a:xfrm>
+          <a:prstGeom prst="rect">
+            <a:avLst/>
+          </a:prstGeom>
+          <a:solidFill>
+            <a:srgbClr val="4E79A7"/>
+          </a:solidFill>
+          <a:ln>
+            <a:noFill/>
+          </a:ln>
+        </p:spPr>
+        <p:style>
+          <a:lnRef idx="1">
+            <a:schemeClr val="accent1"/>
+          </a:lnRef>
+          <a:fillRef idx="3">
+            <a:schemeClr val="accent1"/>
+          </a:fillRef>
+          <a:effectRef idx="2">
+            <a:schemeClr val="accent1"/>
+          </a:effectRef>
+          <a:fontRef idx="minor">
+            <a:schemeClr val="lt1"/>
+          </a:fontRef>
+        </p:style>
+        <p:txBody>
+          <a:bodyPr rtlCol="0" anchor="ctr"/>
+          <a:lstStyle/>
+          <a:p>
+            <a:pPr algn="ctr"/>
+          </a:p>
+        </p:txBody>
+      </p:sp>
+      <p:sp>
+        <p:nvSpPr>
+          <p:cNvPr id="3" name="TextBox 2"/>
+          <p:cNvSpPr txBox="1"/>
+          <p:nvPr/>
+        </p:nvSpPr>
+        <p:spPr>
+          <a:xfrm>
+            <a:off x="548640" y="384048"/>
+            <a:ext cx="11155680" cy="1005840"/>
+          </a:xfrm>
+          <a:prstGeom prst="rect">
+            <a:avLst/>
+          </a:prstGeom>
+          <a:noFill/>
+        </p:spPr>
+        <p:txBody>
+          <a:bodyPr wrap="none">
+            <a:spAutoFit/>
+          </a:bodyPr>
+          <a:lstStyle/>
+          <a:p>
+            <a:pPr algn="l"/>
+            <a:r>
+              <a:rPr sz="1300" b="1" i="0">
+                <a:solidFill>
+                  <a:srgbClr val="4E79A7"/>
+                </a:solidFill>
+                <a:latin typeface="Calibri"/>
+              </a:rPr>
+              <a:t>IN-TABLE CORRELATION</a:t>
+            </a:r>
+          </a:p>
+          <a:p>
+            <a:pPr algn="l"/>
+            <a:r>
+              <a:rPr sz="3200" b="1" i="0">
+                <a:solidFill>
+                  <a:srgbClr val="1F2A37"/>
+                </a:solidFill>
+                <a:latin typeface="Calibri"/>
+              </a:rPr>
+              <a:t>Within-customer correlation: M1 dominates</a:t>
+            </a:r>
+          </a:p>
+        </p:txBody>
+      </p:sp>
+      <p:pic>
+        <p:nvPicPr>
+          <p:cNvPr id="4" name="Picture 3" descr="in_table_correlation.png"/>
+          <p:cNvPicPr>
+            <a:picLocks noChangeAspect="1"/>
+          </p:cNvPicPr>
+          <p:nvPr/>
+        </p:nvPicPr>
+        <p:blipFill>
+          <a:blip r:embed="rId2"/>
+          <a:stretch>
+            <a:fillRect/>
+          </a:stretch>
+        </p:blipFill>
+        <p:spPr>
+          <a:xfrm>
+            <a:off x="1110252" y="1508760"/>
+            <a:ext cx="6740615" cy="4480560"/>
+          </a:xfrm>
+          <a:prstGeom prst="rect">
+            <a:avLst/>
+          </a:prstGeom>
+        </p:spPr>
+      </p:pic>
+      <p:sp>
+        <p:nvSpPr>
+          <p:cNvPr id="5" name="TextBox 4"/>
+          <p:cNvSpPr txBox="1"/>
+          <p:nvPr/>
+        </p:nvSpPr>
+        <p:spPr>
+          <a:xfrm>
+            <a:off x="8595360" y="1737360"/>
+            <a:ext cx="3200400" cy="4023360"/>
+          </a:xfrm>
+          <a:prstGeom prst="rect">
+            <a:avLst/>
+          </a:prstGeom>
+          <a:noFill/>
+        </p:spPr>
+        <p:txBody>
+          <a:bodyPr wrap="square">
+            <a:spAutoFit/>
+          </a:bodyPr>
+          <a:lstStyle/>
+          <a:p>
+            <a:pPr algn="l"/>
+            <a:r>
+              <a:rPr sz="1500" b="1" i="0">
+                <a:solidFill>
+                  <a:srgbClr val="4E79A7"/>
+                </a:solidFill>
+                <a:latin typeface="Calibri"/>
+              </a:rPr>
+              <a:t>MAE vs Real ↓</a:t>
+            </a:r>
+          </a:p>
+          <a:p>
+            <a:pPr algn="l">
+              <a:spcAft>
+                <a:spcPts val="700"/>
+              </a:spcAft>
+            </a:pPr>
+            <a:r>
+              <a:rPr sz="1400" b="1" i="0">
+                <a:solidFill>
+                  <a:srgbClr val="4E79A7"/>
+                </a:solidFill>
+                <a:latin typeface="Calibri"/>
+              </a:rPr>
+              <a:t>M1  0.040   (Gaussian Copula)</a:t>
+            </a:r>
+          </a:p>
+          <a:p>
+            <a:pPr algn="l">
+              <a:spcAft>
+                <a:spcPts val="700"/>
+              </a:spcAft>
+            </a:pPr>
+            <a:r>
+              <a:rPr sz="1400" b="0" i="0">
+                <a:solidFill>
+                  <a:srgbClr val="E15759"/>
+                </a:solidFill>
+                <a:latin typeface="Calibri"/>
+              </a:rPr>
+              <a:t>M4  0.110</a:t>
+            </a:r>
+          </a:p>
+          <a:p>
+            <a:pPr algn="l">
+              <a:spcAft>
+                <a:spcPts val="700"/>
+              </a:spcAft>
+            </a:pPr>
+            <a:r>
+              <a:rPr sz="1400" b="0" i="0">
+                <a:solidFill>
+                  <a:srgbClr val="59A14F"/>
+                </a:solidFill>
+                <a:latin typeface="Calibri"/>
+              </a:rPr>
+              <a:t>M3  0.124</a:t>
+            </a:r>
+          </a:p>
+          <a:p>
+            <a:pPr algn="l">
+              <a:spcAft>
+                <a:spcPts val="700"/>
+              </a:spcAft>
+            </a:pPr>
+            <a:r>
+              <a:rPr sz="1400" b="0" i="0">
+                <a:solidFill>
+                  <a:srgbClr val="F28E2B"/>
+                </a:solidFill>
+                <a:latin typeface="Calibri"/>
+              </a:rPr>
+              <a:t>M2  0.138</a:t>
+            </a:r>
+          </a:p>
+          <a:p>
+            <a:pPr algn="l">
+              <a:spcAft>
+                <a:spcPts val="700"/>
+              </a:spcAft>
+            </a:pPr>
+            <a:r>
+              <a:rPr sz="1400" b="1" i="0">
+                <a:solidFill>
+                  <a:srgbClr val="B07AA1"/>
+                </a:solidFill>
+                <a:latin typeface="Calibri"/>
+              </a:rPr>
+              <a:t>M5  0.212   (DP cost)</a:t>
+            </a:r>
+          </a:p>
+          <a:p>
+            <a:pPr algn="l"/>
+            <a:r>
+              <a:rPr sz="1200" b="0" i="1">
+                <a:solidFill>
+                  <a:srgbClr val="5B6670"/>
+                </a:solidFill>
+                <a:latin typeface="Calibri"/>
+              </a:rPr>
+              <a:t>M1 reproduces income↔credit↔age 3–5× better; M5 (best marginals) is worst on correlation.</a:t>
+            </a:r>
+          </a:p>
+        </p:txBody>
+      </p:sp>
+      <p:sp>
+        <p:nvSpPr>
+          <p:cNvPr id="6" name="TextBox 5"/>
+          <p:cNvSpPr txBox="1"/>
+          <p:nvPr/>
+        </p:nvSpPr>
+        <p:spPr>
+          <a:xfrm>
+            <a:off x="777240" y="6309360"/>
+            <a:ext cx="10607040" cy="457200"/>
+          </a:xfrm>
+          <a:prstGeom prst="rect">
+            <a:avLst/>
+          </a:prstGeom>
+          <a:noFill/>
+        </p:spPr>
+        <p:txBody>
+          <a:bodyPr wrap="none">
+            <a:spAutoFit/>
+          </a:bodyPr>
+          <a:lstStyle/>
+          <a:p>
+            <a:pPr algn="l"/>
+            <a:r>
+              <a:rPr sz="1300" b="0" i="1">
+                <a:solidFill>
+                  <a:srgbClr val="5B6670"/>
+                </a:solidFill>
+                <a:latin typeface="Calibri"/>
+              </a:rPr>
+              <a:t>Pearson correlation of customer numeric columns — Real vs each method (MAE over off-diagonal pairs).</a:t>
+            </a:r>
+          </a:p>
+        </p:txBody>
+      </p:sp>
+    </p:spTree>
+  </p:cSld>
+  <p:clrMapOvr>
+    <a:masterClrMapping/>
+  </p:clrMapOvr>
+</p:sld>
+</file>
+
+<file path=ppt/slides/slide12.xml><?xml version="1.0" encoding="utf-8"?>
 <p:sld xmlns:a="http://schemas.openxmlformats.org/drawingml/2006/main" xmlns:p="http://schemas.openxmlformats.org/presentationml/2006/main" xmlns:r="http://schemas.openxmlformats.org/officeDocument/2006/relationships">
   <p:cSld>
     <p:bg>
@@ -3676,7 +3979,7 @@
 </p:sld>
 </file>
 
-<file path=ppt/slides/slide12.xml><?xml version="1.0" encoding="utf-8"?>
+<file path=ppt/slides/slide13.xml><?xml version="1.0" encoding="utf-8"?>
 <p:sld xmlns:a="http://schemas.openxmlformats.org/drawingml/2006/main" xmlns:p="http://schemas.openxmlformats.org/presentationml/2006/main" xmlns:r="http://schemas.openxmlformats.org/officeDocument/2006/relationships">
   <p:cSld>
     <p:bg>
@@ -5254,7 +5557,7 @@
 </p:sld>
 </file>
 
-<file path=ppt/slides/slide13.xml><?xml version="1.0" encoding="utf-8"?>
+<file path=ppt/slides/slide14.xml><?xml version="1.0" encoding="utf-8"?>
 <p:sld xmlns:a="http://schemas.openxmlformats.org/drawingml/2006/main" xmlns:p="http://schemas.openxmlformats.org/presentationml/2006/main" xmlns:r="http://schemas.openxmlformats.org/officeDocument/2006/relationships">
   <p:cSld>
     <p:bg>
@@ -5783,7 +6086,7 @@
 </p:sld>
 </file>
 
-<file path=ppt/slides/slide14.xml><?xml version="1.0" encoding="utf-8"?>
+<file path=ppt/slides/slide15.xml><?xml version="1.0" encoding="utf-8"?>
 <p:sld xmlns:a="http://schemas.openxmlformats.org/drawingml/2006/main" xmlns:p="http://schemas.openxmlformats.org/presentationml/2006/main" xmlns:r="http://schemas.openxmlformats.org/officeDocument/2006/relationships">
   <p:cSld>
     <p:bg>

</xml_diff>

<commit_message>
Widen spacing in within-table correlation charts for readability
Increase inter-panel spacing in the correlation-matrix grid (bigger figure +
subplots_adjust) so the rotated column labels no longer crowd neighbouring
panels, and widen the MAE bar chart with spaced bars and method-name labels.
Regenerate both PNGs + rebuild slides.
</commit_message>
<xml_diff>
--- a/slides.pptx
+++ b/slides.pptx
@@ -3554,8 +3554,8 @@
         </p:blipFill>
         <p:spPr>
           <a:xfrm>
-            <a:off x="1110252" y="1508760"/>
-            <a:ext cx="6740615" cy="4480560"/>
+            <a:off x="845296" y="1508760"/>
+            <a:ext cx="7270527" cy="4480560"/>
           </a:xfrm>
           <a:prstGeom prst="rect">
             <a:avLst/>

</xml_diff>

<commit_message>
Add metric-explainer and correlation-scorecard slides
- Two "how they're computed" slides after Evaluation: SDMetrics fidelity
  (Cust/Txn Shapes, Cust Pairs, Diagnostic with KS/TV/Correlation/Contingency
  definitions) and custom metrics (Cross-table MAD, Within-table corr MAE,
  IA KS p-value, Autocorr MAE with formulas + ↑/↓).
- New correlation scorecard table slide: within-table corr MAE, cross-table MAD
  and customer pair trends for all five methods (winners highlighted).
Deck now 18 slides; all include M5.
</commit_message>
<xml_diff>
--- a/slides.pptx
+++ b/slides.pptx
@@ -20,6 +20,9 @@
     <p:sldId id="268" r:id="rId19"/>
     <p:sldId id="269" r:id="rId20"/>
     <p:sldId id="270" r:id="rId21"/>
+    <p:sldId id="271" r:id="rId22"/>
+    <p:sldId id="272" r:id="rId23"/>
+    <p:sldId id="273" r:id="rId24"/>
   </p:sldIdLst>
   <p:sldSz cx="12191695" cy="6858000" type="screen4x3"/>
   <p:notesSz cx="6858000" cy="9144000"/>
@@ -3346,7 +3349,7 @@
                 </a:solidFill>
                 <a:latin typeface="Calibri"/>
               </a:rPr>
-              <a:t>CROSS-TABLE CORRELATION</a:t>
+              <a:t>HOW THEY'RE COMPUTED</a:t>
             </a:r>
           </a:p>
           <a:p>
@@ -3358,35 +3361,509 @@
                 </a:solidFill>
                 <a:latin typeface="Calibri"/>
               </a:rPr>
-              <a:t>Does income still predict products?</a:t>
+              <a:t>Metrics — correlation &amp; temporal (custom)</a:t>
             </a:r>
           </a:p>
         </p:txBody>
       </p:sp>
-      <p:pic>
-        <p:nvPicPr>
-          <p:cNvPr id="4" name="Picture 3" descr="cross_table_heatmap.png"/>
-          <p:cNvPicPr>
-            <a:picLocks noChangeAspect="1"/>
-          </p:cNvPicPr>
+      <p:graphicFrame>
+        <p:nvGraphicFramePr>
+          <p:cNvPr id="4" name="Table 3"/>
+          <p:cNvGraphicFramePr>
+            <a:graphicFrameLocks noGrp="1"/>
+          </p:cNvGraphicFramePr>
           <p:nvPr/>
-        </p:nvPicPr>
-        <p:blipFill>
-          <a:blip r:embed="rId2"/>
-          <a:stretch>
-            <a:fillRect/>
-          </a:stretch>
-        </p:blipFill>
-        <p:spPr>
-          <a:xfrm>
-            <a:off x="548640" y="2950784"/>
-            <a:ext cx="11155680" cy="1505071"/>
-          </a:xfrm>
-          <a:prstGeom prst="rect">
-            <a:avLst/>
-          </a:prstGeom>
-        </p:spPr>
-      </p:pic>
+        </p:nvGraphicFramePr>
+        <p:xfrm>
+          <a:off x="640080" y="1874519"/>
+          <a:ext cx="10607040" cy="2743200"/>
+        </p:xfrm>
+        <a:graphic>
+          <a:graphicData uri="http://schemas.openxmlformats.org/drawingml/2006/table">
+            <a:tbl>
+              <a:tblPr firstRow="1" bandRow="1">
+                <a:tableStyleId>{5C22544A-7EE6-4342-B048-85BDC9FD1C3A}</a:tableStyleId>
+              </a:tblPr>
+              <a:tblGrid>
+                <a:gridCol w="2377440"/>
+                <a:gridCol w="3017520"/>
+                <a:gridCol w="4572000"/>
+                <a:gridCol w="640080"/>
+              </a:tblGrid>
+              <a:tr h="548640">
+                <a:tc>
+                  <a:txBody>
+                    <a:bodyPr/>
+                    <a:lstStyle/>
+                    <a:p>
+                      <a:pPr algn="l"/>
+                      <a:r>
+                        <a:rPr sz="1300" b="1" i="0">
+                          <a:solidFill>
+                            <a:srgbClr val="FFFFFF"/>
+                          </a:solidFill>
+                          <a:latin typeface="Calibri"/>
+                        </a:rPr>
+                        <a:t>Metric</a:t>
+                      </a:r>
+                    </a:p>
+                  </a:txBody>
+                  <a:tcPr marT="25400" marB="25400" marL="76200" marR="76200" anchor="ctr">
+                    <a:solidFill>
+                      <a:srgbClr val="4E79A7"/>
+                    </a:solidFill>
+                  </a:tcPr>
+                </a:tc>
+                <a:tc>
+                  <a:txBody>
+                    <a:bodyPr/>
+                    <a:lstStyle/>
+                    <a:p>
+                      <a:pPr algn="ctr"/>
+                      <a:r>
+                        <a:rPr sz="1300" b="1" i="0">
+                          <a:solidFill>
+                            <a:srgbClr val="FFFFFF"/>
+                          </a:solidFill>
+                          <a:latin typeface="Calibri"/>
+                        </a:rPr>
+                        <a:t>What it measures</a:t>
+                      </a:r>
+                    </a:p>
+                  </a:txBody>
+                  <a:tcPr marT="25400" marB="25400" marL="76200" marR="76200" anchor="ctr">
+                    <a:solidFill>
+                      <a:srgbClr val="4E79A7"/>
+                    </a:solidFill>
+                  </a:tcPr>
+                </a:tc>
+                <a:tc>
+                  <a:txBody>
+                    <a:bodyPr/>
+                    <a:lstStyle/>
+                    <a:p>
+                      <a:pPr algn="ctr"/>
+                      <a:r>
+                        <a:rPr sz="1300" b="1" i="0">
+                          <a:solidFill>
+                            <a:srgbClr val="FFFFFF"/>
+                          </a:solidFill>
+                          <a:latin typeface="Calibri"/>
+                        </a:rPr>
+                        <a:t>How it's computed</a:t>
+                      </a:r>
+                    </a:p>
+                  </a:txBody>
+                  <a:tcPr marT="25400" marB="25400" marL="76200" marR="76200" anchor="ctr">
+                    <a:solidFill>
+                      <a:srgbClr val="4E79A7"/>
+                    </a:solidFill>
+                  </a:tcPr>
+                </a:tc>
+                <a:tc>
+                  <a:txBody>
+                    <a:bodyPr/>
+                    <a:lstStyle/>
+                    <a:p>
+                      <a:pPr algn="ctr"/>
+                      <a:r>
+                        <a:rPr sz="1300" b="1" i="0">
+                          <a:solidFill>
+                            <a:srgbClr val="FFFFFF"/>
+                          </a:solidFill>
+                          <a:latin typeface="Calibri"/>
+                        </a:rPr>
+                        <a:t>↑/↓</a:t>
+                      </a:r>
+                    </a:p>
+                  </a:txBody>
+                  <a:tcPr marT="25400" marB="25400" marL="76200" marR="76200" anchor="ctr">
+                    <a:solidFill>
+                      <a:srgbClr val="4E79A7"/>
+                    </a:solidFill>
+                  </a:tcPr>
+                </a:tc>
+              </a:tr>
+              <a:tr h="548640">
+                <a:tc>
+                  <a:txBody>
+                    <a:bodyPr/>
+                    <a:lstStyle/>
+                    <a:p>
+                      <a:pPr algn="l"/>
+                      <a:r>
+                        <a:rPr sz="1300" b="1" i="0">
+                          <a:solidFill>
+                            <a:srgbClr val="1F2A37"/>
+                          </a:solidFill>
+                          <a:latin typeface="Calibri"/>
+                        </a:rPr>
+                        <a:t>Cross-table MAD</a:t>
+                      </a:r>
+                    </a:p>
+                  </a:txBody>
+                  <a:tcPr marT="25400" marB="25400" marL="76200" marR="76200" anchor="ctr">
+                    <a:solidFill>
+                      <a:srgbClr val="FFFFFF"/>
+                    </a:solidFill>
+                  </a:tcPr>
+                </a:tc>
+                <a:tc>
+                  <a:txBody>
+                    <a:bodyPr/>
+                    <a:lstStyle/>
+                    <a:p>
+                      <a:pPr algn="ctr"/>
+                      <a:r>
+                        <a:rPr sz="1300" b="0" i="0">
+                          <a:solidFill>
+                            <a:srgbClr val="1F2A37"/>
+                          </a:solidFill>
+                          <a:latin typeface="Calibri"/>
+                        </a:rPr>
+                        <a:t>feature → product-category signal</a:t>
+                      </a:r>
+                    </a:p>
+                  </a:txBody>
+                  <a:tcPr marT="25400" marB="25400" marL="76200" marR="76200" anchor="ctr">
+                    <a:solidFill>
+                      <a:srgbClr val="FFFFFF"/>
+                    </a:solidFill>
+                  </a:tcPr>
+                </a:tc>
+                <a:tc>
+                  <a:txBody>
+                    <a:bodyPr/>
+                    <a:lstStyle/>
+                    <a:p>
+                      <a:pPr algn="ctr"/>
+                      <a:r>
+                        <a:rPr sz="1300" b="0" i="0">
+                          <a:solidFill>
+                            <a:srgbClr val="1F2A37"/>
+                          </a:solidFill>
+                          <a:latin typeface="Calibri"/>
+                        </a:rPr>
+                        <a:t>mean |Δ Spearman(feature, %category)| real vs synth</a:t>
+                      </a:r>
+                    </a:p>
+                  </a:txBody>
+                  <a:tcPr marT="25400" marB="25400" marL="76200" marR="76200" anchor="ctr">
+                    <a:solidFill>
+                      <a:srgbClr val="FFFFFF"/>
+                    </a:solidFill>
+                  </a:tcPr>
+                </a:tc>
+                <a:tc>
+                  <a:txBody>
+                    <a:bodyPr/>
+                    <a:lstStyle/>
+                    <a:p>
+                      <a:pPr algn="ctr"/>
+                      <a:r>
+                        <a:rPr sz="1300" b="0" i="0">
+                          <a:solidFill>
+                            <a:srgbClr val="1F2A37"/>
+                          </a:solidFill>
+                          <a:latin typeface="Calibri"/>
+                        </a:rPr>
+                        <a:t>↓</a:t>
+                      </a:r>
+                    </a:p>
+                  </a:txBody>
+                  <a:tcPr marT="25400" marB="25400" marL="76200" marR="76200" anchor="ctr">
+                    <a:solidFill>
+                      <a:srgbClr val="FFFFFF"/>
+                    </a:solidFill>
+                  </a:tcPr>
+                </a:tc>
+              </a:tr>
+              <a:tr h="548640">
+                <a:tc>
+                  <a:txBody>
+                    <a:bodyPr/>
+                    <a:lstStyle/>
+                    <a:p>
+                      <a:pPr algn="l"/>
+                      <a:r>
+                        <a:rPr sz="1300" b="1" i="0">
+                          <a:solidFill>
+                            <a:srgbClr val="1F2A37"/>
+                          </a:solidFill>
+                          <a:latin typeface="Calibri"/>
+                        </a:rPr>
+                        <a:t>Within-table corr MAE</a:t>
+                      </a:r>
+                    </a:p>
+                  </a:txBody>
+                  <a:tcPr marT="25400" marB="25400" marL="76200" marR="76200" anchor="ctr">
+                    <a:solidFill>
+                      <a:srgbClr val="F3F5F7"/>
+                    </a:solidFill>
+                  </a:tcPr>
+                </a:tc>
+                <a:tc>
+                  <a:txBody>
+                    <a:bodyPr/>
+                    <a:lstStyle/>
+                    <a:p>
+                      <a:pPr algn="ctr"/>
+                      <a:r>
+                        <a:rPr sz="1300" b="0" i="0">
+                          <a:solidFill>
+                            <a:srgbClr val="1F2A37"/>
+                          </a:solidFill>
+                          <a:latin typeface="Calibri"/>
+                        </a:rPr>
+                        <a:t>customer column correlations</a:t>
+                      </a:r>
+                    </a:p>
+                  </a:txBody>
+                  <a:tcPr marT="25400" marB="25400" marL="76200" marR="76200" anchor="ctr">
+                    <a:solidFill>
+                      <a:srgbClr val="F3F5F7"/>
+                    </a:solidFill>
+                  </a:tcPr>
+                </a:tc>
+                <a:tc>
+                  <a:txBody>
+                    <a:bodyPr/>
+                    <a:lstStyle/>
+                    <a:p>
+                      <a:pPr algn="ctr"/>
+                      <a:r>
+                        <a:rPr sz="1300" b="0" i="0">
+                          <a:solidFill>
+                            <a:srgbClr val="1F2A37"/>
+                          </a:solidFill>
+                          <a:latin typeface="Calibri"/>
+                        </a:rPr>
+                        <a:t>mean |Δ Pearson| over off-diagonal pairs</a:t>
+                      </a:r>
+                    </a:p>
+                  </a:txBody>
+                  <a:tcPr marT="25400" marB="25400" marL="76200" marR="76200" anchor="ctr">
+                    <a:solidFill>
+                      <a:srgbClr val="F3F5F7"/>
+                    </a:solidFill>
+                  </a:tcPr>
+                </a:tc>
+                <a:tc>
+                  <a:txBody>
+                    <a:bodyPr/>
+                    <a:lstStyle/>
+                    <a:p>
+                      <a:pPr algn="ctr"/>
+                      <a:r>
+                        <a:rPr sz="1300" b="0" i="0">
+                          <a:solidFill>
+                            <a:srgbClr val="1F2A37"/>
+                          </a:solidFill>
+                          <a:latin typeface="Calibri"/>
+                        </a:rPr>
+                        <a:t>↓</a:t>
+                      </a:r>
+                    </a:p>
+                  </a:txBody>
+                  <a:tcPr marT="25400" marB="25400" marL="76200" marR="76200" anchor="ctr">
+                    <a:solidFill>
+                      <a:srgbClr val="F3F5F7"/>
+                    </a:solidFill>
+                  </a:tcPr>
+                </a:tc>
+              </a:tr>
+              <a:tr h="548640">
+                <a:tc>
+                  <a:txBody>
+                    <a:bodyPr/>
+                    <a:lstStyle/>
+                    <a:p>
+                      <a:pPr algn="l"/>
+                      <a:r>
+                        <a:rPr sz="1300" b="1" i="0">
+                          <a:solidFill>
+                            <a:srgbClr val="1F2A37"/>
+                          </a:solidFill>
+                          <a:latin typeface="Calibri"/>
+                        </a:rPr>
+                        <a:t>IA KS p-value</a:t>
+                      </a:r>
+                    </a:p>
+                  </a:txBody>
+                  <a:tcPr marT="25400" marB="25400" marL="76200" marR="76200" anchor="ctr">
+                    <a:solidFill>
+                      <a:srgbClr val="FFFFFF"/>
+                    </a:solidFill>
+                  </a:tcPr>
+                </a:tc>
+                <a:tc>
+                  <a:txBody>
+                    <a:bodyPr/>
+                    <a:lstStyle/>
+                    <a:p>
+                      <a:pPr algn="ctr"/>
+                      <a:r>
+                        <a:rPr sz="1300" b="0" i="0">
+                          <a:solidFill>
+                            <a:srgbClr val="1F2A37"/>
+                          </a:solidFill>
+                          <a:latin typeface="Calibri"/>
+                        </a:rPr>
+                        <a:t>transaction timing realism</a:t>
+                      </a:r>
+                    </a:p>
+                  </a:txBody>
+                  <a:tcPr marT="25400" marB="25400" marL="76200" marR="76200" anchor="ctr">
+                    <a:solidFill>
+                      <a:srgbClr val="FFFFFF"/>
+                    </a:solidFill>
+                  </a:tcPr>
+                </a:tc>
+                <a:tc>
+                  <a:txBody>
+                    <a:bodyPr/>
+                    <a:lstStyle/>
+                    <a:p>
+                      <a:pPr algn="ctr"/>
+                      <a:r>
+                        <a:rPr sz="1300" b="0" i="0">
+                          <a:solidFill>
+                            <a:srgbClr val="1F2A37"/>
+                          </a:solidFill>
+                          <a:latin typeface="Calibri"/>
+                        </a:rPr>
+                        <a:t>KS test on days-between-consecutive-txns</a:t>
+                      </a:r>
+                    </a:p>
+                  </a:txBody>
+                  <a:tcPr marT="25400" marB="25400" marL="76200" marR="76200" anchor="ctr">
+                    <a:solidFill>
+                      <a:srgbClr val="FFFFFF"/>
+                    </a:solidFill>
+                  </a:tcPr>
+                </a:tc>
+                <a:tc>
+                  <a:txBody>
+                    <a:bodyPr/>
+                    <a:lstStyle/>
+                    <a:p>
+                      <a:pPr algn="ctr"/>
+                      <a:r>
+                        <a:rPr sz="1300" b="0" i="0">
+                          <a:solidFill>
+                            <a:srgbClr val="1F2A37"/>
+                          </a:solidFill>
+                          <a:latin typeface="Calibri"/>
+                        </a:rPr>
+                        <a:t>↑</a:t>
+                      </a:r>
+                    </a:p>
+                  </a:txBody>
+                  <a:tcPr marT="25400" marB="25400" marL="76200" marR="76200" anchor="ctr">
+                    <a:solidFill>
+                      <a:srgbClr val="FFFFFF"/>
+                    </a:solidFill>
+                  </a:tcPr>
+                </a:tc>
+              </a:tr>
+              <a:tr h="548640">
+                <a:tc>
+                  <a:txBody>
+                    <a:bodyPr/>
+                    <a:lstStyle/>
+                    <a:p>
+                      <a:pPr algn="l"/>
+                      <a:r>
+                        <a:rPr sz="1300" b="1" i="0">
+                          <a:solidFill>
+                            <a:srgbClr val="1F2A37"/>
+                          </a:solidFill>
+                          <a:latin typeface="Calibri"/>
+                        </a:rPr>
+                        <a:t>Autocorr MAE</a:t>
+                      </a:r>
+                    </a:p>
+                  </a:txBody>
+                  <a:tcPr marT="25400" marB="25400" marL="76200" marR="76200" anchor="ctr">
+                    <a:solidFill>
+                      <a:srgbClr val="F3F5F7"/>
+                    </a:solidFill>
+                  </a:tcPr>
+                </a:tc>
+                <a:tc>
+                  <a:txBody>
+                    <a:bodyPr/>
+                    <a:lstStyle/>
+                    <a:p>
+                      <a:pPr algn="ctr"/>
+                      <a:r>
+                        <a:rPr sz="1300" b="0" i="0">
+                          <a:solidFill>
+                            <a:srgbClr val="1F2A37"/>
+                          </a:solidFill>
+                          <a:latin typeface="Calibri"/>
+                        </a:rPr>
+                        <a:t>sequential spend pattern</a:t>
+                      </a:r>
+                    </a:p>
+                  </a:txBody>
+                  <a:tcPr marT="25400" marB="25400" marL="76200" marR="76200" anchor="ctr">
+                    <a:solidFill>
+                      <a:srgbClr val="F3F5F7"/>
+                    </a:solidFill>
+                  </a:tcPr>
+                </a:tc>
+                <a:tc>
+                  <a:txBody>
+                    <a:bodyPr/>
+                    <a:lstStyle/>
+                    <a:p>
+                      <a:pPr algn="ctr"/>
+                      <a:r>
+                        <a:rPr sz="1300" b="0" i="0">
+                          <a:solidFill>
+                            <a:srgbClr val="1F2A37"/>
+                          </a:solidFill>
+                          <a:latin typeface="Calibri"/>
+                        </a:rPr>
+                        <a:t>|Δ mean lag-1 autocorrelation of amount|</a:t>
+                      </a:r>
+                    </a:p>
+                  </a:txBody>
+                  <a:tcPr marT="25400" marB="25400" marL="76200" marR="76200" anchor="ctr">
+                    <a:solidFill>
+                      <a:srgbClr val="F3F5F7"/>
+                    </a:solidFill>
+                  </a:tcPr>
+                </a:tc>
+                <a:tc>
+                  <a:txBody>
+                    <a:bodyPr/>
+                    <a:lstStyle/>
+                    <a:p>
+                      <a:pPr algn="ctr"/>
+                      <a:r>
+                        <a:rPr sz="1300" b="0" i="0">
+                          <a:solidFill>
+                            <a:srgbClr val="1F2A37"/>
+                          </a:solidFill>
+                          <a:latin typeface="Calibri"/>
+                        </a:rPr>
+                        <a:t>↓</a:t>
+                      </a:r>
+                    </a:p>
+                  </a:txBody>
+                  <a:tcPr marT="25400" marB="25400" marL="76200" marR="76200" anchor="ctr">
+                    <a:solidFill>
+                      <a:srgbClr val="F3F5F7"/>
+                    </a:solidFill>
+                  </a:tcPr>
+                </a:tc>
+              </a:tr>
+            </a:tbl>
+          </a:graphicData>
+        </a:graphic>
+      </p:graphicFrame>
       <p:sp>
         <p:nvSpPr>
           <p:cNvPr id="5" name="TextBox 4"/>
@@ -3395,8 +3872,8 @@
         </p:nvSpPr>
         <p:spPr>
           <a:xfrm>
-            <a:off x="777240" y="6309360"/>
-            <a:ext cx="10607040" cy="457200"/>
+            <a:off x="777240" y="4846320"/>
+            <a:ext cx="10607040" cy="1737360"/>
           </a:xfrm>
           <a:prstGeom prst="rect">
             <a:avLst/>
@@ -3404,20 +3881,40 @@
           <a:noFill/>
         </p:spPr>
         <p:txBody>
-          <a:bodyPr wrap="none">
+          <a:bodyPr wrap="square">
             <a:spAutoFit/>
           </a:bodyPr>
           <a:lstStyle/>
           <a:p>
-            <a:pPr algn="l"/>
-            <a:r>
-              <a:rPr sz="1300" b="0" i="1">
+            <a:pPr algn="l">
+              <a:spcAft>
+                <a:spcPts val="800"/>
+              </a:spcAft>
+            </a:pPr>
+            <a:r>
+              <a:rPr sz="1400" b="0" i="0">
                 <a:solidFill>
-                  <a:srgbClr val="5B6670"/>
+                  <a:srgbClr val="1F2A37"/>
                 </a:solidFill>
                 <a:latin typeface="Calibri"/>
               </a:rPr>
-              <a:t>Feature→category Spearman correlations. Weak for every method — the cross-table signal is the hardest to keep.</a:t>
+              <a:t>•  Cross-table &amp; within-table MAE: lower = closer to real. KS p-value: higher = timing indistinguishable from real.</a:t>
+            </a:r>
+          </a:p>
+          <a:p>
+            <a:pPr algn="l">
+              <a:spcAft>
+                <a:spcPts val="800"/>
+              </a:spcAft>
+            </a:pPr>
+            <a:r>
+              <a:rPr sz="1400" b="0" i="0">
+                <a:solidFill>
+                  <a:srgbClr val="1F2A37"/>
+                </a:solidFill>
+                <a:latin typeface="Calibri"/>
+              </a:rPr>
+              <a:t>•  Autocorr is a column vs its own past (over time); corr MAE is between different columns (same row).</a:t>
             </a:r>
           </a:p>
         </p:txBody>
@@ -3521,6 +4018,356 @@
                 </a:solidFill>
                 <a:latin typeface="Calibri"/>
               </a:rPr>
+              <a:t>RESULTS</a:t>
+            </a:r>
+          </a:p>
+          <a:p>
+            <a:pPr algn="l"/>
+            <a:r>
+              <a:rPr sz="3200" b="1" i="0">
+                <a:solidFill>
+                  <a:srgbClr val="1F2A37"/>
+                </a:solidFill>
+                <a:latin typeface="Calibri"/>
+              </a:rPr>
+              <a:t>All methods, all metrics</a:t>
+            </a:r>
+          </a:p>
+        </p:txBody>
+      </p:sp>
+      <p:pic>
+        <p:nvPicPr>
+          <p:cNvPr id="4" name="Picture 3" descr="comparison_dashboard.png"/>
+          <p:cNvPicPr>
+            <a:picLocks noChangeAspect="1"/>
+          </p:cNvPicPr>
+          <p:nvPr/>
+        </p:nvPicPr>
+        <p:blipFill>
+          <a:blip r:embed="rId2"/>
+          <a:stretch>
+            <a:fillRect/>
+          </a:stretch>
+        </p:blipFill>
+        <p:spPr>
+          <a:xfrm>
+            <a:off x="1603721" y="1554480"/>
+            <a:ext cx="9228396" cy="4297680"/>
+          </a:xfrm>
+          <a:prstGeom prst="rect">
+            <a:avLst/>
+          </a:prstGeom>
+        </p:spPr>
+      </p:pic>
+      <p:sp>
+        <p:nvSpPr>
+          <p:cNvPr id="5" name="TextBox 4"/>
+          <p:cNvSpPr txBox="1"/>
+          <p:nvPr/>
+        </p:nvSpPr>
+        <p:spPr>
+          <a:xfrm>
+            <a:off x="777240" y="6309360"/>
+            <a:ext cx="10607040" cy="457200"/>
+          </a:xfrm>
+          <a:prstGeom prst="rect">
+            <a:avLst/>
+          </a:prstGeom>
+          <a:noFill/>
+        </p:spPr>
+        <p:txBody>
+          <a:bodyPr wrap="none">
+            <a:spAutoFit/>
+          </a:bodyPr>
+          <a:lstStyle/>
+          <a:p>
+            <a:pPr algn="l"/>
+            <a:r>
+              <a:rPr sz="1300" b="0" i="1">
+                <a:solidFill>
+                  <a:srgbClr val="5B6670"/>
+                </a:solidFill>
+                <a:latin typeface="Calibri"/>
+              </a:rPr>
+              <a:t>Normalised so higher = better on every axis. No single method dominates — the trade-offs are the story.</a:t>
+            </a:r>
+          </a:p>
+        </p:txBody>
+      </p:sp>
+    </p:spTree>
+  </p:cSld>
+  <p:clrMapOvr>
+    <a:masterClrMapping/>
+  </p:clrMapOvr>
+</p:sld>
+</file>
+
+<file path=ppt/slides/slide12.xml><?xml version="1.0" encoding="utf-8"?>
+<p:sld xmlns:a="http://schemas.openxmlformats.org/drawingml/2006/main" xmlns:p="http://schemas.openxmlformats.org/presentationml/2006/main" xmlns:r="http://schemas.openxmlformats.org/officeDocument/2006/relationships">
+  <p:cSld>
+    <p:bg>
+      <p:bgPr>
+        <a:solidFill>
+          <a:srgbClr val="FFFFFF"/>
+        </a:solidFill>
+        <a:effectLst/>
+      </p:bgPr>
+    </p:bg>
+    <p:spTree>
+      <p:nvGrpSpPr>
+        <p:cNvPr id="1" name=""/>
+        <p:cNvGrpSpPr/>
+        <p:nvPr/>
+      </p:nvGrpSpPr>
+      <p:grpSpPr/>
+      <p:sp>
+        <p:nvSpPr>
+          <p:cNvPr id="2" name="Rectangle 1"/>
+          <p:cNvSpPr/>
+          <p:nvPr/>
+        </p:nvSpPr>
+        <p:spPr>
+          <a:xfrm>
+            <a:off x="0" y="0"/>
+            <a:ext cx="201168" cy="6858000"/>
+          </a:xfrm>
+          <a:prstGeom prst="rect">
+            <a:avLst/>
+          </a:prstGeom>
+          <a:solidFill>
+            <a:srgbClr val="4E79A7"/>
+          </a:solidFill>
+          <a:ln>
+            <a:noFill/>
+          </a:ln>
+        </p:spPr>
+        <p:style>
+          <a:lnRef idx="1">
+            <a:schemeClr val="accent1"/>
+          </a:lnRef>
+          <a:fillRef idx="3">
+            <a:schemeClr val="accent1"/>
+          </a:fillRef>
+          <a:effectRef idx="2">
+            <a:schemeClr val="accent1"/>
+          </a:effectRef>
+          <a:fontRef idx="minor">
+            <a:schemeClr val="lt1"/>
+          </a:fontRef>
+        </p:style>
+        <p:txBody>
+          <a:bodyPr rtlCol="0" anchor="ctr"/>
+          <a:lstStyle/>
+          <a:p>
+            <a:pPr algn="ctr"/>
+          </a:p>
+        </p:txBody>
+      </p:sp>
+      <p:sp>
+        <p:nvSpPr>
+          <p:cNvPr id="3" name="TextBox 2"/>
+          <p:cNvSpPr txBox="1"/>
+          <p:nvPr/>
+        </p:nvSpPr>
+        <p:spPr>
+          <a:xfrm>
+            <a:off x="548640" y="384048"/>
+            <a:ext cx="11155680" cy="1005840"/>
+          </a:xfrm>
+          <a:prstGeom prst="rect">
+            <a:avLst/>
+          </a:prstGeom>
+          <a:noFill/>
+        </p:spPr>
+        <p:txBody>
+          <a:bodyPr wrap="none">
+            <a:spAutoFit/>
+          </a:bodyPr>
+          <a:lstStyle/>
+          <a:p>
+            <a:pPr algn="l"/>
+            <a:r>
+              <a:rPr sz="1300" b="1" i="0">
+                <a:solidFill>
+                  <a:srgbClr val="4E79A7"/>
+                </a:solidFill>
+                <a:latin typeface="Calibri"/>
+              </a:rPr>
+              <a:t>CROSS-TABLE CORRELATION</a:t>
+            </a:r>
+          </a:p>
+          <a:p>
+            <a:pPr algn="l"/>
+            <a:r>
+              <a:rPr sz="3200" b="1" i="0">
+                <a:solidFill>
+                  <a:srgbClr val="1F2A37"/>
+                </a:solidFill>
+                <a:latin typeface="Calibri"/>
+              </a:rPr>
+              <a:t>Does income still predict products?</a:t>
+            </a:r>
+          </a:p>
+        </p:txBody>
+      </p:sp>
+      <p:pic>
+        <p:nvPicPr>
+          <p:cNvPr id="4" name="Picture 3" descr="cross_table_heatmap.png"/>
+          <p:cNvPicPr>
+            <a:picLocks noChangeAspect="1"/>
+          </p:cNvPicPr>
+          <p:nvPr/>
+        </p:nvPicPr>
+        <p:blipFill>
+          <a:blip r:embed="rId2"/>
+          <a:stretch>
+            <a:fillRect/>
+          </a:stretch>
+        </p:blipFill>
+        <p:spPr>
+          <a:xfrm>
+            <a:off x="548640" y="2950784"/>
+            <a:ext cx="11155680" cy="1505071"/>
+          </a:xfrm>
+          <a:prstGeom prst="rect">
+            <a:avLst/>
+          </a:prstGeom>
+        </p:spPr>
+      </p:pic>
+      <p:sp>
+        <p:nvSpPr>
+          <p:cNvPr id="5" name="TextBox 4"/>
+          <p:cNvSpPr txBox="1"/>
+          <p:nvPr/>
+        </p:nvSpPr>
+        <p:spPr>
+          <a:xfrm>
+            <a:off x="777240" y="6309360"/>
+            <a:ext cx="10607040" cy="457200"/>
+          </a:xfrm>
+          <a:prstGeom prst="rect">
+            <a:avLst/>
+          </a:prstGeom>
+          <a:noFill/>
+        </p:spPr>
+        <p:txBody>
+          <a:bodyPr wrap="none">
+            <a:spAutoFit/>
+          </a:bodyPr>
+          <a:lstStyle/>
+          <a:p>
+            <a:pPr algn="l"/>
+            <a:r>
+              <a:rPr sz="1300" b="0" i="1">
+                <a:solidFill>
+                  <a:srgbClr val="5B6670"/>
+                </a:solidFill>
+                <a:latin typeface="Calibri"/>
+              </a:rPr>
+              <a:t>Feature→category Spearman correlations. Weak for every method — the cross-table signal is the hardest to keep.</a:t>
+            </a:r>
+          </a:p>
+        </p:txBody>
+      </p:sp>
+    </p:spTree>
+  </p:cSld>
+  <p:clrMapOvr>
+    <a:masterClrMapping/>
+  </p:clrMapOvr>
+</p:sld>
+</file>
+
+<file path=ppt/slides/slide13.xml><?xml version="1.0" encoding="utf-8"?>
+<p:sld xmlns:a="http://schemas.openxmlformats.org/drawingml/2006/main" xmlns:p="http://schemas.openxmlformats.org/presentationml/2006/main" xmlns:r="http://schemas.openxmlformats.org/officeDocument/2006/relationships">
+  <p:cSld>
+    <p:bg>
+      <p:bgPr>
+        <a:solidFill>
+          <a:srgbClr val="FFFFFF"/>
+        </a:solidFill>
+        <a:effectLst/>
+      </p:bgPr>
+    </p:bg>
+    <p:spTree>
+      <p:nvGrpSpPr>
+        <p:cNvPr id="1" name=""/>
+        <p:cNvGrpSpPr/>
+        <p:nvPr/>
+      </p:nvGrpSpPr>
+      <p:grpSpPr/>
+      <p:sp>
+        <p:nvSpPr>
+          <p:cNvPr id="2" name="Rectangle 1"/>
+          <p:cNvSpPr/>
+          <p:nvPr/>
+        </p:nvSpPr>
+        <p:spPr>
+          <a:xfrm>
+            <a:off x="0" y="0"/>
+            <a:ext cx="201168" cy="6858000"/>
+          </a:xfrm>
+          <a:prstGeom prst="rect">
+            <a:avLst/>
+          </a:prstGeom>
+          <a:solidFill>
+            <a:srgbClr val="4E79A7"/>
+          </a:solidFill>
+          <a:ln>
+            <a:noFill/>
+          </a:ln>
+        </p:spPr>
+        <p:style>
+          <a:lnRef idx="1">
+            <a:schemeClr val="accent1"/>
+          </a:lnRef>
+          <a:fillRef idx="3">
+            <a:schemeClr val="accent1"/>
+          </a:fillRef>
+          <a:effectRef idx="2">
+            <a:schemeClr val="accent1"/>
+          </a:effectRef>
+          <a:fontRef idx="minor">
+            <a:schemeClr val="lt1"/>
+          </a:fontRef>
+        </p:style>
+        <p:txBody>
+          <a:bodyPr rtlCol="0" anchor="ctr"/>
+          <a:lstStyle/>
+          <a:p>
+            <a:pPr algn="ctr"/>
+          </a:p>
+        </p:txBody>
+      </p:sp>
+      <p:sp>
+        <p:nvSpPr>
+          <p:cNvPr id="3" name="TextBox 2"/>
+          <p:cNvSpPr txBox="1"/>
+          <p:nvPr/>
+        </p:nvSpPr>
+        <p:spPr>
+          <a:xfrm>
+            <a:off x="548640" y="384048"/>
+            <a:ext cx="11155680" cy="1005840"/>
+          </a:xfrm>
+          <a:prstGeom prst="rect">
+            <a:avLst/>
+          </a:prstGeom>
+          <a:noFill/>
+        </p:spPr>
+        <p:txBody>
+          <a:bodyPr wrap="none">
+            <a:spAutoFit/>
+          </a:bodyPr>
+          <a:lstStyle/>
+          <a:p>
+            <a:pPr algn="l"/>
+            <a:r>
+              <a:rPr sz="1300" b="1" i="0">
+                <a:solidFill>
+                  <a:srgbClr val="4E79A7"/>
+                </a:solidFill>
+                <a:latin typeface="Calibri"/>
+              </a:rPr>
               <a:t>IN-TABLE CORRELATION</a:t>
             </a:r>
           </a:p>
@@ -3732,7 +4579,773 @@
 </p:sld>
 </file>
 
-<file path=ppt/slides/slide12.xml><?xml version="1.0" encoding="utf-8"?>
+<file path=ppt/slides/slide14.xml><?xml version="1.0" encoding="utf-8"?>
+<p:sld xmlns:a="http://schemas.openxmlformats.org/drawingml/2006/main" xmlns:p="http://schemas.openxmlformats.org/presentationml/2006/main" xmlns:r="http://schemas.openxmlformats.org/officeDocument/2006/relationships">
+  <p:cSld>
+    <p:bg>
+      <p:bgPr>
+        <a:solidFill>
+          <a:srgbClr val="FFFFFF"/>
+        </a:solidFill>
+        <a:effectLst/>
+      </p:bgPr>
+    </p:bg>
+    <p:spTree>
+      <p:nvGrpSpPr>
+        <p:cNvPr id="1" name=""/>
+        <p:cNvGrpSpPr/>
+        <p:nvPr/>
+      </p:nvGrpSpPr>
+      <p:grpSpPr/>
+      <p:sp>
+        <p:nvSpPr>
+          <p:cNvPr id="2" name="Rectangle 1"/>
+          <p:cNvSpPr/>
+          <p:nvPr/>
+        </p:nvSpPr>
+        <p:spPr>
+          <a:xfrm>
+            <a:off x="0" y="0"/>
+            <a:ext cx="201168" cy="6858000"/>
+          </a:xfrm>
+          <a:prstGeom prst="rect">
+            <a:avLst/>
+          </a:prstGeom>
+          <a:solidFill>
+            <a:srgbClr val="4E79A7"/>
+          </a:solidFill>
+          <a:ln>
+            <a:noFill/>
+          </a:ln>
+        </p:spPr>
+        <p:style>
+          <a:lnRef idx="1">
+            <a:schemeClr val="accent1"/>
+          </a:lnRef>
+          <a:fillRef idx="3">
+            <a:schemeClr val="accent1"/>
+          </a:fillRef>
+          <a:effectRef idx="2">
+            <a:schemeClr val="accent1"/>
+          </a:effectRef>
+          <a:fontRef idx="minor">
+            <a:schemeClr val="lt1"/>
+          </a:fontRef>
+        </p:style>
+        <p:txBody>
+          <a:bodyPr rtlCol="0" anchor="ctr"/>
+          <a:lstStyle/>
+          <a:p>
+            <a:pPr algn="ctr"/>
+          </a:p>
+        </p:txBody>
+      </p:sp>
+      <p:sp>
+        <p:nvSpPr>
+          <p:cNvPr id="3" name="TextBox 2"/>
+          <p:cNvSpPr txBox="1"/>
+          <p:nvPr/>
+        </p:nvSpPr>
+        <p:spPr>
+          <a:xfrm>
+            <a:off x="548640" y="384048"/>
+            <a:ext cx="11155680" cy="1005840"/>
+          </a:xfrm>
+          <a:prstGeom prst="rect">
+            <a:avLst/>
+          </a:prstGeom>
+          <a:noFill/>
+        </p:spPr>
+        <p:txBody>
+          <a:bodyPr wrap="none">
+            <a:spAutoFit/>
+          </a:bodyPr>
+          <a:lstStyle/>
+          <a:p>
+            <a:pPr algn="l"/>
+            <a:r>
+              <a:rPr sz="1300" b="1" i="0">
+                <a:solidFill>
+                  <a:srgbClr val="4E79A7"/>
+                </a:solidFill>
+                <a:latin typeface="Calibri"/>
+              </a:rPr>
+              <a:t>CORRELATION SUMMARY</a:t>
+            </a:r>
+          </a:p>
+          <a:p>
+            <a:pPr algn="l"/>
+            <a:r>
+              <a:rPr sz="3200" b="1" i="0">
+                <a:solidFill>
+                  <a:srgbClr val="1F2A37"/>
+                </a:solidFill>
+                <a:latin typeface="Calibri"/>
+              </a:rPr>
+              <a:t>Correlation scorecard — all methods</a:t>
+            </a:r>
+          </a:p>
+        </p:txBody>
+      </p:sp>
+      <p:graphicFrame>
+        <p:nvGraphicFramePr>
+          <p:cNvPr id="4" name="Table 3"/>
+          <p:cNvGraphicFramePr>
+            <a:graphicFrameLocks noGrp="1"/>
+          </p:cNvGraphicFramePr>
+          <p:nvPr/>
+        </p:nvGraphicFramePr>
+        <p:xfrm>
+          <a:off x="1463040" y="1920240"/>
+          <a:ext cx="9235440" cy="2926080"/>
+        </p:xfrm>
+        <a:graphic>
+          <a:graphicData uri="http://schemas.openxmlformats.org/drawingml/2006/table">
+            <a:tbl>
+              <a:tblPr firstRow="1" bandRow="1">
+                <a:tableStyleId>{5C22544A-7EE6-4342-B048-85BDC9FD1C3A}</a:tableStyleId>
+              </a:tblPr>
+              <a:tblGrid>
+                <a:gridCol w="2834640"/>
+                <a:gridCol w="2286000"/>
+                <a:gridCol w="2103120"/>
+                <a:gridCol w="2011680"/>
+              </a:tblGrid>
+              <a:tr h="487680">
+                <a:tc>
+                  <a:txBody>
+                    <a:bodyPr/>
+                    <a:lstStyle/>
+                    <a:p>
+                      <a:pPr algn="l"/>
+                      <a:r>
+                        <a:rPr sz="1400" b="1" i="0">
+                          <a:solidFill>
+                            <a:srgbClr val="FFFFFF"/>
+                          </a:solidFill>
+                          <a:latin typeface="Calibri"/>
+                        </a:rPr>
+                        <a:t>Method</a:t>
+                      </a:r>
+                    </a:p>
+                  </a:txBody>
+                  <a:tcPr marT="25400" marB="25400" marL="76200" marR="76200" anchor="ctr">
+                    <a:solidFill>
+                      <a:srgbClr val="4E79A7"/>
+                    </a:solidFill>
+                  </a:tcPr>
+                </a:tc>
+                <a:tc>
+                  <a:txBody>
+                    <a:bodyPr/>
+                    <a:lstStyle/>
+                    <a:p>
+                      <a:pPr algn="ctr"/>
+                      <a:r>
+                        <a:rPr sz="1400" b="1" i="0">
+                          <a:solidFill>
+                            <a:srgbClr val="FFFFFF"/>
+                          </a:solidFill>
+                          <a:latin typeface="Calibri"/>
+                        </a:rPr>
+                        <a:t>Within-table
+corr MAE ↓</a:t>
+                      </a:r>
+                    </a:p>
+                  </a:txBody>
+                  <a:tcPr marT="25400" marB="25400" marL="76200" marR="76200" anchor="ctr">
+                    <a:solidFill>
+                      <a:srgbClr val="4E79A7"/>
+                    </a:solidFill>
+                  </a:tcPr>
+                </a:tc>
+                <a:tc>
+                  <a:txBody>
+                    <a:bodyPr/>
+                    <a:lstStyle/>
+                    <a:p>
+                      <a:pPr algn="ctr"/>
+                      <a:r>
+                        <a:rPr sz="1400" b="1" i="0">
+                          <a:solidFill>
+                            <a:srgbClr val="FFFFFF"/>
+                          </a:solidFill>
+                          <a:latin typeface="Calibri"/>
+                        </a:rPr>
+                        <a:t>Cross-table
+MAD ↓</a:t>
+                      </a:r>
+                    </a:p>
+                  </a:txBody>
+                  <a:tcPr marT="25400" marB="25400" marL="76200" marR="76200" anchor="ctr">
+                    <a:solidFill>
+                      <a:srgbClr val="4E79A7"/>
+                    </a:solidFill>
+                  </a:tcPr>
+                </a:tc>
+                <a:tc>
+                  <a:txBody>
+                    <a:bodyPr/>
+                    <a:lstStyle/>
+                    <a:p>
+                      <a:pPr algn="ctr"/>
+                      <a:r>
+                        <a:rPr sz="1400" b="1" i="0">
+                          <a:solidFill>
+                            <a:srgbClr val="FFFFFF"/>
+                          </a:solidFill>
+                          <a:latin typeface="Calibri"/>
+                        </a:rPr>
+                        <a:t>Cust. pair
+trends ↑</a:t>
+                      </a:r>
+                    </a:p>
+                  </a:txBody>
+                  <a:tcPr marT="25400" marB="25400" marL="76200" marR="76200" anchor="ctr">
+                    <a:solidFill>
+                      <a:srgbClr val="4E79A7"/>
+                    </a:solidFill>
+                  </a:tcPr>
+                </a:tc>
+              </a:tr>
+              <a:tr h="487680">
+                <a:tc>
+                  <a:txBody>
+                    <a:bodyPr/>
+                    <a:lstStyle/>
+                    <a:p>
+                      <a:pPr algn="l"/>
+                      <a:r>
+                        <a:rPr sz="1400" b="1" i="0">
+                          <a:solidFill>
+                            <a:srgbClr val="4E79A7"/>
+                          </a:solidFill>
+                          <a:latin typeface="Calibri"/>
+                        </a:rPr>
+                        <a:t>M1 HMA GC</a:t>
+                      </a:r>
+                    </a:p>
+                  </a:txBody>
+                  <a:tcPr marT="25400" marB="25400" marL="76200" marR="76200" anchor="ctr">
+                    <a:solidFill>
+                      <a:srgbClr val="FFFFFF"/>
+                    </a:solidFill>
+                  </a:tcPr>
+                </a:tc>
+                <a:tc>
+                  <a:txBody>
+                    <a:bodyPr/>
+                    <a:lstStyle/>
+                    <a:p>
+                      <a:pPr algn="ctr"/>
+                      <a:r>
+                        <a:rPr sz="1400" b="1" i="0">
+                          <a:solidFill>
+                            <a:srgbClr val="2E7D32"/>
+                          </a:solidFill>
+                          <a:latin typeface="Calibri"/>
+                        </a:rPr>
+                        <a:t>0.040</a:t>
+                      </a:r>
+                    </a:p>
+                  </a:txBody>
+                  <a:tcPr marT="25400" marB="25400" marL="76200" marR="76200" anchor="ctr">
+                    <a:solidFill>
+                      <a:srgbClr val="FFFFFF"/>
+                    </a:solidFill>
+                  </a:tcPr>
+                </a:tc>
+                <a:tc>
+                  <a:txBody>
+                    <a:bodyPr/>
+                    <a:lstStyle/>
+                    <a:p>
+                      <a:pPr algn="ctr"/>
+                      <a:r>
+                        <a:rPr sz="1400" b="0" i="0">
+                          <a:solidFill>
+                            <a:srgbClr val="1F2A37"/>
+                          </a:solidFill>
+                          <a:latin typeface="Calibri"/>
+                        </a:rPr>
+                        <a:t>0.242</a:t>
+                      </a:r>
+                    </a:p>
+                  </a:txBody>
+                  <a:tcPr marT="25400" marB="25400" marL="76200" marR="76200" anchor="ctr">
+                    <a:solidFill>
+                      <a:srgbClr val="FFFFFF"/>
+                    </a:solidFill>
+                  </a:tcPr>
+                </a:tc>
+                <a:tc>
+                  <a:txBody>
+                    <a:bodyPr/>
+                    <a:lstStyle/>
+                    <a:p>
+                      <a:pPr algn="ctr"/>
+                      <a:r>
+                        <a:rPr sz="1400" b="1" i="0">
+                          <a:solidFill>
+                            <a:srgbClr val="2E7D32"/>
+                          </a:solidFill>
+                          <a:latin typeface="Calibri"/>
+                        </a:rPr>
+                        <a:t>0.720</a:t>
+                      </a:r>
+                    </a:p>
+                  </a:txBody>
+                  <a:tcPr marT="25400" marB="25400" marL="76200" marR="76200" anchor="ctr">
+                    <a:solidFill>
+                      <a:srgbClr val="FFFFFF"/>
+                    </a:solidFill>
+                  </a:tcPr>
+                </a:tc>
+              </a:tr>
+              <a:tr h="487680">
+                <a:tc>
+                  <a:txBody>
+                    <a:bodyPr/>
+                    <a:lstStyle/>
+                    <a:p>
+                      <a:pPr algn="l"/>
+                      <a:r>
+                        <a:rPr sz="1400" b="1" i="0">
+                          <a:solidFill>
+                            <a:srgbClr val="F28E2B"/>
+                          </a:solidFill>
+                          <a:latin typeface="Calibri"/>
+                        </a:rPr>
+                        <a:t>M2 CTGAN</a:t>
+                      </a:r>
+                    </a:p>
+                  </a:txBody>
+                  <a:tcPr marT="25400" marB="25400" marL="76200" marR="76200" anchor="ctr">
+                    <a:solidFill>
+                      <a:srgbClr val="F3F5F7"/>
+                    </a:solidFill>
+                  </a:tcPr>
+                </a:tc>
+                <a:tc>
+                  <a:txBody>
+                    <a:bodyPr/>
+                    <a:lstStyle/>
+                    <a:p>
+                      <a:pPr algn="ctr"/>
+                      <a:r>
+                        <a:rPr sz="1400" b="0" i="0">
+                          <a:solidFill>
+                            <a:srgbClr val="1F2A37"/>
+                          </a:solidFill>
+                          <a:latin typeface="Calibri"/>
+                        </a:rPr>
+                        <a:t>0.138</a:t>
+                      </a:r>
+                    </a:p>
+                  </a:txBody>
+                  <a:tcPr marT="25400" marB="25400" marL="76200" marR="76200" anchor="ctr">
+                    <a:solidFill>
+                      <a:srgbClr val="F3F5F7"/>
+                    </a:solidFill>
+                  </a:tcPr>
+                </a:tc>
+                <a:tc>
+                  <a:txBody>
+                    <a:bodyPr/>
+                    <a:lstStyle/>
+                    <a:p>
+                      <a:pPr algn="ctr"/>
+                      <a:r>
+                        <a:rPr sz="1400" b="0" i="0">
+                          <a:solidFill>
+                            <a:srgbClr val="1F2A37"/>
+                          </a:solidFill>
+                          <a:latin typeface="Calibri"/>
+                        </a:rPr>
+                        <a:t>0.281</a:t>
+                      </a:r>
+                    </a:p>
+                  </a:txBody>
+                  <a:tcPr marT="25400" marB="25400" marL="76200" marR="76200" anchor="ctr">
+                    <a:solidFill>
+                      <a:srgbClr val="F3F5F7"/>
+                    </a:solidFill>
+                  </a:tcPr>
+                </a:tc>
+                <a:tc>
+                  <a:txBody>
+                    <a:bodyPr/>
+                    <a:lstStyle/>
+                    <a:p>
+                      <a:pPr algn="ctr"/>
+                      <a:r>
+                        <a:rPr sz="1400" b="0" i="0">
+                          <a:solidFill>
+                            <a:srgbClr val="1F2A37"/>
+                          </a:solidFill>
+                          <a:latin typeface="Calibri"/>
+                        </a:rPr>
+                        <a:t>0.544</a:t>
+                      </a:r>
+                    </a:p>
+                  </a:txBody>
+                  <a:tcPr marT="25400" marB="25400" marL="76200" marR="76200" anchor="ctr">
+                    <a:solidFill>
+                      <a:srgbClr val="F3F5F7"/>
+                    </a:solidFill>
+                  </a:tcPr>
+                </a:tc>
+              </a:tr>
+              <a:tr h="487680">
+                <a:tc>
+                  <a:txBody>
+                    <a:bodyPr/>
+                    <a:lstStyle/>
+                    <a:p>
+                      <a:pPr algn="l"/>
+                      <a:r>
+                        <a:rPr sz="1400" b="1" i="0">
+                          <a:solidFill>
+                            <a:srgbClr val="59A14F"/>
+                          </a:solidFill>
+                          <a:latin typeface="Calibri"/>
+                        </a:rPr>
+                        <a:t>M3 CTGAN+PAR</a:t>
+                      </a:r>
+                    </a:p>
+                  </a:txBody>
+                  <a:tcPr marT="25400" marB="25400" marL="76200" marR="76200" anchor="ctr">
+                    <a:solidFill>
+                      <a:srgbClr val="FFFFFF"/>
+                    </a:solidFill>
+                  </a:tcPr>
+                </a:tc>
+                <a:tc>
+                  <a:txBody>
+                    <a:bodyPr/>
+                    <a:lstStyle/>
+                    <a:p>
+                      <a:pPr algn="ctr"/>
+                      <a:r>
+                        <a:rPr sz="1400" b="0" i="0">
+                          <a:solidFill>
+                            <a:srgbClr val="1F2A37"/>
+                          </a:solidFill>
+                          <a:latin typeface="Calibri"/>
+                        </a:rPr>
+                        <a:t>0.124</a:t>
+                      </a:r>
+                    </a:p>
+                  </a:txBody>
+                  <a:tcPr marT="25400" marB="25400" marL="76200" marR="76200" anchor="ctr">
+                    <a:solidFill>
+                      <a:srgbClr val="FFFFFF"/>
+                    </a:solidFill>
+                  </a:tcPr>
+                </a:tc>
+                <a:tc>
+                  <a:txBody>
+                    <a:bodyPr/>
+                    <a:lstStyle/>
+                    <a:p>
+                      <a:pPr algn="ctr"/>
+                      <a:r>
+                        <a:rPr sz="1400" b="1" i="0">
+                          <a:solidFill>
+                            <a:srgbClr val="2E7D32"/>
+                          </a:solidFill>
+                          <a:latin typeface="Calibri"/>
+                        </a:rPr>
+                        <a:t>0.195</a:t>
+                      </a:r>
+                    </a:p>
+                  </a:txBody>
+                  <a:tcPr marT="25400" marB="25400" marL="76200" marR="76200" anchor="ctr">
+                    <a:solidFill>
+                      <a:srgbClr val="FFFFFF"/>
+                    </a:solidFill>
+                  </a:tcPr>
+                </a:tc>
+                <a:tc>
+                  <a:txBody>
+                    <a:bodyPr/>
+                    <a:lstStyle/>
+                    <a:p>
+                      <a:pPr algn="ctr"/>
+                      <a:r>
+                        <a:rPr sz="1400" b="0" i="0">
+                          <a:solidFill>
+                            <a:srgbClr val="1F2A37"/>
+                          </a:solidFill>
+                          <a:latin typeface="Calibri"/>
+                        </a:rPr>
+                        <a:t>0.540</a:t>
+                      </a:r>
+                    </a:p>
+                  </a:txBody>
+                  <a:tcPr marT="25400" marB="25400" marL="76200" marR="76200" anchor="ctr">
+                    <a:solidFill>
+                      <a:srgbClr val="FFFFFF"/>
+                    </a:solidFill>
+                  </a:tcPr>
+                </a:tc>
+              </a:tr>
+              <a:tr h="487680">
+                <a:tc>
+                  <a:txBody>
+                    <a:bodyPr/>
+                    <a:lstStyle/>
+                    <a:p>
+                      <a:pPr algn="l"/>
+                      <a:r>
+                        <a:rPr sz="1400" b="1" i="0">
+                          <a:solidFill>
+                            <a:srgbClr val="E15759"/>
+                          </a:solidFill>
+                          <a:latin typeface="Calibri"/>
+                        </a:rPr>
+                        <a:t>M4 TVAE</a:t>
+                      </a:r>
+                    </a:p>
+                  </a:txBody>
+                  <a:tcPr marT="25400" marB="25400" marL="76200" marR="76200" anchor="ctr">
+                    <a:solidFill>
+                      <a:srgbClr val="F3F5F7"/>
+                    </a:solidFill>
+                  </a:tcPr>
+                </a:tc>
+                <a:tc>
+                  <a:txBody>
+                    <a:bodyPr/>
+                    <a:lstStyle/>
+                    <a:p>
+                      <a:pPr algn="ctr"/>
+                      <a:r>
+                        <a:rPr sz="1400" b="0" i="0">
+                          <a:solidFill>
+                            <a:srgbClr val="1F2A37"/>
+                          </a:solidFill>
+                          <a:latin typeface="Calibri"/>
+                        </a:rPr>
+                        <a:t>0.110</a:t>
+                      </a:r>
+                    </a:p>
+                  </a:txBody>
+                  <a:tcPr marT="25400" marB="25400" marL="76200" marR="76200" anchor="ctr">
+                    <a:solidFill>
+                      <a:srgbClr val="F3F5F7"/>
+                    </a:solidFill>
+                  </a:tcPr>
+                </a:tc>
+                <a:tc>
+                  <a:txBody>
+                    <a:bodyPr/>
+                    <a:lstStyle/>
+                    <a:p>
+                      <a:pPr algn="ctr"/>
+                      <a:r>
+                        <a:rPr sz="1400" b="0" i="0">
+                          <a:solidFill>
+                            <a:srgbClr val="1F2A37"/>
+                          </a:solidFill>
+                          <a:latin typeface="Calibri"/>
+                        </a:rPr>
+                        <a:t>0.288</a:t>
+                      </a:r>
+                    </a:p>
+                  </a:txBody>
+                  <a:tcPr marT="25400" marB="25400" marL="76200" marR="76200" anchor="ctr">
+                    <a:solidFill>
+                      <a:srgbClr val="F3F5F7"/>
+                    </a:solidFill>
+                  </a:tcPr>
+                </a:tc>
+                <a:tc>
+                  <a:txBody>
+                    <a:bodyPr/>
+                    <a:lstStyle/>
+                    <a:p>
+                      <a:pPr algn="ctr"/>
+                      <a:r>
+                        <a:rPr sz="1400" b="0" i="0">
+                          <a:solidFill>
+                            <a:srgbClr val="1F2A37"/>
+                          </a:solidFill>
+                          <a:latin typeface="Calibri"/>
+                        </a:rPr>
+                        <a:t>0.683</a:t>
+                      </a:r>
+                    </a:p>
+                  </a:txBody>
+                  <a:tcPr marT="25400" marB="25400" marL="76200" marR="76200" anchor="ctr">
+                    <a:solidFill>
+                      <a:srgbClr val="F3F5F7"/>
+                    </a:solidFill>
+                  </a:tcPr>
+                </a:tc>
+              </a:tr>
+              <a:tr h="487680">
+                <a:tc>
+                  <a:txBody>
+                    <a:bodyPr/>
+                    <a:lstStyle/>
+                    <a:p>
+                      <a:pPr algn="l"/>
+                      <a:r>
+                        <a:rPr sz="1400" b="1" i="0">
+                          <a:solidFill>
+                            <a:srgbClr val="B07AA1"/>
+                          </a:solidFill>
+                          <a:latin typeface="Calibri"/>
+                        </a:rPr>
+                        <a:t>M5 SmartNoise</a:t>
+                      </a:r>
+                    </a:p>
+                  </a:txBody>
+                  <a:tcPr marT="25400" marB="25400" marL="76200" marR="76200" anchor="ctr">
+                    <a:solidFill>
+                      <a:srgbClr val="FFFFFF"/>
+                    </a:solidFill>
+                  </a:tcPr>
+                </a:tc>
+                <a:tc>
+                  <a:txBody>
+                    <a:bodyPr/>
+                    <a:lstStyle/>
+                    <a:p>
+                      <a:pPr algn="ctr"/>
+                      <a:r>
+                        <a:rPr sz="1400" b="0" i="0">
+                          <a:solidFill>
+                            <a:srgbClr val="1F2A37"/>
+                          </a:solidFill>
+                          <a:latin typeface="Calibri"/>
+                        </a:rPr>
+                        <a:t>0.212</a:t>
+                      </a:r>
+                    </a:p>
+                  </a:txBody>
+                  <a:tcPr marT="25400" marB="25400" marL="76200" marR="76200" anchor="ctr">
+                    <a:solidFill>
+                      <a:srgbClr val="FFFFFF"/>
+                    </a:solidFill>
+                  </a:tcPr>
+                </a:tc>
+                <a:tc>
+                  <a:txBody>
+                    <a:bodyPr/>
+                    <a:lstStyle/>
+                    <a:p>
+                      <a:pPr algn="ctr"/>
+                      <a:r>
+                        <a:rPr sz="1400" b="0" i="0">
+                          <a:solidFill>
+                            <a:srgbClr val="1F2A37"/>
+                          </a:solidFill>
+                          <a:latin typeface="Calibri"/>
+                        </a:rPr>
+                        <a:t>0.297</a:t>
+                      </a:r>
+                    </a:p>
+                  </a:txBody>
+                  <a:tcPr marT="25400" marB="25400" marL="76200" marR="76200" anchor="ctr">
+                    <a:solidFill>
+                      <a:srgbClr val="FFFFFF"/>
+                    </a:solidFill>
+                  </a:tcPr>
+                </a:tc>
+                <a:tc>
+                  <a:txBody>
+                    <a:bodyPr/>
+                    <a:lstStyle/>
+                    <a:p>
+                      <a:pPr algn="ctr"/>
+                      <a:r>
+                        <a:rPr sz="1400" b="0" i="0">
+                          <a:solidFill>
+                            <a:srgbClr val="1F2A37"/>
+                          </a:solidFill>
+                          <a:latin typeface="Calibri"/>
+                        </a:rPr>
+                        <a:t>0.680</a:t>
+                      </a:r>
+                    </a:p>
+                  </a:txBody>
+                  <a:tcPr marT="25400" marB="25400" marL="76200" marR="76200" anchor="ctr">
+                    <a:solidFill>
+                      <a:srgbClr val="FFFFFF"/>
+                    </a:solidFill>
+                  </a:tcPr>
+                </a:tc>
+              </a:tr>
+            </a:tbl>
+          </a:graphicData>
+        </a:graphic>
+      </p:graphicFrame>
+      <p:sp>
+        <p:nvSpPr>
+          <p:cNvPr id="5" name="TextBox 4"/>
+          <p:cNvSpPr txBox="1"/>
+          <p:nvPr/>
+        </p:nvSpPr>
+        <p:spPr>
+          <a:xfrm>
+            <a:off x="777240" y="5120640"/>
+            <a:ext cx="10607040" cy="1463040"/>
+          </a:xfrm>
+          <a:prstGeom prst="rect">
+            <a:avLst/>
+          </a:prstGeom>
+          <a:noFill/>
+        </p:spPr>
+        <p:txBody>
+          <a:bodyPr wrap="square">
+            <a:spAutoFit/>
+          </a:bodyPr>
+          <a:lstStyle/>
+          <a:p>
+            <a:pPr algn="l">
+              <a:spcAft>
+                <a:spcPts val="800"/>
+              </a:spcAft>
+            </a:pPr>
+            <a:r>
+              <a:rPr sz="1400" b="0" i="0">
+                <a:solidFill>
+                  <a:srgbClr val="1F2A37"/>
+                </a:solidFill>
+                <a:latin typeface="Calibri"/>
+              </a:rPr>
+              <a:t>•  M1 owns within-table correlation (0.040) and customer pair trends (0.720) — the relationship signals.</a:t>
+            </a:r>
+          </a:p>
+          <a:p>
+            <a:pPr algn="l">
+              <a:spcAft>
+                <a:spcPts val="800"/>
+              </a:spcAft>
+            </a:pPr>
+            <a:r>
+              <a:rPr sz="1400" b="0" i="0">
+                <a:solidFill>
+                  <a:srgbClr val="1F2A37"/>
+                </a:solidFill>
+                <a:latin typeface="Calibri"/>
+              </a:rPr>
+              <a:t>•  Cross-table (income→product) is weak for all; M3 least bad. M5 trades correlation for marginals + privacy.</a:t>
+            </a:r>
+          </a:p>
+        </p:txBody>
+      </p:sp>
+    </p:spTree>
+  </p:cSld>
+  <p:clrMapOvr>
+    <a:masterClrMapping/>
+  </p:clrMapOvr>
+</p:sld>
+</file>
+
+<file path=ppt/slides/slide15.xml><?xml version="1.0" encoding="utf-8"?>
 <p:sld xmlns:a="http://schemas.openxmlformats.org/drawingml/2006/main" xmlns:p="http://schemas.openxmlformats.org/presentationml/2006/main" xmlns:r="http://schemas.openxmlformats.org/officeDocument/2006/relationships">
   <p:cSld>
     <p:bg>
@@ -3979,7 +5592,7 @@
 </p:sld>
 </file>
 
-<file path=ppt/slides/slide13.xml><?xml version="1.0" encoding="utf-8"?>
+<file path=ppt/slides/slide16.xml><?xml version="1.0" encoding="utf-8"?>
 <p:sld xmlns:a="http://schemas.openxmlformats.org/drawingml/2006/main" xmlns:p="http://schemas.openxmlformats.org/presentationml/2006/main" xmlns:r="http://schemas.openxmlformats.org/officeDocument/2006/relationships">
   <p:cSld>
     <p:bg>
@@ -5557,7 +7170,7 @@
 </p:sld>
 </file>
 
-<file path=ppt/slides/slide14.xml><?xml version="1.0" encoding="utf-8"?>
+<file path=ppt/slides/slide17.xml><?xml version="1.0" encoding="utf-8"?>
 <p:sld xmlns:a="http://schemas.openxmlformats.org/drawingml/2006/main" xmlns:p="http://schemas.openxmlformats.org/presentationml/2006/main" xmlns:r="http://schemas.openxmlformats.org/officeDocument/2006/relationships">
   <p:cSld>
     <p:bg>
@@ -6086,7 +7699,7 @@
 </p:sld>
 </file>
 
-<file path=ppt/slides/slide15.xml><?xml version="1.0" encoding="utf-8"?>
+<file path=ppt/slides/slide18.xml><?xml version="1.0" encoding="utf-8"?>
 <p:sld xmlns:a="http://schemas.openxmlformats.org/drawingml/2006/main" xmlns:p="http://schemas.openxmlformats.org/presentationml/2006/main" xmlns:r="http://schemas.openxmlformats.org/officeDocument/2006/relationships">
   <p:cSld>
     <p:bg>
@@ -10096,7 +11709,7 @@
                 </a:solidFill>
                 <a:latin typeface="Calibri"/>
               </a:rPr>
-              <a:t>RESULTS</a:t>
+              <a:t>HOW THEY'RE COMPUTED</a:t>
             </a:r>
           </a:p>
           <a:p>
@@ -10108,35 +11721,509 @@
                 </a:solidFill>
                 <a:latin typeface="Calibri"/>
               </a:rPr>
-              <a:t>All methods, all metrics</a:t>
+              <a:t>Metrics — fidelity (SDMetrics)</a:t>
             </a:r>
           </a:p>
         </p:txBody>
       </p:sp>
-      <p:pic>
-        <p:nvPicPr>
-          <p:cNvPr id="4" name="Picture 3" descr="comparison_dashboard.png"/>
-          <p:cNvPicPr>
-            <a:picLocks noChangeAspect="1"/>
-          </p:cNvPicPr>
+      <p:graphicFrame>
+        <p:nvGraphicFramePr>
+          <p:cNvPr id="4" name="Table 3"/>
+          <p:cNvGraphicFramePr>
+            <a:graphicFrameLocks noGrp="1"/>
+          </p:cNvGraphicFramePr>
           <p:nvPr/>
-        </p:nvPicPr>
-        <p:blipFill>
-          <a:blip r:embed="rId2"/>
-          <a:stretch>
-            <a:fillRect/>
-          </a:stretch>
-        </p:blipFill>
-        <p:spPr>
-          <a:xfrm>
-            <a:off x="1603721" y="1554480"/>
-            <a:ext cx="9228396" cy="4297680"/>
-          </a:xfrm>
-          <a:prstGeom prst="rect">
-            <a:avLst/>
-          </a:prstGeom>
-        </p:spPr>
-      </p:pic>
+        </p:nvGraphicFramePr>
+        <p:xfrm>
+          <a:off x="640080" y="1874519"/>
+          <a:ext cx="10149840" cy="2743200"/>
+        </p:xfrm>
+        <a:graphic>
+          <a:graphicData uri="http://schemas.openxmlformats.org/drawingml/2006/table">
+            <a:tbl>
+              <a:tblPr firstRow="1" bandRow="1">
+                <a:tableStyleId>{5C22544A-7EE6-4342-B048-85BDC9FD1C3A}</a:tableStyleId>
+              </a:tblPr>
+              <a:tblGrid>
+                <a:gridCol w="1737360"/>
+                <a:gridCol w="3200400"/>
+                <a:gridCol w="4572000"/>
+                <a:gridCol w="640080"/>
+              </a:tblGrid>
+              <a:tr h="548640">
+                <a:tc>
+                  <a:txBody>
+                    <a:bodyPr/>
+                    <a:lstStyle/>
+                    <a:p>
+                      <a:pPr algn="l"/>
+                      <a:r>
+                        <a:rPr sz="1300" b="1" i="0">
+                          <a:solidFill>
+                            <a:srgbClr val="FFFFFF"/>
+                          </a:solidFill>
+                          <a:latin typeface="Calibri"/>
+                        </a:rPr>
+                        <a:t>Metric</a:t>
+                      </a:r>
+                    </a:p>
+                  </a:txBody>
+                  <a:tcPr marT="25400" marB="25400" marL="76200" marR="76200" anchor="ctr">
+                    <a:solidFill>
+                      <a:srgbClr val="4E79A7"/>
+                    </a:solidFill>
+                  </a:tcPr>
+                </a:tc>
+                <a:tc>
+                  <a:txBody>
+                    <a:bodyPr/>
+                    <a:lstStyle/>
+                    <a:p>
+                      <a:pPr algn="ctr"/>
+                      <a:r>
+                        <a:rPr sz="1300" b="1" i="0">
+                          <a:solidFill>
+                            <a:srgbClr val="FFFFFF"/>
+                          </a:solidFill>
+                          <a:latin typeface="Calibri"/>
+                        </a:rPr>
+                        <a:t>What it measures</a:t>
+                      </a:r>
+                    </a:p>
+                  </a:txBody>
+                  <a:tcPr marT="25400" marB="25400" marL="76200" marR="76200" anchor="ctr">
+                    <a:solidFill>
+                      <a:srgbClr val="4E79A7"/>
+                    </a:solidFill>
+                  </a:tcPr>
+                </a:tc>
+                <a:tc>
+                  <a:txBody>
+                    <a:bodyPr/>
+                    <a:lstStyle/>
+                    <a:p>
+                      <a:pPr algn="ctr"/>
+                      <a:r>
+                        <a:rPr sz="1300" b="1" i="0">
+                          <a:solidFill>
+                            <a:srgbClr val="FFFFFF"/>
+                          </a:solidFill>
+                          <a:latin typeface="Calibri"/>
+                        </a:rPr>
+                        <a:t>How it's computed</a:t>
+                      </a:r>
+                    </a:p>
+                  </a:txBody>
+                  <a:tcPr marT="25400" marB="25400" marL="76200" marR="76200" anchor="ctr">
+                    <a:solidFill>
+                      <a:srgbClr val="4E79A7"/>
+                    </a:solidFill>
+                  </a:tcPr>
+                </a:tc>
+                <a:tc>
+                  <a:txBody>
+                    <a:bodyPr/>
+                    <a:lstStyle/>
+                    <a:p>
+                      <a:pPr algn="ctr"/>
+                      <a:r>
+                        <a:rPr sz="1300" b="1" i="0">
+                          <a:solidFill>
+                            <a:srgbClr val="FFFFFF"/>
+                          </a:solidFill>
+                          <a:latin typeface="Calibri"/>
+                        </a:rPr>
+                        <a:t>↑/↓</a:t>
+                      </a:r>
+                    </a:p>
+                  </a:txBody>
+                  <a:tcPr marT="25400" marB="25400" marL="76200" marR="76200" anchor="ctr">
+                    <a:solidFill>
+                      <a:srgbClr val="4E79A7"/>
+                    </a:solidFill>
+                  </a:tcPr>
+                </a:tc>
+              </a:tr>
+              <a:tr h="548640">
+                <a:tc>
+                  <a:txBody>
+                    <a:bodyPr/>
+                    <a:lstStyle/>
+                    <a:p>
+                      <a:pPr algn="l"/>
+                      <a:r>
+                        <a:rPr sz="1300" b="1" i="0">
+                          <a:solidFill>
+                            <a:srgbClr val="1F2A37"/>
+                          </a:solidFill>
+                          <a:latin typeface="Calibri"/>
+                        </a:rPr>
+                        <a:t>Cust. Shapes</a:t>
+                      </a:r>
+                    </a:p>
+                  </a:txBody>
+                  <a:tcPr marT="25400" marB="25400" marL="76200" marR="76200" anchor="ctr">
+                    <a:solidFill>
+                      <a:srgbClr val="FFFFFF"/>
+                    </a:solidFill>
+                  </a:tcPr>
+                </a:tc>
+                <a:tc>
+                  <a:txBody>
+                    <a:bodyPr/>
+                    <a:lstStyle/>
+                    <a:p>
+                      <a:pPr algn="ctr"/>
+                      <a:r>
+                        <a:rPr sz="1300" b="0" i="0">
+                          <a:solidFill>
+                            <a:srgbClr val="1F2A37"/>
+                          </a:solidFill>
+                          <a:latin typeface="Calibri"/>
+                        </a:rPr>
+                        <a:t>Per-column marginals (customers)</a:t>
+                      </a:r>
+                    </a:p>
+                  </a:txBody>
+                  <a:tcPr marT="25400" marB="25400" marL="76200" marR="76200" anchor="ctr">
+                    <a:solidFill>
+                      <a:srgbClr val="FFFFFF"/>
+                    </a:solidFill>
+                  </a:tcPr>
+                </a:tc>
+                <a:tc>
+                  <a:txBody>
+                    <a:bodyPr/>
+                    <a:lstStyle/>
+                    <a:p>
+                      <a:pPr algn="ctr"/>
+                      <a:r>
+                        <a:rPr sz="1300" b="0" i="0">
+                          <a:solidFill>
+                            <a:srgbClr val="1F2A37"/>
+                          </a:solidFill>
+                          <a:latin typeface="Calibri"/>
+                        </a:rPr>
+                        <a:t>avg KSComplement (num) / TVComplement (cat)</a:t>
+                      </a:r>
+                    </a:p>
+                  </a:txBody>
+                  <a:tcPr marT="25400" marB="25400" marL="76200" marR="76200" anchor="ctr">
+                    <a:solidFill>
+                      <a:srgbClr val="FFFFFF"/>
+                    </a:solidFill>
+                  </a:tcPr>
+                </a:tc>
+                <a:tc>
+                  <a:txBody>
+                    <a:bodyPr/>
+                    <a:lstStyle/>
+                    <a:p>
+                      <a:pPr algn="ctr"/>
+                      <a:r>
+                        <a:rPr sz="1300" b="0" i="0">
+                          <a:solidFill>
+                            <a:srgbClr val="1F2A37"/>
+                          </a:solidFill>
+                          <a:latin typeface="Calibri"/>
+                        </a:rPr>
+                        <a:t>↑</a:t>
+                      </a:r>
+                    </a:p>
+                  </a:txBody>
+                  <a:tcPr marT="25400" marB="25400" marL="76200" marR="76200" anchor="ctr">
+                    <a:solidFill>
+                      <a:srgbClr val="FFFFFF"/>
+                    </a:solidFill>
+                  </a:tcPr>
+                </a:tc>
+              </a:tr>
+              <a:tr h="548640">
+                <a:tc>
+                  <a:txBody>
+                    <a:bodyPr/>
+                    <a:lstStyle/>
+                    <a:p>
+                      <a:pPr algn="l"/>
+                      <a:r>
+                        <a:rPr sz="1300" b="1" i="0">
+                          <a:solidFill>
+                            <a:srgbClr val="1F2A37"/>
+                          </a:solidFill>
+                          <a:latin typeface="Calibri"/>
+                        </a:rPr>
+                        <a:t>Txn. Shapes</a:t>
+                      </a:r>
+                    </a:p>
+                  </a:txBody>
+                  <a:tcPr marT="25400" marB="25400" marL="76200" marR="76200" anchor="ctr">
+                    <a:solidFill>
+                      <a:srgbClr val="F3F5F7"/>
+                    </a:solidFill>
+                  </a:tcPr>
+                </a:tc>
+                <a:tc>
+                  <a:txBody>
+                    <a:bodyPr/>
+                    <a:lstStyle/>
+                    <a:p>
+                      <a:pPr algn="ctr"/>
+                      <a:r>
+                        <a:rPr sz="1300" b="0" i="0">
+                          <a:solidFill>
+                            <a:srgbClr val="1F2A37"/>
+                          </a:solidFill>
+                          <a:latin typeface="Calibri"/>
+                        </a:rPr>
+                        <a:t>Per-column marginals (transactions)</a:t>
+                      </a:r>
+                    </a:p>
+                  </a:txBody>
+                  <a:tcPr marT="25400" marB="25400" marL="76200" marR="76200" anchor="ctr">
+                    <a:solidFill>
+                      <a:srgbClr val="F3F5F7"/>
+                    </a:solidFill>
+                  </a:tcPr>
+                </a:tc>
+                <a:tc>
+                  <a:txBody>
+                    <a:bodyPr/>
+                    <a:lstStyle/>
+                    <a:p>
+                      <a:pPr algn="ctr"/>
+                      <a:r>
+                        <a:rPr sz="1300" b="0" i="0">
+                          <a:solidFill>
+                            <a:srgbClr val="1F2A37"/>
+                          </a:solidFill>
+                          <a:latin typeface="Calibri"/>
+                        </a:rPr>
+                        <a:t>same complements on transaction columns</a:t>
+                      </a:r>
+                    </a:p>
+                  </a:txBody>
+                  <a:tcPr marT="25400" marB="25400" marL="76200" marR="76200" anchor="ctr">
+                    <a:solidFill>
+                      <a:srgbClr val="F3F5F7"/>
+                    </a:solidFill>
+                  </a:tcPr>
+                </a:tc>
+                <a:tc>
+                  <a:txBody>
+                    <a:bodyPr/>
+                    <a:lstStyle/>
+                    <a:p>
+                      <a:pPr algn="ctr"/>
+                      <a:r>
+                        <a:rPr sz="1300" b="0" i="0">
+                          <a:solidFill>
+                            <a:srgbClr val="1F2A37"/>
+                          </a:solidFill>
+                          <a:latin typeface="Calibri"/>
+                        </a:rPr>
+                        <a:t>↑</a:t>
+                      </a:r>
+                    </a:p>
+                  </a:txBody>
+                  <a:tcPr marT="25400" marB="25400" marL="76200" marR="76200" anchor="ctr">
+                    <a:solidFill>
+                      <a:srgbClr val="F3F5F7"/>
+                    </a:solidFill>
+                  </a:tcPr>
+                </a:tc>
+              </a:tr>
+              <a:tr h="548640">
+                <a:tc>
+                  <a:txBody>
+                    <a:bodyPr/>
+                    <a:lstStyle/>
+                    <a:p>
+                      <a:pPr algn="l"/>
+                      <a:r>
+                        <a:rPr sz="1300" b="1" i="0">
+                          <a:solidFill>
+                            <a:srgbClr val="1F2A37"/>
+                          </a:solidFill>
+                          <a:latin typeface="Calibri"/>
+                        </a:rPr>
+                        <a:t>Cust. Pairs</a:t>
+                      </a:r>
+                    </a:p>
+                  </a:txBody>
+                  <a:tcPr marT="25400" marB="25400" marL="76200" marR="76200" anchor="ctr">
+                    <a:solidFill>
+                      <a:srgbClr val="FFFFFF"/>
+                    </a:solidFill>
+                  </a:tcPr>
+                </a:tc>
+                <a:tc>
+                  <a:txBody>
+                    <a:bodyPr/>
+                    <a:lstStyle/>
+                    <a:p>
+                      <a:pPr algn="ctr"/>
+                      <a:r>
+                        <a:rPr sz="1300" b="0" i="0">
+                          <a:solidFill>
+                            <a:srgbClr val="1F2A37"/>
+                          </a:solidFill>
+                          <a:latin typeface="Calibri"/>
+                        </a:rPr>
+                        <a:t>Pairwise column relationships</a:t>
+                      </a:r>
+                    </a:p>
+                  </a:txBody>
+                  <a:tcPr marT="25400" marB="25400" marL="76200" marR="76200" anchor="ctr">
+                    <a:solidFill>
+                      <a:srgbClr val="FFFFFF"/>
+                    </a:solidFill>
+                  </a:tcPr>
+                </a:tc>
+                <a:tc>
+                  <a:txBody>
+                    <a:bodyPr/>
+                    <a:lstStyle/>
+                    <a:p>
+                      <a:pPr algn="ctr"/>
+                      <a:r>
+                        <a:rPr sz="1300" b="0" i="0">
+                          <a:solidFill>
+                            <a:srgbClr val="1F2A37"/>
+                          </a:solidFill>
+                          <a:latin typeface="Calibri"/>
+                        </a:rPr>
+                        <a:t>avg CorrelationSimilarity / ContingencySimilarity</a:t>
+                      </a:r>
+                    </a:p>
+                  </a:txBody>
+                  <a:tcPr marT="25400" marB="25400" marL="76200" marR="76200" anchor="ctr">
+                    <a:solidFill>
+                      <a:srgbClr val="FFFFFF"/>
+                    </a:solidFill>
+                  </a:tcPr>
+                </a:tc>
+                <a:tc>
+                  <a:txBody>
+                    <a:bodyPr/>
+                    <a:lstStyle/>
+                    <a:p>
+                      <a:pPr algn="ctr"/>
+                      <a:r>
+                        <a:rPr sz="1300" b="0" i="0">
+                          <a:solidFill>
+                            <a:srgbClr val="1F2A37"/>
+                          </a:solidFill>
+                          <a:latin typeface="Calibri"/>
+                        </a:rPr>
+                        <a:t>↑</a:t>
+                      </a:r>
+                    </a:p>
+                  </a:txBody>
+                  <a:tcPr marT="25400" marB="25400" marL="76200" marR="76200" anchor="ctr">
+                    <a:solidFill>
+                      <a:srgbClr val="FFFFFF"/>
+                    </a:solidFill>
+                  </a:tcPr>
+                </a:tc>
+              </a:tr>
+              <a:tr h="548640">
+                <a:tc>
+                  <a:txBody>
+                    <a:bodyPr/>
+                    <a:lstStyle/>
+                    <a:p>
+                      <a:pPr algn="l"/>
+                      <a:r>
+                        <a:rPr sz="1300" b="1" i="0">
+                          <a:solidFill>
+                            <a:srgbClr val="1F2A37"/>
+                          </a:solidFill>
+                          <a:latin typeface="Calibri"/>
+                        </a:rPr>
+                        <a:t>Diagnostic</a:t>
+                      </a:r>
+                    </a:p>
+                  </a:txBody>
+                  <a:tcPr marT="25400" marB="25400" marL="76200" marR="76200" anchor="ctr">
+                    <a:solidFill>
+                      <a:srgbClr val="F3F5F7"/>
+                    </a:solidFill>
+                  </a:tcPr>
+                </a:tc>
+                <a:tc>
+                  <a:txBody>
+                    <a:bodyPr/>
+                    <a:lstStyle/>
+                    <a:p>
+                      <a:pPr algn="ctr"/>
+                      <a:r>
+                        <a:rPr sz="1300" b="0" i="0">
+                          <a:solidFill>
+                            <a:srgbClr val="1F2A37"/>
+                          </a:solidFill>
+                          <a:latin typeface="Calibri"/>
+                        </a:rPr>
+                        <a:t>Validity &amp; structure (not fidelity)</a:t>
+                      </a:r>
+                    </a:p>
+                  </a:txBody>
+                  <a:tcPr marT="25400" marB="25400" marL="76200" marR="76200" anchor="ctr">
+                    <a:solidFill>
+                      <a:srgbClr val="F3F5F7"/>
+                    </a:solidFill>
+                  </a:tcPr>
+                </a:tc>
+                <a:tc>
+                  <a:txBody>
+                    <a:bodyPr/>
+                    <a:lstStyle/>
+                    <a:p>
+                      <a:pPr algn="ctr"/>
+                      <a:r>
+                        <a:rPr sz="1300" b="0" i="0">
+                          <a:solidFill>
+                            <a:srgbClr val="1F2A37"/>
+                          </a:solidFill>
+                          <a:latin typeface="Calibri"/>
+                        </a:rPr>
+                        <a:t>ranges · categories · keys · FK integrity</a:t>
+                      </a:r>
+                    </a:p>
+                  </a:txBody>
+                  <a:tcPr marT="25400" marB="25400" marL="76200" marR="76200" anchor="ctr">
+                    <a:solidFill>
+                      <a:srgbClr val="F3F5F7"/>
+                    </a:solidFill>
+                  </a:tcPr>
+                </a:tc>
+                <a:tc>
+                  <a:txBody>
+                    <a:bodyPr/>
+                    <a:lstStyle/>
+                    <a:p>
+                      <a:pPr algn="ctr"/>
+                      <a:r>
+                        <a:rPr sz="1300" b="0" i="0">
+                          <a:solidFill>
+                            <a:srgbClr val="1F2A37"/>
+                          </a:solidFill>
+                          <a:latin typeface="Calibri"/>
+                        </a:rPr>
+                        <a:t>↑</a:t>
+                      </a:r>
+                    </a:p>
+                  </a:txBody>
+                  <a:tcPr marT="25400" marB="25400" marL="76200" marR="76200" anchor="ctr">
+                    <a:solidFill>
+                      <a:srgbClr val="F3F5F7"/>
+                    </a:solidFill>
+                  </a:tcPr>
+                </a:tc>
+              </a:tr>
+            </a:tbl>
+          </a:graphicData>
+        </a:graphic>
+      </p:graphicFrame>
       <p:sp>
         <p:nvSpPr>
           <p:cNvPr id="5" name="TextBox 4"/>
@@ -10145,8 +12232,8 @@
         </p:nvSpPr>
         <p:spPr>
           <a:xfrm>
-            <a:off x="777240" y="6309360"/>
-            <a:ext cx="10607040" cy="457200"/>
+            <a:off x="777240" y="4846320"/>
+            <a:ext cx="10607040" cy="1737360"/>
           </a:xfrm>
           <a:prstGeom prst="rect">
             <a:avLst/>
@@ -10154,20 +12241,40 @@
           <a:noFill/>
         </p:spPr>
         <p:txBody>
-          <a:bodyPr wrap="none">
+          <a:bodyPr wrap="square">
             <a:spAutoFit/>
           </a:bodyPr>
           <a:lstStyle/>
           <a:p>
-            <a:pPr algn="l"/>
-            <a:r>
-              <a:rPr sz="1300" b="0" i="1">
+            <a:pPr algn="l">
+              <a:spcAft>
+                <a:spcPts val="800"/>
+              </a:spcAft>
+            </a:pPr>
+            <a:r>
+              <a:rPr sz="1400" b="0" i="0">
                 <a:solidFill>
-                  <a:srgbClr val="5B6670"/>
+                  <a:srgbClr val="1F2A37"/>
                 </a:solidFill>
                 <a:latin typeface="Calibri"/>
               </a:rPr>
-              <a:t>Normalised so higher = better on every axis. No single method dominates — the trade-offs are the story.</a:t>
+              <a:t>•  KSComplement = 1 − KS distance · TVComplement = 1 − total-variation distance (1.0 = identical).</a:t>
+            </a:r>
+          </a:p>
+          <a:p>
+            <a:pPr algn="l">
+              <a:spcAft>
+                <a:spcPts val="800"/>
+              </a:spcAft>
+            </a:pPr>
+            <a:r>
+              <a:rPr sz="1400" b="0" i="0">
+                <a:solidFill>
+                  <a:srgbClr val="1F2A37"/>
+                </a:solidFill>
+                <a:latin typeface="Calibri"/>
+              </a:rPr>
+              <a:t>•  Overall quality score = average of Column Shapes and Column Pair Trends.</a:t>
             </a:r>
           </a:p>
         </p:txBody>

</xml_diff>

<commit_message>
Add bootstrap CI metrics, DP/MST explainer slides, and quality-report slide
- metrics_extended.py: customer-level bootstrap (resample + relabel keys),
  bootstrap_compare_methods with shared real draws (common random numbers),
  median + 95% percentile CIs, format_ci_table helper
- run_bootstrap.py: full 5-method bootstrap runner -> reports/ + forest plot
- quality_report_fig.py: SDMetrics QualityReport breakdown grouped-bar figure
- slides: 'How differential privacy works', 'How SmartNoise/MST builds M5',
  and 'SDMetrics Quality Report' showcase (22 slides total)
- gitignore Office lock files and run logs
</commit_message>
<xml_diff>
--- a/slides.pptx
+++ b/slides.pptx
@@ -24,6 +24,9 @@
     <p:sldId id="272" r:id="rId23"/>
     <p:sldId id="273" r:id="rId24"/>
     <p:sldId id="274" r:id="rId25"/>
+    <p:sldId id="275" r:id="rId26"/>
+    <p:sldId id="276" r:id="rId27"/>
+    <p:sldId id="277" r:id="rId28"/>
   </p:sldIdLst>
   <p:sldSz cx="12191695" cy="6858000" type="screen4x3"/>
   <p:notesSz cx="6858000" cy="9144000"/>
@@ -4382,7 +4385,7 @@
                 </a:solidFill>
                 <a:latin typeface="Calibri"/>
               </a:rPr>
-              <a:t>CROSS-TABLE CORRELATION</a:t>
+              <a:t>FIDELITY SCORECARD</a:t>
             </a:r>
           </a:p>
           <a:p>
@@ -4394,14 +4397,14 @@
                 </a:solidFill>
                 <a:latin typeface="Calibri"/>
               </a:rPr>
-              <a:t>Does income still predict products?</a:t>
+              <a:t>SDMetrics Quality Report</a:t>
             </a:r>
           </a:p>
         </p:txBody>
       </p:sp>
       <p:pic>
         <p:nvPicPr>
-          <p:cNvPr id="4" name="Picture 3" descr="cross_table_heatmap.png"/>
+          <p:cNvPr id="4" name="Picture 3" descr="quality_report.png"/>
           <p:cNvPicPr>
             <a:picLocks noChangeAspect="1"/>
           </p:cNvPicPr>
@@ -4415,8 +4418,8 @@
         </p:blipFill>
         <p:spPr>
           <a:xfrm>
-            <a:off x="548640" y="2950784"/>
-            <a:ext cx="11155680" cy="1505071"/>
+            <a:off x="640080" y="1894290"/>
+            <a:ext cx="8229600" cy="3800938"/>
           </a:xfrm>
           <a:prstGeom prst="rect">
             <a:avLst/>
@@ -4426,6 +4429,107 @@
       <p:sp>
         <p:nvSpPr>
           <p:cNvPr id="5" name="TextBox 4"/>
+          <p:cNvSpPr txBox="1"/>
+          <p:nvPr/>
+        </p:nvSpPr>
+        <p:spPr>
+          <a:xfrm>
+            <a:off x="9052560" y="1691640"/>
+            <a:ext cx="2834640" cy="4297680"/>
+          </a:xfrm>
+          <a:prstGeom prst="rect">
+            <a:avLst/>
+          </a:prstGeom>
+          <a:noFill/>
+        </p:spPr>
+        <p:txBody>
+          <a:bodyPr wrap="square">
+            <a:spAutoFit/>
+          </a:bodyPr>
+          <a:lstStyle/>
+          <a:p>
+            <a:pPr algn="l"/>
+            <a:r>
+              <a:rPr sz="1300" b="1" i="0">
+                <a:solidFill>
+                  <a:srgbClr val="4E79A7"/>
+                </a:solidFill>
+                <a:latin typeface="Calibri"/>
+              </a:rPr>
+              <a:t>Overall = mean of
+Column Shapes &amp;
+Column Pair Trends</a:t>
+            </a:r>
+          </a:p>
+          <a:p>
+            <a:pPr algn="l">
+              <a:spcAft>
+                <a:spcPts val="800"/>
+              </a:spcAft>
+            </a:pPr>
+            <a:r>
+              <a:rPr sz="1200" b="0" i="0">
+                <a:solidFill>
+                  <a:srgbClr val="1F2A37"/>
+                </a:solidFill>
+                <a:latin typeface="Calibri"/>
+              </a:rPr>
+              <a:t>• M1 ≈ M4 lead overall (0.89) — strong on both halves.</a:t>
+            </a:r>
+          </a:p>
+          <a:p>
+            <a:pPr algn="l">
+              <a:spcAft>
+                <a:spcPts val="800"/>
+              </a:spcAft>
+            </a:pPr>
+            <a:r>
+              <a:rPr sz="1200" b="0" i="0">
+                <a:solidFill>
+                  <a:srgbClr val="1F2A37"/>
+                </a:solidFill>
+                <a:latin typeface="Calibri"/>
+              </a:rPr>
+              <a:t>• M5 wins customer pair trends (0.85) but on raw numeric correlation it's worst (see in-table slide).</a:t>
+            </a:r>
+          </a:p>
+          <a:p>
+            <a:pPr algn="l">
+              <a:spcAft>
+                <a:spcPts val="800"/>
+              </a:spcAft>
+            </a:pPr>
+            <a:r>
+              <a:rPr sz="1200" b="0" i="0">
+                <a:solidFill>
+                  <a:srgbClr val="1F2A37"/>
+                </a:solidFill>
+                <a:latin typeface="Calibri"/>
+              </a:rPr>
+              <a:t>• M2 best on transaction shapes (0.91), weak on pair trends.</a:t>
+            </a:r>
+          </a:p>
+          <a:p>
+            <a:pPr algn="l">
+              <a:spcAft>
+                <a:spcPts val="800"/>
+              </a:spcAft>
+            </a:pPr>
+            <a:r>
+              <a:rPr sz="1200" b="0" i="0">
+                <a:solidFill>
+                  <a:srgbClr val="1F2A37"/>
+                </a:solidFill>
+                <a:latin typeface="Calibri"/>
+              </a:rPr>
+              <a:t>• M3 trails everywhere (0.65) — PAR sacrifices marginals for sequence context.</a:t>
+            </a:r>
+          </a:p>
+        </p:txBody>
+      </p:sp>
+      <p:sp>
+        <p:nvSpPr>
+          <p:cNvPr id="6" name="TextBox 5"/>
           <p:cNvSpPr txBox="1"/>
           <p:nvPr/>
         </p:nvSpPr>
@@ -4453,7 +4557,7 @@
                 </a:solidFill>
                 <a:latin typeface="Calibri"/>
               </a:rPr>
-              <a:t>Feature→category Spearman correlations. Weak for every method — the cross-table signal is the hardest to keep.</a:t>
+              <a:t>SDMetrics QualityReport overall score decomposed into its sub-components, per method.</a:t>
             </a:r>
           </a:p>
         </p:txBody>
@@ -4557,7 +4661,7 @@
                 </a:solidFill>
                 <a:latin typeface="Calibri"/>
               </a:rPr>
-              <a:t>IN-TABLE CORRELATION</a:t>
+              <a:t>CROSS-TABLE CORRELATION</a:t>
             </a:r>
           </a:p>
           <a:p>
@@ -4569,14 +4673,14 @@
                 </a:solidFill>
                 <a:latin typeface="Calibri"/>
               </a:rPr>
-              <a:t>Within-customer correlation: M1 dominates</a:t>
+              <a:t>Does income still predict products?</a:t>
             </a:r>
           </a:p>
         </p:txBody>
       </p:sp>
       <p:pic>
         <p:nvPicPr>
-          <p:cNvPr id="4" name="Picture 3" descr="in_table_correlation.png"/>
+          <p:cNvPr id="4" name="Picture 3" descr="cross_table_heatmap.png"/>
           <p:cNvPicPr>
             <a:picLocks noChangeAspect="1"/>
           </p:cNvPicPr>
@@ -4590,8 +4694,8 @@
         </p:blipFill>
         <p:spPr>
           <a:xfrm>
-            <a:off x="848153" y="1508760"/>
-            <a:ext cx="7264812" cy="4480560"/>
+            <a:off x="548640" y="2950784"/>
+            <a:ext cx="11155680" cy="1505071"/>
           </a:xfrm>
           <a:prstGeom prst="rect">
             <a:avLst/>
@@ -4601,133 +4705,6 @@
       <p:sp>
         <p:nvSpPr>
           <p:cNvPr id="5" name="TextBox 4"/>
-          <p:cNvSpPr txBox="1"/>
-          <p:nvPr/>
-        </p:nvSpPr>
-        <p:spPr>
-          <a:xfrm>
-            <a:off x="8595360" y="1737360"/>
-            <a:ext cx="3200400" cy="4023360"/>
-          </a:xfrm>
-          <a:prstGeom prst="rect">
-            <a:avLst/>
-          </a:prstGeom>
-          <a:noFill/>
-        </p:spPr>
-        <p:txBody>
-          <a:bodyPr wrap="square">
-            <a:spAutoFit/>
-          </a:bodyPr>
-          <a:lstStyle/>
-          <a:p>
-            <a:pPr algn="l"/>
-            <a:r>
-              <a:rPr sz="1500" b="1" i="0">
-                <a:solidFill>
-                  <a:srgbClr val="4E79A7"/>
-                </a:solidFill>
-                <a:latin typeface="Calibri"/>
-              </a:rPr>
-              <a:t>MAE vs Real ↓</a:t>
-            </a:r>
-          </a:p>
-          <a:p>
-            <a:pPr algn="l">
-              <a:spcAft>
-                <a:spcPts val="700"/>
-              </a:spcAft>
-            </a:pPr>
-            <a:r>
-              <a:rPr sz="1400" b="1" i="0">
-                <a:solidFill>
-                  <a:srgbClr val="4E79A7"/>
-                </a:solidFill>
-                <a:latin typeface="Calibri"/>
-              </a:rPr>
-              <a:t>M1  0.029   (Gaussian Copula)</a:t>
-            </a:r>
-          </a:p>
-          <a:p>
-            <a:pPr algn="l">
-              <a:spcAft>
-                <a:spcPts val="700"/>
-              </a:spcAft>
-            </a:pPr>
-            <a:r>
-              <a:rPr sz="1400" b="0" i="0">
-                <a:solidFill>
-                  <a:srgbClr val="E15759"/>
-                </a:solidFill>
-                <a:latin typeface="Calibri"/>
-              </a:rPr>
-              <a:t>M4  0.056</a:t>
-            </a:r>
-          </a:p>
-          <a:p>
-            <a:pPr algn="l">
-              <a:spcAft>
-                <a:spcPts val="700"/>
-              </a:spcAft>
-            </a:pPr>
-            <a:r>
-              <a:rPr sz="1400" b="0" i="0">
-                <a:solidFill>
-                  <a:srgbClr val="F28E2B"/>
-                </a:solidFill>
-                <a:latin typeface="Calibri"/>
-              </a:rPr>
-              <a:t>M2  0.132</a:t>
-            </a:r>
-          </a:p>
-          <a:p>
-            <a:pPr algn="l">
-              <a:spcAft>
-                <a:spcPts val="700"/>
-              </a:spcAft>
-            </a:pPr>
-            <a:r>
-              <a:rPr sz="1400" b="0" i="0">
-                <a:solidFill>
-                  <a:srgbClr val="59A14F"/>
-                </a:solidFill>
-                <a:latin typeface="Calibri"/>
-              </a:rPr>
-              <a:t>M3  0.139</a:t>
-            </a:r>
-          </a:p>
-          <a:p>
-            <a:pPr algn="l">
-              <a:spcAft>
-                <a:spcPts val="700"/>
-              </a:spcAft>
-            </a:pPr>
-            <a:r>
-              <a:rPr sz="1400" b="1" i="0">
-                <a:solidFill>
-                  <a:srgbClr val="B07AA1"/>
-                </a:solidFill>
-                <a:latin typeface="Calibri"/>
-              </a:rPr>
-              <a:t>M5  0.225   (DP cost)</a:t>
-            </a:r>
-          </a:p>
-          <a:p>
-            <a:pPr algn="l"/>
-            <a:r>
-              <a:rPr sz="1200" b="0" i="1">
-                <a:solidFill>
-                  <a:srgbClr val="5B6670"/>
-                </a:solidFill>
-                <a:latin typeface="Calibri"/>
-              </a:rPr>
-              <a:t>M1 reproduces income↔credit↔age ~2–8× better; M5 (best marginals) is worst on correlation.</a:t>
-            </a:r>
-          </a:p>
-        </p:txBody>
-      </p:sp>
-      <p:sp>
-        <p:nvSpPr>
-          <p:cNvPr id="6" name="TextBox 5"/>
           <p:cNvSpPr txBox="1"/>
           <p:nvPr/>
         </p:nvSpPr>
@@ -4755,7 +4732,7 @@
                 </a:solidFill>
                 <a:latin typeface="Calibri"/>
               </a:rPr>
-              <a:t>Pearson correlation of customer numeric columns — Real vs each method (MAE over off-diagonal pairs).</a:t>
+              <a:t>Feature→category Spearman correlations. Weak for every method — the cross-table signal is the hardest to keep.</a:t>
             </a:r>
           </a:p>
         </p:txBody>
@@ -4859,6 +4836,308 @@
                 </a:solidFill>
                 <a:latin typeface="Calibri"/>
               </a:rPr>
+              <a:t>IN-TABLE CORRELATION</a:t>
+            </a:r>
+          </a:p>
+          <a:p>
+            <a:pPr algn="l"/>
+            <a:r>
+              <a:rPr sz="3200" b="1" i="0">
+                <a:solidFill>
+                  <a:srgbClr val="1F2A37"/>
+                </a:solidFill>
+                <a:latin typeface="Calibri"/>
+              </a:rPr>
+              <a:t>Within-customer correlation: M1 dominates</a:t>
+            </a:r>
+          </a:p>
+        </p:txBody>
+      </p:sp>
+      <p:pic>
+        <p:nvPicPr>
+          <p:cNvPr id="4" name="Picture 3" descr="in_table_correlation.png"/>
+          <p:cNvPicPr>
+            <a:picLocks noChangeAspect="1"/>
+          </p:cNvPicPr>
+          <p:nvPr/>
+        </p:nvPicPr>
+        <p:blipFill>
+          <a:blip r:embed="rId2"/>
+          <a:stretch>
+            <a:fillRect/>
+          </a:stretch>
+        </p:blipFill>
+        <p:spPr>
+          <a:xfrm>
+            <a:off x="848153" y="1508760"/>
+            <a:ext cx="7264812" cy="4480560"/>
+          </a:xfrm>
+          <a:prstGeom prst="rect">
+            <a:avLst/>
+          </a:prstGeom>
+        </p:spPr>
+      </p:pic>
+      <p:sp>
+        <p:nvSpPr>
+          <p:cNvPr id="5" name="TextBox 4"/>
+          <p:cNvSpPr txBox="1"/>
+          <p:nvPr/>
+        </p:nvSpPr>
+        <p:spPr>
+          <a:xfrm>
+            <a:off x="8595360" y="1737360"/>
+            <a:ext cx="3200400" cy="4023360"/>
+          </a:xfrm>
+          <a:prstGeom prst="rect">
+            <a:avLst/>
+          </a:prstGeom>
+          <a:noFill/>
+        </p:spPr>
+        <p:txBody>
+          <a:bodyPr wrap="square">
+            <a:spAutoFit/>
+          </a:bodyPr>
+          <a:lstStyle/>
+          <a:p>
+            <a:pPr algn="l"/>
+            <a:r>
+              <a:rPr sz="1500" b="1" i="0">
+                <a:solidFill>
+                  <a:srgbClr val="4E79A7"/>
+                </a:solidFill>
+                <a:latin typeface="Calibri"/>
+              </a:rPr>
+              <a:t>MAE vs Real ↓</a:t>
+            </a:r>
+          </a:p>
+          <a:p>
+            <a:pPr algn="l">
+              <a:spcAft>
+                <a:spcPts val="700"/>
+              </a:spcAft>
+            </a:pPr>
+            <a:r>
+              <a:rPr sz="1400" b="1" i="0">
+                <a:solidFill>
+                  <a:srgbClr val="4E79A7"/>
+                </a:solidFill>
+                <a:latin typeface="Calibri"/>
+              </a:rPr>
+              <a:t>M1  0.029   (Gaussian Copula)</a:t>
+            </a:r>
+          </a:p>
+          <a:p>
+            <a:pPr algn="l">
+              <a:spcAft>
+                <a:spcPts val="700"/>
+              </a:spcAft>
+            </a:pPr>
+            <a:r>
+              <a:rPr sz="1400" b="0" i="0">
+                <a:solidFill>
+                  <a:srgbClr val="E15759"/>
+                </a:solidFill>
+                <a:latin typeface="Calibri"/>
+              </a:rPr>
+              <a:t>M4  0.056</a:t>
+            </a:r>
+          </a:p>
+          <a:p>
+            <a:pPr algn="l">
+              <a:spcAft>
+                <a:spcPts val="700"/>
+              </a:spcAft>
+            </a:pPr>
+            <a:r>
+              <a:rPr sz="1400" b="0" i="0">
+                <a:solidFill>
+                  <a:srgbClr val="F28E2B"/>
+                </a:solidFill>
+                <a:latin typeface="Calibri"/>
+              </a:rPr>
+              <a:t>M2  0.132</a:t>
+            </a:r>
+          </a:p>
+          <a:p>
+            <a:pPr algn="l">
+              <a:spcAft>
+                <a:spcPts val="700"/>
+              </a:spcAft>
+            </a:pPr>
+            <a:r>
+              <a:rPr sz="1400" b="0" i="0">
+                <a:solidFill>
+                  <a:srgbClr val="59A14F"/>
+                </a:solidFill>
+                <a:latin typeface="Calibri"/>
+              </a:rPr>
+              <a:t>M3  0.139</a:t>
+            </a:r>
+          </a:p>
+          <a:p>
+            <a:pPr algn="l">
+              <a:spcAft>
+                <a:spcPts val="700"/>
+              </a:spcAft>
+            </a:pPr>
+            <a:r>
+              <a:rPr sz="1400" b="1" i="0">
+                <a:solidFill>
+                  <a:srgbClr val="B07AA1"/>
+                </a:solidFill>
+                <a:latin typeface="Calibri"/>
+              </a:rPr>
+              <a:t>M5  0.225   (DP cost)</a:t>
+            </a:r>
+          </a:p>
+          <a:p>
+            <a:pPr algn="l"/>
+            <a:r>
+              <a:rPr sz="1200" b="0" i="1">
+                <a:solidFill>
+                  <a:srgbClr val="5B6670"/>
+                </a:solidFill>
+                <a:latin typeface="Calibri"/>
+              </a:rPr>
+              <a:t>M1 reproduces income↔credit↔age ~2–8× better; M5 (best marginals) is worst on correlation.</a:t>
+            </a:r>
+          </a:p>
+        </p:txBody>
+      </p:sp>
+      <p:sp>
+        <p:nvSpPr>
+          <p:cNvPr id="6" name="TextBox 5"/>
+          <p:cNvSpPr txBox="1"/>
+          <p:nvPr/>
+        </p:nvSpPr>
+        <p:spPr>
+          <a:xfrm>
+            <a:off x="777240" y="6309360"/>
+            <a:ext cx="10607040" cy="457200"/>
+          </a:xfrm>
+          <a:prstGeom prst="rect">
+            <a:avLst/>
+          </a:prstGeom>
+          <a:noFill/>
+        </p:spPr>
+        <p:txBody>
+          <a:bodyPr wrap="none">
+            <a:spAutoFit/>
+          </a:bodyPr>
+          <a:lstStyle/>
+          <a:p>
+            <a:pPr algn="l"/>
+            <a:r>
+              <a:rPr sz="1300" b="0" i="1">
+                <a:solidFill>
+                  <a:srgbClr val="5B6670"/>
+                </a:solidFill>
+                <a:latin typeface="Calibri"/>
+              </a:rPr>
+              <a:t>Pearson correlation of customer numeric columns — Real vs each method (MAE over off-diagonal pairs).</a:t>
+            </a:r>
+          </a:p>
+        </p:txBody>
+      </p:sp>
+    </p:spTree>
+  </p:cSld>
+  <p:clrMapOvr>
+    <a:masterClrMapping/>
+  </p:clrMapOvr>
+</p:sld>
+</file>
+
+<file path=ppt/slides/slide15.xml><?xml version="1.0" encoding="utf-8"?>
+<p:sld xmlns:a="http://schemas.openxmlformats.org/drawingml/2006/main" xmlns:p="http://schemas.openxmlformats.org/presentationml/2006/main" xmlns:r="http://schemas.openxmlformats.org/officeDocument/2006/relationships">
+  <p:cSld>
+    <p:bg>
+      <p:bgPr>
+        <a:solidFill>
+          <a:srgbClr val="FFFFFF"/>
+        </a:solidFill>
+        <a:effectLst/>
+      </p:bgPr>
+    </p:bg>
+    <p:spTree>
+      <p:nvGrpSpPr>
+        <p:cNvPr id="1" name=""/>
+        <p:cNvGrpSpPr/>
+        <p:nvPr/>
+      </p:nvGrpSpPr>
+      <p:grpSpPr/>
+      <p:sp>
+        <p:nvSpPr>
+          <p:cNvPr id="2" name="Rectangle 1"/>
+          <p:cNvSpPr/>
+          <p:nvPr/>
+        </p:nvSpPr>
+        <p:spPr>
+          <a:xfrm>
+            <a:off x="0" y="0"/>
+            <a:ext cx="201168" cy="6858000"/>
+          </a:xfrm>
+          <a:prstGeom prst="rect">
+            <a:avLst/>
+          </a:prstGeom>
+          <a:solidFill>
+            <a:srgbClr val="4E79A7"/>
+          </a:solidFill>
+          <a:ln>
+            <a:noFill/>
+          </a:ln>
+        </p:spPr>
+        <p:style>
+          <a:lnRef idx="1">
+            <a:schemeClr val="accent1"/>
+          </a:lnRef>
+          <a:fillRef idx="3">
+            <a:schemeClr val="accent1"/>
+          </a:fillRef>
+          <a:effectRef idx="2">
+            <a:schemeClr val="accent1"/>
+          </a:effectRef>
+          <a:fontRef idx="minor">
+            <a:schemeClr val="lt1"/>
+          </a:fontRef>
+        </p:style>
+        <p:txBody>
+          <a:bodyPr rtlCol="0" anchor="ctr"/>
+          <a:lstStyle/>
+          <a:p>
+            <a:pPr algn="ctr"/>
+          </a:p>
+        </p:txBody>
+      </p:sp>
+      <p:sp>
+        <p:nvSpPr>
+          <p:cNvPr id="3" name="TextBox 2"/>
+          <p:cNvSpPr txBox="1"/>
+          <p:nvPr/>
+        </p:nvSpPr>
+        <p:spPr>
+          <a:xfrm>
+            <a:off x="548640" y="384048"/>
+            <a:ext cx="11155680" cy="1005840"/>
+          </a:xfrm>
+          <a:prstGeom prst="rect">
+            <a:avLst/>
+          </a:prstGeom>
+          <a:noFill/>
+        </p:spPr>
+        <p:txBody>
+          <a:bodyPr wrap="none">
+            <a:spAutoFit/>
+          </a:bodyPr>
+          <a:lstStyle/>
+          <a:p>
+            <a:pPr algn="l"/>
+            <a:r>
+              <a:rPr sz="1300" b="1" i="0">
+                <a:solidFill>
+                  <a:srgbClr val="4E79A7"/>
+                </a:solidFill>
+                <a:latin typeface="Calibri"/>
+              </a:rPr>
               <a:t>CORRELATION SUMMARY</a:t>
             </a:r>
           </a:p>
@@ -5550,7 +5829,7 @@
 </p:sld>
 </file>
 
-<file path=ppt/slides/slide15.xml><?xml version="1.0" encoding="utf-8"?>
+<file path=ppt/slides/slide16.xml><?xml version="1.0" encoding="utf-8"?>
 <p:sld xmlns:a="http://schemas.openxmlformats.org/drawingml/2006/main" xmlns:p="http://schemas.openxmlformats.org/presentationml/2006/main" xmlns:r="http://schemas.openxmlformats.org/officeDocument/2006/relationships">
   <p:cSld>
     <p:bg>
@@ -5641,6 +5920,640 @@
                 </a:solidFill>
                 <a:latin typeface="Calibri"/>
               </a:rPr>
+              <a:t>METHOD 5 · THE GUARANTEE</a:t>
+            </a:r>
+          </a:p>
+          <a:p>
+            <a:pPr algn="l"/>
+            <a:r>
+              <a:rPr sz="3200" b="1" i="0">
+                <a:solidFill>
+                  <a:srgbClr val="1F2A37"/>
+                </a:solidFill>
+                <a:latin typeface="Calibri"/>
+              </a:rPr>
+              <a:t>How differential privacy works</a:t>
+            </a:r>
+          </a:p>
+        </p:txBody>
+      </p:sp>
+      <p:sp>
+        <p:nvSpPr>
+          <p:cNvPr id="4" name="Rounded Rectangle 3"/>
+          <p:cNvSpPr/>
+          <p:nvPr/>
+        </p:nvSpPr>
+        <p:spPr>
+          <a:xfrm>
+            <a:off x="777240" y="1600200"/>
+            <a:ext cx="10607040" cy="1097280"/>
+          </a:xfrm>
+          <a:prstGeom prst="roundRect">
+            <a:avLst/>
+          </a:prstGeom>
+          <a:solidFill>
+            <a:srgbClr val="F3F5F7"/>
+          </a:solidFill>
+          <a:ln>
+            <a:solidFill>
+              <a:srgbClr val="B07AA1"/>
+            </a:solidFill>
+          </a:ln>
+        </p:spPr>
+        <p:style>
+          <a:lnRef idx="1">
+            <a:schemeClr val="accent1"/>
+          </a:lnRef>
+          <a:fillRef idx="3">
+            <a:schemeClr val="accent1"/>
+          </a:fillRef>
+          <a:effectRef idx="2">
+            <a:schemeClr val="accent1"/>
+          </a:effectRef>
+          <a:fontRef idx="minor">
+            <a:schemeClr val="lt1"/>
+          </a:fontRef>
+        </p:style>
+        <p:txBody>
+          <a:bodyPr rtlCol="0" anchor="ctr" wrap="square"/>
+          <a:lstStyle/>
+          <a:p>
+            <a:pPr algn="ctr"/>
+            <a:r>
+              <a:rPr sz="1700" b="1" i="0">
+                <a:solidFill>
+                  <a:srgbClr val="1F2A37"/>
+                </a:solidFill>
+                <a:latin typeface="Calibri"/>
+              </a:rPr>
+              <a:t>Add or remove any one person   →   P(output | with you)  ≤  e^ε · P(output | without you)</a:t>
+            </a:r>
+          </a:p>
+          <a:p>
+            <a:pPr algn="ctr"/>
+            <a:r>
+              <a:rPr sz="1300" b="0" i="0">
+                <a:solidFill>
+                  <a:srgbClr val="5B6670"/>
+                </a:solidFill>
+                <a:latin typeface="Calibri"/>
+              </a:rPr>
+              <a:t>The two clouds of possible outputs stay nearly identical — your footprint hides in the noise.</a:t>
+            </a:r>
+          </a:p>
+        </p:txBody>
+      </p:sp>
+      <p:sp>
+        <p:nvSpPr>
+          <p:cNvPr id="5" name="TextBox 4"/>
+          <p:cNvSpPr txBox="1"/>
+          <p:nvPr/>
+        </p:nvSpPr>
+        <p:spPr>
+          <a:xfrm>
+            <a:off x="777240" y="2880360"/>
+            <a:ext cx="10607040" cy="3703320"/>
+          </a:xfrm>
+          <a:prstGeom prst="rect">
+            <a:avLst/>
+          </a:prstGeom>
+          <a:noFill/>
+        </p:spPr>
+        <p:txBody>
+          <a:bodyPr wrap="square">
+            <a:spAutoFit/>
+          </a:bodyPr>
+          <a:lstStyle/>
+          <a:p>
+            <a:pPr algn="l">
+              <a:spcAft>
+                <a:spcPts val="800"/>
+              </a:spcAft>
+            </a:pPr>
+            <a:r>
+              <a:rPr sz="1450" b="0" i="0">
+                <a:solidFill>
+                  <a:srgbClr val="1F2A37"/>
+                </a:solidFill>
+                <a:latin typeface="Calibri"/>
+              </a:rPr>
+              <a:t>•  A mathematical promise about the algorithm, not a property of the output — provable, not measured after the fact.</a:t>
+            </a:r>
+          </a:p>
+          <a:p>
+            <a:pPr algn="l">
+              <a:spcAft>
+                <a:spcPts val="800"/>
+              </a:spcAft>
+            </a:pPr>
+            <a:r>
+              <a:rPr sz="1450" b="0" i="0">
+                <a:solidFill>
+                  <a:srgbClr val="1F2A37"/>
+                </a:solidFill>
+                <a:latin typeface="Calibri"/>
+              </a:rPr>
+              <a:t>•  ε (privacy budget): small ε = strong privacy, blurry data; large ε = sharp data, weak privacy. Pipeline ≈ 3 / table.</a:t>
+            </a:r>
+          </a:p>
+          <a:p>
+            <a:pPr algn="l">
+              <a:spcAft>
+                <a:spcPts val="800"/>
+              </a:spcAft>
+            </a:pPr>
+            <a:r>
+              <a:rPr sz="1450" b="0" i="0">
+                <a:solidFill>
+                  <a:srgbClr val="1F2A37"/>
+                </a:solidFill>
+                <a:latin typeface="Calibri"/>
+              </a:rPr>
+              <a:t>•  δ: tiny probability the guarantee is allowed to fail (needed by the Gaussian mechanism).</a:t>
+            </a:r>
+          </a:p>
+          <a:p>
+            <a:pPr algn="l">
+              <a:spcAft>
+                <a:spcPts val="800"/>
+              </a:spcAft>
+            </a:pPr>
+            <a:r>
+              <a:rPr sz="1450" b="0" i="0">
+                <a:solidFill>
+                  <a:srgbClr val="1F2A37"/>
+                </a:solidFill>
+                <a:latin typeface="Calibri"/>
+              </a:rPr>
+              <a:t>•  Mechanism: add calibrated noise to aggregates — noise ∝ sensitivity / ε (how much one person can move the result).</a:t>
+            </a:r>
+          </a:p>
+          <a:p>
+            <a:pPr algn="l" lvl="1">
+              <a:spcAft>
+                <a:spcPts val="800"/>
+              </a:spcAft>
+            </a:pPr>
+            <a:r>
+              <a:rPr sz="1250" b="0" i="0">
+                <a:solidFill>
+                  <a:srgbClr val="5B6670"/>
+                </a:solidFill>
+                <a:latin typeface="Calibri"/>
+              </a:rPr>
+              <a:t>–  Never noise individual rows — noise the counts / histograms, then build data from those.</a:t>
+            </a:r>
+          </a:p>
+          <a:p>
+            <a:pPr algn="l">
+              <a:spcAft>
+                <a:spcPts val="800"/>
+              </a:spcAft>
+            </a:pPr>
+            <a:r>
+              <a:rPr sz="1450" b="0" i="0">
+                <a:solidFill>
+                  <a:srgbClr val="1F2A37"/>
+                </a:solidFill>
+                <a:latin typeface="Calibri"/>
+              </a:rPr>
+              <a:t>•  Composition: customers (ε=3) + transactions (ε=3) → ε ≈ 6 for someone in both tables.</a:t>
+            </a:r>
+          </a:p>
+          <a:p>
+            <a:pPr algn="l">
+              <a:spcAft>
+                <a:spcPts val="800"/>
+              </a:spcAft>
+            </a:pPr>
+            <a:r>
+              <a:rPr sz="1450" b="0" i="0">
+                <a:solidFill>
+                  <a:srgbClr val="1F2A37"/>
+                </a:solidFill>
+                <a:latin typeface="Calibri"/>
+              </a:rPr>
+              <a:t>•  Post-processing immunity: anything computed from DP output stays DP — you can't 'use it up'.</a:t>
+            </a:r>
+          </a:p>
+        </p:txBody>
+      </p:sp>
+    </p:spTree>
+  </p:cSld>
+  <p:clrMapOvr>
+    <a:masterClrMapping/>
+  </p:clrMapOvr>
+</p:sld>
+</file>
+
+<file path=ppt/slides/slide17.xml><?xml version="1.0" encoding="utf-8"?>
+<p:sld xmlns:a="http://schemas.openxmlformats.org/drawingml/2006/main" xmlns:p="http://schemas.openxmlformats.org/presentationml/2006/main" xmlns:r="http://schemas.openxmlformats.org/officeDocument/2006/relationships">
+  <p:cSld>
+    <p:bg>
+      <p:bgPr>
+        <a:solidFill>
+          <a:srgbClr val="FFFFFF"/>
+        </a:solidFill>
+        <a:effectLst/>
+      </p:bgPr>
+    </p:bg>
+    <p:spTree>
+      <p:nvGrpSpPr>
+        <p:cNvPr id="1" name=""/>
+        <p:cNvGrpSpPr/>
+        <p:nvPr/>
+      </p:nvGrpSpPr>
+      <p:grpSpPr/>
+      <p:sp>
+        <p:nvSpPr>
+          <p:cNvPr id="2" name="Rectangle 1"/>
+          <p:cNvSpPr/>
+          <p:nvPr/>
+        </p:nvSpPr>
+        <p:spPr>
+          <a:xfrm>
+            <a:off x="0" y="0"/>
+            <a:ext cx="201168" cy="6858000"/>
+          </a:xfrm>
+          <a:prstGeom prst="rect">
+            <a:avLst/>
+          </a:prstGeom>
+          <a:solidFill>
+            <a:srgbClr val="B07AA1"/>
+          </a:solidFill>
+          <a:ln>
+            <a:noFill/>
+          </a:ln>
+        </p:spPr>
+        <p:style>
+          <a:lnRef idx="1">
+            <a:schemeClr val="accent1"/>
+          </a:lnRef>
+          <a:fillRef idx="3">
+            <a:schemeClr val="accent1"/>
+          </a:fillRef>
+          <a:effectRef idx="2">
+            <a:schemeClr val="accent1"/>
+          </a:effectRef>
+          <a:fontRef idx="minor">
+            <a:schemeClr val="lt1"/>
+          </a:fontRef>
+        </p:style>
+        <p:txBody>
+          <a:bodyPr rtlCol="0" anchor="ctr"/>
+          <a:lstStyle/>
+          <a:p>
+            <a:pPr algn="ctr"/>
+          </a:p>
+        </p:txBody>
+      </p:sp>
+      <p:sp>
+        <p:nvSpPr>
+          <p:cNvPr id="3" name="TextBox 2"/>
+          <p:cNvSpPr txBox="1"/>
+          <p:nvPr/>
+        </p:nvSpPr>
+        <p:spPr>
+          <a:xfrm>
+            <a:off x="548640" y="384048"/>
+            <a:ext cx="11155680" cy="1005840"/>
+          </a:xfrm>
+          <a:prstGeom prst="rect">
+            <a:avLst/>
+          </a:prstGeom>
+          <a:noFill/>
+        </p:spPr>
+        <p:txBody>
+          <a:bodyPr wrap="none">
+            <a:spAutoFit/>
+          </a:bodyPr>
+          <a:lstStyle/>
+          <a:p>
+            <a:pPr algn="l"/>
+            <a:r>
+              <a:rPr sz="1300" b="1" i="0">
+                <a:solidFill>
+                  <a:srgbClr val="B07AA1"/>
+                </a:solidFill>
+                <a:latin typeface="Calibri"/>
+              </a:rPr>
+              <a:t>METHOD 5 · THE MECHANISM</a:t>
+            </a:r>
+          </a:p>
+          <a:p>
+            <a:pPr algn="l"/>
+            <a:r>
+              <a:rPr sz="3200" b="1" i="0">
+                <a:solidFill>
+                  <a:srgbClr val="1F2A37"/>
+                </a:solidFill>
+                <a:latin typeface="Calibri"/>
+              </a:rPr>
+              <a:t>How SmartNoise / MST builds M5</a:t>
+            </a:r>
+          </a:p>
+        </p:txBody>
+      </p:sp>
+      <p:sp>
+        <p:nvSpPr>
+          <p:cNvPr id="4" name="TextBox 3"/>
+          <p:cNvSpPr txBox="1"/>
+          <p:nvPr/>
+        </p:nvSpPr>
+        <p:spPr>
+          <a:xfrm>
+            <a:off x="777240" y="1783080"/>
+            <a:ext cx="10607040" cy="4572000"/>
+          </a:xfrm>
+          <a:prstGeom prst="rect">
+            <a:avLst/>
+          </a:prstGeom>
+          <a:noFill/>
+        </p:spPr>
+        <p:txBody>
+          <a:bodyPr wrap="square">
+            <a:spAutoFit/>
+          </a:bodyPr>
+          <a:lstStyle/>
+          <a:p>
+            <a:pPr algn="l">
+              <a:spcAft>
+                <a:spcPts val="800"/>
+              </a:spcAft>
+            </a:pPr>
+            <a:r>
+              <a:rPr sz="1500" b="0" i="0">
+                <a:solidFill>
+                  <a:srgbClr val="1F2A37"/>
+                </a:solidFill>
+                <a:latin typeface="Calibri"/>
+              </a:rPr>
+              <a:t>•  MST (private-PGM family): marginal-based — it learns noisy summaries and never memorises rows.</a:t>
+            </a:r>
+          </a:p>
+          <a:p>
+            <a:pPr algn="l">
+              <a:spcAft>
+                <a:spcPts val="800"/>
+              </a:spcAft>
+            </a:pPr>
+            <a:r>
+              <a:rPr sz="1500" b="0" i="0">
+                <a:solidFill>
+                  <a:srgbClr val="1F2A37"/>
+                </a:solidFill>
+                <a:latin typeface="Calibri"/>
+              </a:rPr>
+              <a:t>•  1 · Discretize — bucket every column into bins; privately learns the ranges (preprocessor_eps).</a:t>
+            </a:r>
+          </a:p>
+          <a:p>
+            <a:pPr algn="l">
+              <a:spcAft>
+                <a:spcPts val="800"/>
+              </a:spcAft>
+            </a:pPr>
+            <a:r>
+              <a:rPr sz="1500" b="0" i="0">
+                <a:solidFill>
+                  <a:srgbClr val="1F2A37"/>
+                </a:solidFill>
+                <a:latin typeface="Calibri"/>
+              </a:rPr>
+              <a:t>•  2 · Noisy 1-way marginals — per-column histograms with Gaussian noise added to every count.</a:t>
+            </a:r>
+          </a:p>
+          <a:p>
+            <a:pPr algn="l">
+              <a:spcAft>
+                <a:spcPts val="800"/>
+              </a:spcAft>
+            </a:pPr>
+            <a:r>
+              <a:rPr sz="1500" b="0" i="0">
+                <a:solidFill>
+                  <a:srgbClr val="1F2A37"/>
+                </a:solidFill>
+                <a:latin typeface="Calibri"/>
+              </a:rPr>
+              <a:t>•  3 · Maximum spanning tree — privately find the most-correlated column pairs and keep the tree that connects all columns; only those 2-way marginals are measured (+ noise).</a:t>
+            </a:r>
+          </a:p>
+          <a:p>
+            <a:pPr algn="l">
+              <a:spcAft>
+                <a:spcPts val="800"/>
+              </a:spcAft>
+            </a:pPr>
+            <a:r>
+              <a:rPr sz="1500" b="0" i="0">
+                <a:solidFill>
+                  <a:srgbClr val="1F2A37"/>
+                </a:solidFill>
+                <a:latin typeface="Calibri"/>
+              </a:rPr>
+              <a:t>•  4 · Fit a graphical model (Markov Random Field) consistent with the noisy marginals — pure post-processing, zero extra ε.</a:t>
+            </a:r>
+          </a:p>
+          <a:p>
+            <a:pPr algn="l">
+              <a:spcAft>
+                <a:spcPts val="800"/>
+              </a:spcAft>
+            </a:pPr>
+            <a:r>
+              <a:rPr sz="1500" b="0" i="0">
+                <a:solidFill>
+                  <a:srgbClr val="1F2A37"/>
+                </a:solidFill>
+                <a:latin typeface="Calibri"/>
+              </a:rPr>
+              <a:t>•  5 · Sample new rows from the fitted model.</a:t>
+            </a:r>
+          </a:p>
+          <a:p>
+            <a:pPr algn="l">
+              <a:spcAft>
+                <a:spcPts val="800"/>
+              </a:spcAft>
+            </a:pPr>
+            <a:r>
+              <a:rPr sz="1500" b="0" i="0">
+                <a:solidFill>
+                  <a:srgbClr val="1F2A37"/>
+                </a:solidFill>
+                <a:latin typeface="Calibri"/>
+              </a:rPr>
+              <a:t>•  Runs once per table (customers, transactions) → per-table ε composes to ≈ 6.</a:t>
+            </a:r>
+          </a:p>
+        </p:txBody>
+      </p:sp>
+      <p:sp>
+        <p:nvSpPr>
+          <p:cNvPr id="5" name="Rounded Rectangle 4"/>
+          <p:cNvSpPr/>
+          <p:nvPr/>
+        </p:nvSpPr>
+        <p:spPr>
+          <a:xfrm>
+            <a:off x="777240" y="5212080"/>
+            <a:ext cx="10607040" cy="1143000"/>
+          </a:xfrm>
+          <a:prstGeom prst="roundRect">
+            <a:avLst/>
+          </a:prstGeom>
+          <a:solidFill>
+            <a:srgbClr val="F3F5F7"/>
+          </a:solidFill>
+          <a:ln>
+            <a:solidFill>
+              <a:srgbClr val="B07AA1"/>
+            </a:solidFill>
+          </a:ln>
+        </p:spPr>
+        <p:style>
+          <a:lnRef idx="1">
+            <a:schemeClr val="accent1"/>
+          </a:lnRef>
+          <a:fillRef idx="3">
+            <a:schemeClr val="accent1"/>
+          </a:fillRef>
+          <a:effectRef idx="2">
+            <a:schemeClr val="accent1"/>
+          </a:effectRef>
+          <a:fontRef idx="minor">
+            <a:schemeClr val="lt1"/>
+          </a:fontRef>
+        </p:style>
+        <p:txBody>
+          <a:bodyPr rtlCol="0" anchor="ctr" wrap="square"/>
+          <a:lstStyle/>
+          <a:p>
+            <a:pPr algn="l"/>
+            <a:r>
+              <a:rPr sz="1300" b="1" i="0">
+                <a:solidFill>
+                  <a:srgbClr val="B07AA1"/>
+                </a:solidFill>
+                <a:latin typeface="Calibri"/>
+              </a:rPr>
+              <a:t>Why M5 looks the way it does</a:t>
+            </a:r>
+          </a:p>
+          <a:p>
+            <a:pPr algn="l"/>
+            <a:r>
+              <a:rPr sz="1250" b="0" i="0">
+                <a:solidFill>
+                  <a:srgbClr val="1F2A37"/>
+                </a:solidFill>
+                <a:latin typeface="Calibri"/>
+              </a:rPr>
+              <a:t>Guarantee by construction · only measured marginals survive (off-tree structure like per-customer sequencing is lost → autocorr collapses) · faithful marginals sit close to real rows → low DCR.</a:t>
+            </a:r>
+          </a:p>
+        </p:txBody>
+      </p:sp>
+    </p:spTree>
+  </p:cSld>
+  <p:clrMapOvr>
+    <a:masterClrMapping/>
+  </p:clrMapOvr>
+</p:sld>
+</file>
+
+<file path=ppt/slides/slide18.xml><?xml version="1.0" encoding="utf-8"?>
+<p:sld xmlns:a="http://schemas.openxmlformats.org/drawingml/2006/main" xmlns:p="http://schemas.openxmlformats.org/presentationml/2006/main" xmlns:r="http://schemas.openxmlformats.org/officeDocument/2006/relationships">
+  <p:cSld>
+    <p:bg>
+      <p:bgPr>
+        <a:solidFill>
+          <a:srgbClr val="FFFFFF"/>
+        </a:solidFill>
+        <a:effectLst/>
+      </p:bgPr>
+    </p:bg>
+    <p:spTree>
+      <p:nvGrpSpPr>
+        <p:cNvPr id="1" name=""/>
+        <p:cNvGrpSpPr/>
+        <p:nvPr/>
+      </p:nvGrpSpPr>
+      <p:grpSpPr/>
+      <p:sp>
+        <p:nvSpPr>
+          <p:cNvPr id="2" name="Rectangle 1"/>
+          <p:cNvSpPr/>
+          <p:nvPr/>
+        </p:nvSpPr>
+        <p:spPr>
+          <a:xfrm>
+            <a:off x="0" y="0"/>
+            <a:ext cx="201168" cy="6858000"/>
+          </a:xfrm>
+          <a:prstGeom prst="rect">
+            <a:avLst/>
+          </a:prstGeom>
+          <a:solidFill>
+            <a:srgbClr val="B07AA1"/>
+          </a:solidFill>
+          <a:ln>
+            <a:noFill/>
+          </a:ln>
+        </p:spPr>
+        <p:style>
+          <a:lnRef idx="1">
+            <a:schemeClr val="accent1"/>
+          </a:lnRef>
+          <a:fillRef idx="3">
+            <a:schemeClr val="accent1"/>
+          </a:fillRef>
+          <a:effectRef idx="2">
+            <a:schemeClr val="accent1"/>
+          </a:effectRef>
+          <a:fontRef idx="minor">
+            <a:schemeClr val="lt1"/>
+          </a:fontRef>
+        </p:style>
+        <p:txBody>
+          <a:bodyPr rtlCol="0" anchor="ctr"/>
+          <a:lstStyle/>
+          <a:p>
+            <a:pPr algn="ctr"/>
+          </a:p>
+        </p:txBody>
+      </p:sp>
+      <p:sp>
+        <p:nvSpPr>
+          <p:cNvPr id="3" name="TextBox 2"/>
+          <p:cNvSpPr txBox="1"/>
+          <p:nvPr/>
+        </p:nvSpPr>
+        <p:spPr>
+          <a:xfrm>
+            <a:off x="548640" y="384048"/>
+            <a:ext cx="11155680" cy="1005840"/>
+          </a:xfrm>
+          <a:prstGeom prst="rect">
+            <a:avLst/>
+          </a:prstGeom>
+          <a:noFill/>
+        </p:spPr>
+        <p:txBody>
+          <a:bodyPr wrap="none">
+            <a:spAutoFit/>
+          </a:bodyPr>
+          <a:lstStyle/>
+          <a:p>
+            <a:pPr algn="l"/>
+            <a:r>
+              <a:rPr sz="1300" b="1" i="0">
+                <a:solidFill>
+                  <a:srgbClr val="B07AA1"/>
+                </a:solidFill>
+                <a:latin typeface="Calibri"/>
+              </a:rPr>
               <a:t>PRIVACY</a:t>
             </a:r>
           </a:p>
@@ -5856,7 +6769,7 @@
 </p:sld>
 </file>
 
-<file path=ppt/slides/slide16.xml><?xml version="1.0" encoding="utf-8"?>
+<file path=ppt/slides/slide19.xml><?xml version="1.0" encoding="utf-8"?>
 <p:sld xmlns:a="http://schemas.openxmlformats.org/drawingml/2006/main" xmlns:p="http://schemas.openxmlformats.org/presentationml/2006/main" xmlns:r="http://schemas.openxmlformats.org/officeDocument/2006/relationships">
   <p:cSld>
     <p:bg>
@@ -6103,7 +7016,7 @@
 </p:sld>
 </file>
 
-<file path=ppt/slides/slide17.xml><?xml version="1.0" encoding="utf-8"?>
+<file path=ppt/slides/slide2.xml><?xml version="1.0" encoding="utf-8"?>
 <p:sld xmlns:a="http://schemas.openxmlformats.org/drawingml/2006/main" xmlns:p="http://schemas.openxmlformats.org/presentationml/2006/main" xmlns:r="http://schemas.openxmlformats.org/officeDocument/2006/relationships">
   <p:cSld>
     <p:bg>
@@ -6194,6 +7107,241 @@
                 </a:solidFill>
                 <a:latin typeface="Calibri"/>
               </a:rPr>
+              <a:t>THE PROBLEM</a:t>
+            </a:r>
+          </a:p>
+          <a:p>
+            <a:pPr algn="l"/>
+            <a:r>
+              <a:rPr sz="3200" b="1" i="0">
+                <a:solidFill>
+                  <a:srgbClr val="1F2A37"/>
+                </a:solidFill>
+                <a:latin typeface="Calibri"/>
+              </a:rPr>
+              <a:t>Why synthetic data?</a:t>
+            </a:r>
+          </a:p>
+        </p:txBody>
+      </p:sp>
+      <p:sp>
+        <p:nvSpPr>
+          <p:cNvPr id="4" name="TextBox 3"/>
+          <p:cNvSpPr txBox="1"/>
+          <p:nvPr/>
+        </p:nvSpPr>
+        <p:spPr>
+          <a:xfrm>
+            <a:off x="777240" y="1737360"/>
+            <a:ext cx="10607040" cy="4572000"/>
+          </a:xfrm>
+          <a:prstGeom prst="rect">
+            <a:avLst/>
+          </a:prstGeom>
+          <a:noFill/>
+        </p:spPr>
+        <p:txBody>
+          <a:bodyPr wrap="square">
+            <a:spAutoFit/>
+          </a:bodyPr>
+          <a:lstStyle/>
+          <a:p>
+            <a:pPr algn="l">
+              <a:spcAft>
+                <a:spcPts val="1200"/>
+              </a:spcAft>
+            </a:pPr>
+            <a:r>
+              <a:rPr sz="1800" b="0" i="0">
+                <a:solidFill>
+                  <a:srgbClr val="1F2A37"/>
+                </a:solidFill>
+                <a:latin typeface="Calibri"/>
+              </a:rPr>
+              <a:t>•  Real customer + transaction data is sensitive, regulated, and scarce.</a:t>
+            </a:r>
+          </a:p>
+          <a:p>
+            <a:pPr algn="l">
+              <a:spcAft>
+                <a:spcPts val="1200"/>
+              </a:spcAft>
+            </a:pPr>
+            <a:r>
+              <a:rPr sz="1800" b="0" i="0">
+                <a:solidFill>
+                  <a:srgbClr val="1F2A37"/>
+                </a:solidFill>
+                <a:latin typeface="Calibri"/>
+              </a:rPr>
+              <a:t>•  Teams still need realistic data to build &amp; test models, demos, and pipelines.</a:t>
+            </a:r>
+          </a:p>
+          <a:p>
+            <a:pPr algn="l">
+              <a:spcAft>
+                <a:spcPts val="1200"/>
+              </a:spcAft>
+            </a:pPr>
+            <a:r>
+              <a:rPr sz="1800" b="1" i="0">
+                <a:solidFill>
+                  <a:srgbClr val="1F2A37"/>
+                </a:solidFill>
+                <a:latin typeface="Calibri"/>
+              </a:rPr>
+              <a:t>•  Naïve synthesis preserves single-column shapes but breaks what matters:</a:t>
+            </a:r>
+          </a:p>
+          <a:p>
+            <a:pPr algn="l" lvl="1">
+              <a:spcAft>
+                <a:spcPts val="1200"/>
+              </a:spcAft>
+            </a:pPr>
+            <a:r>
+              <a:rPr sz="1600" b="0" i="0">
+                <a:solidFill>
+                  <a:srgbClr val="5B6670"/>
+                </a:solidFill>
+                <a:latin typeface="Calibri"/>
+              </a:rPr>
+              <a:t>–  cross-table correlations — does income still predict the products bought?</a:t>
+            </a:r>
+          </a:p>
+          <a:p>
+            <a:pPr algn="l" lvl="1">
+              <a:spcAft>
+                <a:spcPts val="1200"/>
+              </a:spcAft>
+            </a:pPr>
+            <a:r>
+              <a:rPr sz="1600" b="0" i="0">
+                <a:solidFill>
+                  <a:srgbClr val="5B6670"/>
+                </a:solidFill>
+                <a:latin typeface="Calibri"/>
+              </a:rPr>
+              <a:t>–  business rules — a product's category, a valid credit score, whole-number counts.</a:t>
+            </a:r>
+          </a:p>
+          <a:p>
+            <a:pPr algn="l">
+              <a:spcAft>
+                <a:spcPts val="1200"/>
+              </a:spcAft>
+            </a:pPr>
+            <a:r>
+              <a:rPr sz="1800" b="0" i="0">
+                <a:solidFill>
+                  <a:srgbClr val="1F2A37"/>
+                </a:solidFill>
+                <a:latin typeface="Calibri"/>
+              </a:rPr>
+              <a:t>•  Goal: data that is statistically faithful AND provably valid — then prove it's useful.</a:t>
+            </a:r>
+          </a:p>
+        </p:txBody>
+      </p:sp>
+    </p:spTree>
+  </p:cSld>
+  <p:clrMapOvr>
+    <a:masterClrMapping/>
+  </p:clrMapOvr>
+</p:sld>
+</file>
+
+<file path=ppt/slides/slide20.xml><?xml version="1.0" encoding="utf-8"?>
+<p:sld xmlns:a="http://schemas.openxmlformats.org/drawingml/2006/main" xmlns:p="http://schemas.openxmlformats.org/presentationml/2006/main" xmlns:r="http://schemas.openxmlformats.org/officeDocument/2006/relationships">
+  <p:cSld>
+    <p:bg>
+      <p:bgPr>
+        <a:solidFill>
+          <a:srgbClr val="FFFFFF"/>
+        </a:solidFill>
+        <a:effectLst/>
+      </p:bgPr>
+    </p:bg>
+    <p:spTree>
+      <p:nvGrpSpPr>
+        <p:cNvPr id="1" name=""/>
+        <p:cNvGrpSpPr/>
+        <p:nvPr/>
+      </p:nvGrpSpPr>
+      <p:grpSpPr/>
+      <p:sp>
+        <p:nvSpPr>
+          <p:cNvPr id="2" name="Rectangle 1"/>
+          <p:cNvSpPr/>
+          <p:nvPr/>
+        </p:nvSpPr>
+        <p:spPr>
+          <a:xfrm>
+            <a:off x="0" y="0"/>
+            <a:ext cx="201168" cy="6858000"/>
+          </a:xfrm>
+          <a:prstGeom prst="rect">
+            <a:avLst/>
+          </a:prstGeom>
+          <a:solidFill>
+            <a:srgbClr val="4E79A7"/>
+          </a:solidFill>
+          <a:ln>
+            <a:noFill/>
+          </a:ln>
+        </p:spPr>
+        <p:style>
+          <a:lnRef idx="1">
+            <a:schemeClr val="accent1"/>
+          </a:lnRef>
+          <a:fillRef idx="3">
+            <a:schemeClr val="accent1"/>
+          </a:fillRef>
+          <a:effectRef idx="2">
+            <a:schemeClr val="accent1"/>
+          </a:effectRef>
+          <a:fontRef idx="minor">
+            <a:schemeClr val="lt1"/>
+          </a:fontRef>
+        </p:style>
+        <p:txBody>
+          <a:bodyPr rtlCol="0" anchor="ctr"/>
+          <a:lstStyle/>
+          <a:p>
+            <a:pPr algn="ctr"/>
+          </a:p>
+        </p:txBody>
+      </p:sp>
+      <p:sp>
+        <p:nvSpPr>
+          <p:cNvPr id="3" name="TextBox 2"/>
+          <p:cNvSpPr txBox="1"/>
+          <p:nvPr/>
+        </p:nvSpPr>
+        <p:spPr>
+          <a:xfrm>
+            <a:off x="548640" y="384048"/>
+            <a:ext cx="11155680" cy="1005840"/>
+          </a:xfrm>
+          <a:prstGeom prst="rect">
+            <a:avLst/>
+          </a:prstGeom>
+          <a:noFill/>
+        </p:spPr>
+        <p:txBody>
+          <a:bodyPr wrap="none">
+            <a:spAutoFit/>
+          </a:bodyPr>
+          <a:lstStyle/>
+          <a:p>
+            <a:pPr algn="l"/>
+            <a:r>
+              <a:rPr sz="1300" b="1" i="0">
+                <a:solidFill>
+                  <a:srgbClr val="4E79A7"/>
+                </a:solidFill>
+                <a:latin typeface="Calibri"/>
+              </a:rPr>
               <a:t>VERDICT</a:t>
             </a:r>
           </a:p>
@@ -7844,7 +8992,7 @@
 </p:sld>
 </file>
 
-<file path=ppt/slides/slide18.xml><?xml version="1.0" encoding="utf-8"?>
+<file path=ppt/slides/slide21.xml><?xml version="1.0" encoding="utf-8"?>
 <p:sld xmlns:a="http://schemas.openxmlformats.org/drawingml/2006/main" xmlns:p="http://schemas.openxmlformats.org/presentationml/2006/main" xmlns:r="http://schemas.openxmlformats.org/officeDocument/2006/relationships">
   <p:cSld>
     <p:bg>
@@ -8373,7 +9521,7 @@
 </p:sld>
 </file>
 
-<file path=ppt/slides/slide19.xml><?xml version="1.0" encoding="utf-8"?>
+<file path=ppt/slides/slide22.xml><?xml version="1.0" encoding="utf-8"?>
 <p:sld xmlns:a="http://schemas.openxmlformats.org/drawingml/2006/main" xmlns:p="http://schemas.openxmlformats.org/presentationml/2006/main" xmlns:r="http://schemas.openxmlformats.org/officeDocument/2006/relationships">
   <p:cSld>
     <p:bg>
@@ -8631,241 +9779,6 @@
                 <a:latin typeface="Calibri"/>
               </a:rPr>
               <a:t>Code: src/{methods,constraints,evaluate,llm_suggest}.py  ·  synthetic_data_pipeline.ipynb</a:t>
-            </a:r>
-          </a:p>
-        </p:txBody>
-      </p:sp>
-    </p:spTree>
-  </p:cSld>
-  <p:clrMapOvr>
-    <a:masterClrMapping/>
-  </p:clrMapOvr>
-</p:sld>
-</file>
-
-<file path=ppt/slides/slide2.xml><?xml version="1.0" encoding="utf-8"?>
-<p:sld xmlns:a="http://schemas.openxmlformats.org/drawingml/2006/main" xmlns:p="http://schemas.openxmlformats.org/presentationml/2006/main" xmlns:r="http://schemas.openxmlformats.org/officeDocument/2006/relationships">
-  <p:cSld>
-    <p:bg>
-      <p:bgPr>
-        <a:solidFill>
-          <a:srgbClr val="FFFFFF"/>
-        </a:solidFill>
-        <a:effectLst/>
-      </p:bgPr>
-    </p:bg>
-    <p:spTree>
-      <p:nvGrpSpPr>
-        <p:cNvPr id="1" name=""/>
-        <p:cNvGrpSpPr/>
-        <p:nvPr/>
-      </p:nvGrpSpPr>
-      <p:grpSpPr/>
-      <p:sp>
-        <p:nvSpPr>
-          <p:cNvPr id="2" name="Rectangle 1"/>
-          <p:cNvSpPr/>
-          <p:nvPr/>
-        </p:nvSpPr>
-        <p:spPr>
-          <a:xfrm>
-            <a:off x="0" y="0"/>
-            <a:ext cx="201168" cy="6858000"/>
-          </a:xfrm>
-          <a:prstGeom prst="rect">
-            <a:avLst/>
-          </a:prstGeom>
-          <a:solidFill>
-            <a:srgbClr val="4E79A7"/>
-          </a:solidFill>
-          <a:ln>
-            <a:noFill/>
-          </a:ln>
-        </p:spPr>
-        <p:style>
-          <a:lnRef idx="1">
-            <a:schemeClr val="accent1"/>
-          </a:lnRef>
-          <a:fillRef idx="3">
-            <a:schemeClr val="accent1"/>
-          </a:fillRef>
-          <a:effectRef idx="2">
-            <a:schemeClr val="accent1"/>
-          </a:effectRef>
-          <a:fontRef idx="minor">
-            <a:schemeClr val="lt1"/>
-          </a:fontRef>
-        </p:style>
-        <p:txBody>
-          <a:bodyPr rtlCol="0" anchor="ctr"/>
-          <a:lstStyle/>
-          <a:p>
-            <a:pPr algn="ctr"/>
-          </a:p>
-        </p:txBody>
-      </p:sp>
-      <p:sp>
-        <p:nvSpPr>
-          <p:cNvPr id="3" name="TextBox 2"/>
-          <p:cNvSpPr txBox="1"/>
-          <p:nvPr/>
-        </p:nvSpPr>
-        <p:spPr>
-          <a:xfrm>
-            <a:off x="548640" y="384048"/>
-            <a:ext cx="11155680" cy="1005840"/>
-          </a:xfrm>
-          <a:prstGeom prst="rect">
-            <a:avLst/>
-          </a:prstGeom>
-          <a:noFill/>
-        </p:spPr>
-        <p:txBody>
-          <a:bodyPr wrap="none">
-            <a:spAutoFit/>
-          </a:bodyPr>
-          <a:lstStyle/>
-          <a:p>
-            <a:pPr algn="l"/>
-            <a:r>
-              <a:rPr sz="1300" b="1" i="0">
-                <a:solidFill>
-                  <a:srgbClr val="4E79A7"/>
-                </a:solidFill>
-                <a:latin typeface="Calibri"/>
-              </a:rPr>
-              <a:t>THE PROBLEM</a:t>
-            </a:r>
-          </a:p>
-          <a:p>
-            <a:pPr algn="l"/>
-            <a:r>
-              <a:rPr sz="3200" b="1" i="0">
-                <a:solidFill>
-                  <a:srgbClr val="1F2A37"/>
-                </a:solidFill>
-                <a:latin typeface="Calibri"/>
-              </a:rPr>
-              <a:t>Why synthetic data?</a:t>
-            </a:r>
-          </a:p>
-        </p:txBody>
-      </p:sp>
-      <p:sp>
-        <p:nvSpPr>
-          <p:cNvPr id="4" name="TextBox 3"/>
-          <p:cNvSpPr txBox="1"/>
-          <p:nvPr/>
-        </p:nvSpPr>
-        <p:spPr>
-          <a:xfrm>
-            <a:off x="777240" y="1737360"/>
-            <a:ext cx="10607040" cy="4572000"/>
-          </a:xfrm>
-          <a:prstGeom prst="rect">
-            <a:avLst/>
-          </a:prstGeom>
-          <a:noFill/>
-        </p:spPr>
-        <p:txBody>
-          <a:bodyPr wrap="square">
-            <a:spAutoFit/>
-          </a:bodyPr>
-          <a:lstStyle/>
-          <a:p>
-            <a:pPr algn="l">
-              <a:spcAft>
-                <a:spcPts val="1200"/>
-              </a:spcAft>
-            </a:pPr>
-            <a:r>
-              <a:rPr sz="1800" b="0" i="0">
-                <a:solidFill>
-                  <a:srgbClr val="1F2A37"/>
-                </a:solidFill>
-                <a:latin typeface="Calibri"/>
-              </a:rPr>
-              <a:t>•  Real customer + transaction data is sensitive, regulated, and scarce.</a:t>
-            </a:r>
-          </a:p>
-          <a:p>
-            <a:pPr algn="l">
-              <a:spcAft>
-                <a:spcPts val="1200"/>
-              </a:spcAft>
-            </a:pPr>
-            <a:r>
-              <a:rPr sz="1800" b="0" i="0">
-                <a:solidFill>
-                  <a:srgbClr val="1F2A37"/>
-                </a:solidFill>
-                <a:latin typeface="Calibri"/>
-              </a:rPr>
-              <a:t>•  Teams still need realistic data to build &amp; test models, demos, and pipelines.</a:t>
-            </a:r>
-          </a:p>
-          <a:p>
-            <a:pPr algn="l">
-              <a:spcAft>
-                <a:spcPts val="1200"/>
-              </a:spcAft>
-            </a:pPr>
-            <a:r>
-              <a:rPr sz="1800" b="1" i="0">
-                <a:solidFill>
-                  <a:srgbClr val="1F2A37"/>
-                </a:solidFill>
-                <a:latin typeface="Calibri"/>
-              </a:rPr>
-              <a:t>•  Naïve synthesis preserves single-column shapes but breaks what matters:</a:t>
-            </a:r>
-          </a:p>
-          <a:p>
-            <a:pPr algn="l" lvl="1">
-              <a:spcAft>
-                <a:spcPts val="1200"/>
-              </a:spcAft>
-            </a:pPr>
-            <a:r>
-              <a:rPr sz="1600" b="0" i="0">
-                <a:solidFill>
-                  <a:srgbClr val="5B6670"/>
-                </a:solidFill>
-                <a:latin typeface="Calibri"/>
-              </a:rPr>
-              <a:t>–  cross-table correlations — does income still predict the products bought?</a:t>
-            </a:r>
-          </a:p>
-          <a:p>
-            <a:pPr algn="l" lvl="1">
-              <a:spcAft>
-                <a:spcPts val="1200"/>
-              </a:spcAft>
-            </a:pPr>
-            <a:r>
-              <a:rPr sz="1600" b="0" i="0">
-                <a:solidFill>
-                  <a:srgbClr val="5B6670"/>
-                </a:solidFill>
-                <a:latin typeface="Calibri"/>
-              </a:rPr>
-              <a:t>–  business rules — a product's category, a valid credit score, whole-number counts.</a:t>
-            </a:r>
-          </a:p>
-          <a:p>
-            <a:pPr algn="l">
-              <a:spcAft>
-                <a:spcPts val="1200"/>
-              </a:spcAft>
-            </a:pPr>
-            <a:r>
-              <a:rPr sz="1800" b="0" i="0">
-                <a:solidFill>
-                  <a:srgbClr val="1F2A37"/>
-                </a:solidFill>
-                <a:latin typeface="Calibri"/>
-              </a:rPr>
-              <a:t>•  Goal: data that is statistically faithful AND provably valid — then prove it's useful.</a:t>
             </a:r>
           </a:p>
         </p:txBody>

</xml_diff>

<commit_message>
Add bootstrap CI forest-plot slide and result files
- run_bootstrap.py output: median + 95% CI per metric across 5 methods (B=200,
  privacy B=40); confirms M1≈M4 quality tie, M3-only cross-table separation,
  and M5's wide/unstable quality interval
- new 'Are the differences real?' robustness slide (23 slides total)
</commit_message>
<xml_diff>
--- a/slides.pptx
+++ b/slides.pptx
@@ -27,6 +27,7 @@
     <p:sldId id="275" r:id="rId26"/>
     <p:sldId id="276" r:id="rId27"/>
     <p:sldId id="277" r:id="rId28"/>
+    <p:sldId id="278" r:id="rId29"/>
   </p:sldIdLst>
   <p:sldSz cx="12191695" cy="6858000" type="screen4x3"/>
   <p:notesSz cx="6858000" cy="9144000"/>
@@ -9025,6 +9026,312 @@
             <a:avLst/>
           </a:prstGeom>
           <a:solidFill>
+            <a:srgbClr val="4E79A7"/>
+          </a:solidFill>
+          <a:ln>
+            <a:noFill/>
+          </a:ln>
+        </p:spPr>
+        <p:style>
+          <a:lnRef idx="1">
+            <a:schemeClr val="accent1"/>
+          </a:lnRef>
+          <a:fillRef idx="3">
+            <a:schemeClr val="accent1"/>
+          </a:fillRef>
+          <a:effectRef idx="2">
+            <a:schemeClr val="accent1"/>
+          </a:effectRef>
+          <a:fontRef idx="minor">
+            <a:schemeClr val="lt1"/>
+          </a:fontRef>
+        </p:style>
+        <p:txBody>
+          <a:bodyPr rtlCol="0" anchor="ctr"/>
+          <a:lstStyle/>
+          <a:p>
+            <a:pPr algn="ctr"/>
+          </a:p>
+        </p:txBody>
+      </p:sp>
+      <p:sp>
+        <p:nvSpPr>
+          <p:cNvPr id="3" name="TextBox 2"/>
+          <p:cNvSpPr txBox="1"/>
+          <p:nvPr/>
+        </p:nvSpPr>
+        <p:spPr>
+          <a:xfrm>
+            <a:off x="548640" y="384048"/>
+            <a:ext cx="11155680" cy="1005840"/>
+          </a:xfrm>
+          <a:prstGeom prst="rect">
+            <a:avLst/>
+          </a:prstGeom>
+          <a:noFill/>
+        </p:spPr>
+        <p:txBody>
+          <a:bodyPr wrap="none">
+            <a:spAutoFit/>
+          </a:bodyPr>
+          <a:lstStyle/>
+          <a:p>
+            <a:pPr algn="l"/>
+            <a:r>
+              <a:rPr sz="1300" b="1" i="0">
+                <a:solidFill>
+                  <a:srgbClr val="4E79A7"/>
+                </a:solidFill>
+                <a:latin typeface="Calibri"/>
+              </a:rPr>
+              <a:t>ROBUSTNESS</a:t>
+            </a:r>
+          </a:p>
+          <a:p>
+            <a:pPr algn="l"/>
+            <a:r>
+              <a:rPr sz="3200" b="1" i="0">
+                <a:solidFill>
+                  <a:srgbClr val="1F2A37"/>
+                </a:solidFill>
+                <a:latin typeface="Calibri"/>
+              </a:rPr>
+              <a:t>Are the differences real? 95% bootstrap CIs</a:t>
+            </a:r>
+          </a:p>
+        </p:txBody>
+      </p:sp>
+      <p:pic>
+        <p:nvPicPr>
+          <p:cNvPr id="4" name="Picture 3" descr="bootstrap_ci.png"/>
+          <p:cNvPicPr>
+            <a:picLocks noChangeAspect="1"/>
+          </p:cNvPicPr>
+          <p:nvPr/>
+        </p:nvPicPr>
+        <p:blipFill>
+          <a:blip r:embed="rId2"/>
+          <a:stretch>
+            <a:fillRect/>
+          </a:stretch>
+        </p:blipFill>
+        <p:spPr>
+          <a:xfrm>
+            <a:off x="457200" y="1710343"/>
+            <a:ext cx="8046720" cy="4260272"/>
+          </a:xfrm>
+          <a:prstGeom prst="rect">
+            <a:avLst/>
+          </a:prstGeom>
+        </p:spPr>
+      </p:pic>
+      <p:sp>
+        <p:nvSpPr>
+          <p:cNvPr id="5" name="TextBox 4"/>
+          <p:cNvSpPr txBox="1"/>
+          <p:nvPr/>
+        </p:nvSpPr>
+        <p:spPr>
+          <a:xfrm>
+            <a:off x="8732520" y="1737360"/>
+            <a:ext cx="3154680" cy="4389120"/>
+          </a:xfrm>
+          <a:prstGeom prst="rect">
+            <a:avLst/>
+          </a:prstGeom>
+          <a:noFill/>
+        </p:spPr>
+        <p:txBody>
+          <a:bodyPr wrap="square">
+            <a:spAutoFit/>
+          </a:bodyPr>
+          <a:lstStyle/>
+          <a:p>
+            <a:pPr algn="l"/>
+            <a:r>
+              <a:rPr sz="1400" b="1" i="0">
+                <a:solidFill>
+                  <a:srgbClr val="4E79A7"/>
+                </a:solidFill>
+                <a:latin typeface="Calibri"/>
+              </a:rPr>
+              <a:t>What the overlap tells us</a:t>
+            </a:r>
+          </a:p>
+          <a:p>
+            <a:pPr algn="l">
+              <a:spcAft>
+                <a:spcPts val="700"/>
+              </a:spcAft>
+            </a:pPr>
+            <a:r>
+              <a:rPr sz="1150" b="0" i="0">
+                <a:solidFill>
+                  <a:srgbClr val="1F2A37"/>
+                </a:solidFill>
+                <a:latin typeface="Calibri"/>
+              </a:rPr>
+              <a:t>• B=200 resamples of customers (+ their txns); whiskers = 2.5–97.5%.</a:t>
+            </a:r>
+          </a:p>
+          <a:p>
+            <a:pPr algn="l">
+              <a:spcAft>
+                <a:spcPts val="700"/>
+              </a:spcAft>
+            </a:pPr>
+            <a:r>
+              <a:rPr sz="1150" b="0" i="0">
+                <a:solidFill>
+                  <a:srgbClr val="1F2A37"/>
+                </a:solidFill>
+                <a:latin typeface="Calibri"/>
+              </a:rPr>
+              <a:t>• M1 ≈ M4 on quality — CIs overlap, so the tie is real, not noise.</a:t>
+            </a:r>
+          </a:p>
+          <a:p>
+            <a:pPr algn="l">
+              <a:spcAft>
+                <a:spcPts val="700"/>
+              </a:spcAft>
+            </a:pPr>
+            <a:r>
+              <a:rPr sz="1150" b="0" i="0">
+                <a:solidFill>
+                  <a:srgbClr val="1F2A37"/>
+                </a:solidFill>
+                <a:latin typeface="Calibri"/>
+              </a:rPr>
+              <a:t>• Cross-table: only M3 separates; M1/M2/M4/M5 are statistically tied.</a:t>
+            </a:r>
+          </a:p>
+          <a:p>
+            <a:pPr algn="l">
+              <a:spcAft>
+                <a:spcPts val="700"/>
+              </a:spcAft>
+            </a:pPr>
+            <a:r>
+              <a:rPr sz="1150" b="0" i="0">
+                <a:solidFill>
+                  <a:srgbClr val="1F2A37"/>
+                </a:solidFill>
+                <a:latin typeface="Calibri"/>
+              </a:rPr>
+              <a:t>• M5 leads pair trends (lower CI 0.80 &gt; M4's 0.79) — a genuine edge.</a:t>
+            </a:r>
+          </a:p>
+          <a:p>
+            <a:pPr algn="l">
+              <a:spcAft>
+                <a:spcPts val="700"/>
+              </a:spcAft>
+            </a:pPr>
+            <a:r>
+              <a:rPr sz="1150" b="0" i="0">
+                <a:solidFill>
+                  <a:srgbClr val="1F2A37"/>
+                </a:solidFill>
+                <a:latin typeface="Calibri"/>
+              </a:rPr>
+              <a:t>• M5's autocorr (~0.57) and lowest DCR are clear-cut, non-overlapping.</a:t>
+            </a:r>
+          </a:p>
+          <a:p>
+            <a:pPr algn="l">
+              <a:spcAft>
+                <a:spcPts val="700"/>
+              </a:spcAft>
+            </a:pPr>
+            <a:r>
+              <a:rPr sz="1150" b="0" i="0">
+                <a:solidFill>
+                  <a:srgbClr val="1F2A37"/>
+                </a:solidFill>
+                <a:latin typeface="Calibri"/>
+              </a:rPr>
+              <a:t>• M5's quality CI is the widest — DP randomness makes it least stable.</a:t>
+            </a:r>
+          </a:p>
+        </p:txBody>
+      </p:sp>
+      <p:sp>
+        <p:nvSpPr>
+          <p:cNvPr id="6" name="TextBox 5"/>
+          <p:cNvSpPr txBox="1"/>
+          <p:nvPr/>
+        </p:nvSpPr>
+        <p:spPr>
+          <a:xfrm>
+            <a:off x="777240" y="6309360"/>
+            <a:ext cx="10607040" cy="457200"/>
+          </a:xfrm>
+          <a:prstGeom prst="rect">
+            <a:avLst/>
+          </a:prstGeom>
+          <a:noFill/>
+        </p:spPr>
+        <p:txBody>
+          <a:bodyPr wrap="none">
+            <a:spAutoFit/>
+          </a:bodyPr>
+          <a:lstStyle/>
+          <a:p>
+            <a:pPr algn="l"/>
+            <a:r>
+              <a:rPr sz="1300" b="0" i="1">
+                <a:solidFill>
+                  <a:srgbClr val="5B6670"/>
+                </a:solidFill>
+                <a:latin typeface="Calibri"/>
+              </a:rPr>
+              <a:t>Median ± 95% percentile CI per metric (privacy at B=40, subsample 500). Non-overlapping intervals = a real difference.</a:t>
+            </a:r>
+          </a:p>
+        </p:txBody>
+      </p:sp>
+    </p:spTree>
+  </p:cSld>
+  <p:clrMapOvr>
+    <a:masterClrMapping/>
+  </p:clrMapOvr>
+</p:sld>
+</file>
+
+<file path=ppt/slides/slide22.xml><?xml version="1.0" encoding="utf-8"?>
+<p:sld xmlns:a="http://schemas.openxmlformats.org/drawingml/2006/main" xmlns:p="http://schemas.openxmlformats.org/presentationml/2006/main" xmlns:r="http://schemas.openxmlformats.org/officeDocument/2006/relationships">
+  <p:cSld>
+    <p:bg>
+      <p:bgPr>
+        <a:solidFill>
+          <a:srgbClr val="FFFFFF"/>
+        </a:solidFill>
+        <a:effectLst/>
+      </p:bgPr>
+    </p:bg>
+    <p:spTree>
+      <p:nvGrpSpPr>
+        <p:cNvPr id="1" name=""/>
+        <p:cNvGrpSpPr/>
+        <p:nvPr/>
+      </p:nvGrpSpPr>
+      <p:grpSpPr/>
+      <p:sp>
+        <p:nvSpPr>
+          <p:cNvPr id="2" name="Rectangle 1"/>
+          <p:cNvSpPr/>
+          <p:nvPr/>
+        </p:nvSpPr>
+        <p:spPr>
+          <a:xfrm>
+            <a:off x="0" y="0"/>
+            <a:ext cx="201168" cy="6858000"/>
+          </a:xfrm>
+          <a:prstGeom prst="rect">
+            <a:avLst/>
+          </a:prstGeom>
+          <a:solidFill>
             <a:srgbClr val="E15759"/>
           </a:solidFill>
           <a:ln>
@@ -9521,7 +9828,7 @@
 </p:sld>
 </file>
 
-<file path=ppt/slides/slide22.xml><?xml version="1.0" encoding="utf-8"?>
+<file path=ppt/slides/slide23.xml><?xml version="1.0" encoding="utf-8"?>
 <p:sld xmlns:a="http://schemas.openxmlformats.org/drawingml/2006/main" xmlns:p="http://schemas.openxmlformats.org/presentationml/2006/main" xmlns:r="http://schemas.openxmlformats.org/officeDocument/2006/relationships">
   <p:cSld>
     <p:bg>

</xml_diff>

<commit_message>
Add measurable-privacy audit: bootstrapped MIA + Clopper-Pearson empirical ε
- metrics_extended.py: distance-based membership-inference audit (members vs fresh
  non-members), AUC + advantage, Clopper-Pearson empirical ε lower bound, and
  bootstrap_privacy_audit (B=300 CIs on AUC, ε reported as CP confidence bound)
- run_privacy_audit.py: runs the audit + bootstrap -> reports/privacy_audit.{png,csv}
- slide: 'Can we measure privacy? A membership-inference audit' (measured privacy)
- notebook: new DP-score section with table + figure (all AUC ~0.50, ε=0 -> no
  certifiable leakage at n=2000; M5 alone carries the formal ε guarantee)
</commit_message>
<xml_diff>
--- a/slides.pptx
+++ b/slides.pptx
@@ -28,6 +28,7 @@
     <p:sldId id="276" r:id="rId27"/>
     <p:sldId id="277" r:id="rId28"/>
     <p:sldId id="278" r:id="rId29"/>
+    <p:sldId id="279" r:id="rId30"/>
   </p:sldIdLst>
   <p:sldSz cx="12191695" cy="6858000" type="screen4x3"/>
   <p:notesSz cx="6858000" cy="9144000"/>
@@ -6803,6 +6804,531 @@
             <a:avLst/>
           </a:prstGeom>
           <a:solidFill>
+            <a:srgbClr val="B07AA1"/>
+          </a:solidFill>
+          <a:ln>
+            <a:noFill/>
+          </a:ln>
+        </p:spPr>
+        <p:style>
+          <a:lnRef idx="1">
+            <a:schemeClr val="accent1"/>
+          </a:lnRef>
+          <a:fillRef idx="3">
+            <a:schemeClr val="accent1"/>
+          </a:fillRef>
+          <a:effectRef idx="2">
+            <a:schemeClr val="accent1"/>
+          </a:effectRef>
+          <a:fontRef idx="minor">
+            <a:schemeClr val="lt1"/>
+          </a:fontRef>
+        </p:style>
+        <p:txBody>
+          <a:bodyPr rtlCol="0" anchor="ctr"/>
+          <a:lstStyle/>
+          <a:p>
+            <a:pPr algn="ctr"/>
+          </a:p>
+        </p:txBody>
+      </p:sp>
+      <p:sp>
+        <p:nvSpPr>
+          <p:cNvPr id="3" name="TextBox 2"/>
+          <p:cNvSpPr txBox="1"/>
+          <p:nvPr/>
+        </p:nvSpPr>
+        <p:spPr>
+          <a:xfrm>
+            <a:off x="548640" y="384048"/>
+            <a:ext cx="11155680" cy="1005840"/>
+          </a:xfrm>
+          <a:prstGeom prst="rect">
+            <a:avLst/>
+          </a:prstGeom>
+          <a:noFill/>
+        </p:spPr>
+        <p:txBody>
+          <a:bodyPr wrap="none">
+            <a:spAutoFit/>
+          </a:bodyPr>
+          <a:lstStyle/>
+          <a:p>
+            <a:pPr algn="l"/>
+            <a:r>
+              <a:rPr sz="1300" b="1" i="0">
+                <a:solidFill>
+                  <a:srgbClr val="B07AA1"/>
+                </a:solidFill>
+                <a:latin typeface="Calibri"/>
+              </a:rPr>
+              <a:t>MEASURED PRIVACY</a:t>
+            </a:r>
+          </a:p>
+          <a:p>
+            <a:pPr algn="l"/>
+            <a:r>
+              <a:rPr sz="3200" b="1" i="0">
+                <a:solidFill>
+                  <a:srgbClr val="1F2A37"/>
+                </a:solidFill>
+                <a:latin typeface="Calibri"/>
+              </a:rPr>
+              <a:t>Can we measure privacy? A membership-inference audit</a:t>
+            </a:r>
+          </a:p>
+        </p:txBody>
+      </p:sp>
+      <p:pic>
+        <p:nvPicPr>
+          <p:cNvPr id="4" name="Picture 3" descr="privacy_audit.png"/>
+          <p:cNvPicPr>
+            <a:picLocks noChangeAspect="1"/>
+          </p:cNvPicPr>
+          <p:nvPr/>
+        </p:nvPicPr>
+        <p:blipFill>
+          <a:blip r:embed="rId2"/>
+          <a:stretch>
+            <a:fillRect/>
+          </a:stretch>
+        </p:blipFill>
+        <p:spPr>
+          <a:xfrm>
+            <a:off x="411480" y="1906898"/>
+            <a:ext cx="8275320" cy="3272802"/>
+          </a:xfrm>
+          <a:prstGeom prst="rect">
+            <a:avLst/>
+          </a:prstGeom>
+        </p:spPr>
+      </p:pic>
+      <p:sp>
+        <p:nvSpPr>
+          <p:cNvPr id="5" name="TextBox 4"/>
+          <p:cNvSpPr txBox="1"/>
+          <p:nvPr/>
+        </p:nvSpPr>
+        <p:spPr>
+          <a:xfrm>
+            <a:off x="8823960" y="1691640"/>
+            <a:ext cx="3063240" cy="4297680"/>
+          </a:xfrm>
+          <a:prstGeom prst="rect">
+            <a:avLst/>
+          </a:prstGeom>
+          <a:noFill/>
+        </p:spPr>
+        <p:txBody>
+          <a:bodyPr wrap="square">
+            <a:spAutoFit/>
+          </a:bodyPr>
+          <a:lstStyle/>
+          <a:p>
+            <a:pPr algn="l"/>
+            <a:r>
+              <a:rPr sz="1350" b="1" i="0">
+                <a:solidFill>
+                  <a:srgbClr val="B07AA1"/>
+                </a:solidFill>
+                <a:latin typeface="Calibri"/>
+              </a:rPr>
+              <a:t>ε is accounted, not measured</a:t>
+            </a:r>
+          </a:p>
+          <a:p>
+            <a:pPr algn="l">
+              <a:spcAft>
+                <a:spcPts val="600"/>
+              </a:spcAft>
+            </a:pPr>
+            <a:r>
+              <a:rPr sz="1100" b="0" i="0">
+                <a:solidFill>
+                  <a:srgbClr val="1F2A37"/>
+                </a:solidFill>
+                <a:latin typeface="Calibri"/>
+              </a:rPr>
+              <a:t>• Guarantee (ε) = worst-case bookkeeping from the accountant — can't be read off the data.</a:t>
+            </a:r>
+          </a:p>
+          <a:p>
+            <a:pPr algn="l">
+              <a:spcAft>
+                <a:spcPts val="600"/>
+              </a:spcAft>
+            </a:pPr>
+            <a:r>
+              <a:rPr sz="1100" b="0" i="0">
+                <a:solidFill>
+                  <a:srgbClr val="1F2A37"/>
+                </a:solidFill>
+                <a:latin typeface="Calibri"/>
+              </a:rPr>
+              <a:t>• Measurable instead: attacker AUC separating training members from fresh non-members.</a:t>
+            </a:r>
+          </a:p>
+          <a:p>
+            <a:pPr algn="l">
+              <a:spcAft>
+                <a:spcPts val="600"/>
+              </a:spcAft>
+            </a:pPr>
+            <a:r>
+              <a:rPr sz="1100" b="0" i="0">
+                <a:solidFill>
+                  <a:srgbClr val="1F2A37"/>
+                </a:solidFill>
+                <a:latin typeface="Calibri"/>
+              </a:rPr>
+              <a:t>• B=300 bootstrap: every method's AUC interval straddles 0.50 → no significant leakage.</a:t>
+            </a:r>
+          </a:p>
+          <a:p>
+            <a:pPr algn="l">
+              <a:spcAft>
+                <a:spcPts val="600"/>
+              </a:spcAft>
+            </a:pPr>
+            <a:r>
+              <a:rPr sz="1100" b="0" i="0">
+                <a:solidFill>
+                  <a:srgbClr val="1F2A37"/>
+                </a:solidFill>
+                <a:latin typeface="Calibri"/>
+              </a:rPr>
+              <a:t>• Clopper-Pearson empirical ε = 0 for all — no certifiable leak, far under M5's ε≈6 budget.</a:t>
+            </a:r>
+          </a:p>
+          <a:p>
+            <a:pPr algn="l">
+              <a:spcAft>
+                <a:spcPts val="600"/>
+              </a:spcAft>
+            </a:pPr>
+            <a:r>
+              <a:rPr sz="1100" b="0" i="0">
+                <a:solidFill>
+                  <a:srgbClr val="1F2A37"/>
+                </a:solidFill>
+                <a:latin typeface="Calibri"/>
+              </a:rPr>
+              <a:t>• Average AUC can miss worst-case records; M5's DP bound is the only per-record, any-scale guarantee.</a:t>
+            </a:r>
+          </a:p>
+        </p:txBody>
+      </p:sp>
+      <p:sp>
+        <p:nvSpPr>
+          <p:cNvPr id="6" name="TextBox 5"/>
+          <p:cNvSpPr txBox="1"/>
+          <p:nvPr/>
+        </p:nvSpPr>
+        <p:spPr>
+          <a:xfrm>
+            <a:off x="777240" y="6309360"/>
+            <a:ext cx="10607040" cy="457200"/>
+          </a:xfrm>
+          <a:prstGeom prst="rect">
+            <a:avLst/>
+          </a:prstGeom>
+          <a:noFill/>
+        </p:spPr>
+        <p:txBody>
+          <a:bodyPr wrap="none">
+            <a:spAutoFit/>
+          </a:bodyPr>
+          <a:lstStyle/>
+          <a:p>
+            <a:pPr algn="l"/>
+            <a:r>
+              <a:rPr sz="1300" b="0" i="1">
+                <a:solidFill>
+                  <a:srgbClr val="5B6670"/>
+                </a:solidFill>
+                <a:latin typeface="Calibri"/>
+              </a:rPr>
+              <a:t>Members = real training rows; non-members = fresh draw from the same process. AUC 0.5 = no leakage; ε via Clopper-Pearson 95% lower bound (B=300 bootstrap CIs on AUC).</a:t>
+            </a:r>
+          </a:p>
+        </p:txBody>
+      </p:sp>
+    </p:spTree>
+  </p:cSld>
+  <p:clrMapOvr>
+    <a:masterClrMapping/>
+  </p:clrMapOvr>
+</p:sld>
+</file>
+
+<file path=ppt/slides/slide2.xml><?xml version="1.0" encoding="utf-8"?>
+<p:sld xmlns:a="http://schemas.openxmlformats.org/drawingml/2006/main" xmlns:p="http://schemas.openxmlformats.org/presentationml/2006/main" xmlns:r="http://schemas.openxmlformats.org/officeDocument/2006/relationships">
+  <p:cSld>
+    <p:bg>
+      <p:bgPr>
+        <a:solidFill>
+          <a:srgbClr val="FFFFFF"/>
+        </a:solidFill>
+        <a:effectLst/>
+      </p:bgPr>
+    </p:bg>
+    <p:spTree>
+      <p:nvGrpSpPr>
+        <p:cNvPr id="1" name=""/>
+        <p:cNvGrpSpPr/>
+        <p:nvPr/>
+      </p:nvGrpSpPr>
+      <p:grpSpPr/>
+      <p:sp>
+        <p:nvSpPr>
+          <p:cNvPr id="2" name="Rectangle 1"/>
+          <p:cNvSpPr/>
+          <p:nvPr/>
+        </p:nvSpPr>
+        <p:spPr>
+          <a:xfrm>
+            <a:off x="0" y="0"/>
+            <a:ext cx="201168" cy="6858000"/>
+          </a:xfrm>
+          <a:prstGeom prst="rect">
+            <a:avLst/>
+          </a:prstGeom>
+          <a:solidFill>
+            <a:srgbClr val="4E79A7"/>
+          </a:solidFill>
+          <a:ln>
+            <a:noFill/>
+          </a:ln>
+        </p:spPr>
+        <p:style>
+          <a:lnRef idx="1">
+            <a:schemeClr val="accent1"/>
+          </a:lnRef>
+          <a:fillRef idx="3">
+            <a:schemeClr val="accent1"/>
+          </a:fillRef>
+          <a:effectRef idx="2">
+            <a:schemeClr val="accent1"/>
+          </a:effectRef>
+          <a:fontRef idx="minor">
+            <a:schemeClr val="lt1"/>
+          </a:fontRef>
+        </p:style>
+        <p:txBody>
+          <a:bodyPr rtlCol="0" anchor="ctr"/>
+          <a:lstStyle/>
+          <a:p>
+            <a:pPr algn="ctr"/>
+          </a:p>
+        </p:txBody>
+      </p:sp>
+      <p:sp>
+        <p:nvSpPr>
+          <p:cNvPr id="3" name="TextBox 2"/>
+          <p:cNvSpPr txBox="1"/>
+          <p:nvPr/>
+        </p:nvSpPr>
+        <p:spPr>
+          <a:xfrm>
+            <a:off x="548640" y="384048"/>
+            <a:ext cx="11155680" cy="1005840"/>
+          </a:xfrm>
+          <a:prstGeom prst="rect">
+            <a:avLst/>
+          </a:prstGeom>
+          <a:noFill/>
+        </p:spPr>
+        <p:txBody>
+          <a:bodyPr wrap="none">
+            <a:spAutoFit/>
+          </a:bodyPr>
+          <a:lstStyle/>
+          <a:p>
+            <a:pPr algn="l"/>
+            <a:r>
+              <a:rPr sz="1300" b="1" i="0">
+                <a:solidFill>
+                  <a:srgbClr val="4E79A7"/>
+                </a:solidFill>
+                <a:latin typeface="Calibri"/>
+              </a:rPr>
+              <a:t>THE PROBLEM</a:t>
+            </a:r>
+          </a:p>
+          <a:p>
+            <a:pPr algn="l"/>
+            <a:r>
+              <a:rPr sz="3200" b="1" i="0">
+                <a:solidFill>
+                  <a:srgbClr val="1F2A37"/>
+                </a:solidFill>
+                <a:latin typeface="Calibri"/>
+              </a:rPr>
+              <a:t>Why synthetic data?</a:t>
+            </a:r>
+          </a:p>
+        </p:txBody>
+      </p:sp>
+      <p:sp>
+        <p:nvSpPr>
+          <p:cNvPr id="4" name="TextBox 3"/>
+          <p:cNvSpPr txBox="1"/>
+          <p:nvPr/>
+        </p:nvSpPr>
+        <p:spPr>
+          <a:xfrm>
+            <a:off x="777240" y="1737360"/>
+            <a:ext cx="10607040" cy="4572000"/>
+          </a:xfrm>
+          <a:prstGeom prst="rect">
+            <a:avLst/>
+          </a:prstGeom>
+          <a:noFill/>
+        </p:spPr>
+        <p:txBody>
+          <a:bodyPr wrap="square">
+            <a:spAutoFit/>
+          </a:bodyPr>
+          <a:lstStyle/>
+          <a:p>
+            <a:pPr algn="l">
+              <a:spcAft>
+                <a:spcPts val="1200"/>
+              </a:spcAft>
+            </a:pPr>
+            <a:r>
+              <a:rPr sz="1800" b="0" i="0">
+                <a:solidFill>
+                  <a:srgbClr val="1F2A37"/>
+                </a:solidFill>
+                <a:latin typeface="Calibri"/>
+              </a:rPr>
+              <a:t>•  Real customer + transaction data is sensitive, regulated, and scarce.</a:t>
+            </a:r>
+          </a:p>
+          <a:p>
+            <a:pPr algn="l">
+              <a:spcAft>
+                <a:spcPts val="1200"/>
+              </a:spcAft>
+            </a:pPr>
+            <a:r>
+              <a:rPr sz="1800" b="0" i="0">
+                <a:solidFill>
+                  <a:srgbClr val="1F2A37"/>
+                </a:solidFill>
+                <a:latin typeface="Calibri"/>
+              </a:rPr>
+              <a:t>•  Teams still need realistic data to build &amp; test models, demos, and pipelines.</a:t>
+            </a:r>
+          </a:p>
+          <a:p>
+            <a:pPr algn="l">
+              <a:spcAft>
+                <a:spcPts val="1200"/>
+              </a:spcAft>
+            </a:pPr>
+            <a:r>
+              <a:rPr sz="1800" b="1" i="0">
+                <a:solidFill>
+                  <a:srgbClr val="1F2A37"/>
+                </a:solidFill>
+                <a:latin typeface="Calibri"/>
+              </a:rPr>
+              <a:t>•  Naïve synthesis preserves single-column shapes but breaks what matters:</a:t>
+            </a:r>
+          </a:p>
+          <a:p>
+            <a:pPr algn="l" lvl="1">
+              <a:spcAft>
+                <a:spcPts val="1200"/>
+              </a:spcAft>
+            </a:pPr>
+            <a:r>
+              <a:rPr sz="1600" b="0" i="0">
+                <a:solidFill>
+                  <a:srgbClr val="5B6670"/>
+                </a:solidFill>
+                <a:latin typeface="Calibri"/>
+              </a:rPr>
+              <a:t>–  cross-table correlations — does income still predict the products bought?</a:t>
+            </a:r>
+          </a:p>
+          <a:p>
+            <a:pPr algn="l" lvl="1">
+              <a:spcAft>
+                <a:spcPts val="1200"/>
+              </a:spcAft>
+            </a:pPr>
+            <a:r>
+              <a:rPr sz="1600" b="0" i="0">
+                <a:solidFill>
+                  <a:srgbClr val="5B6670"/>
+                </a:solidFill>
+                <a:latin typeface="Calibri"/>
+              </a:rPr>
+              <a:t>–  business rules — a product's category, a valid credit score, whole-number counts.</a:t>
+            </a:r>
+          </a:p>
+          <a:p>
+            <a:pPr algn="l">
+              <a:spcAft>
+                <a:spcPts val="1200"/>
+              </a:spcAft>
+            </a:pPr>
+            <a:r>
+              <a:rPr sz="1800" b="0" i="0">
+                <a:solidFill>
+                  <a:srgbClr val="1F2A37"/>
+                </a:solidFill>
+                <a:latin typeface="Calibri"/>
+              </a:rPr>
+              <a:t>•  Goal: data that is statistically faithful AND provably valid — then prove it's useful.</a:t>
+            </a:r>
+          </a:p>
+        </p:txBody>
+      </p:sp>
+    </p:spTree>
+  </p:cSld>
+  <p:clrMapOvr>
+    <a:masterClrMapping/>
+  </p:clrMapOvr>
+</p:sld>
+</file>
+
+<file path=ppt/slides/slide20.xml><?xml version="1.0" encoding="utf-8"?>
+<p:sld xmlns:a="http://schemas.openxmlformats.org/drawingml/2006/main" xmlns:p="http://schemas.openxmlformats.org/presentationml/2006/main" xmlns:r="http://schemas.openxmlformats.org/officeDocument/2006/relationships">
+  <p:cSld>
+    <p:bg>
+      <p:bgPr>
+        <a:solidFill>
+          <a:srgbClr val="FFFFFF"/>
+        </a:solidFill>
+        <a:effectLst/>
+      </p:bgPr>
+    </p:bg>
+    <p:spTree>
+      <p:nvGrpSpPr>
+        <p:cNvPr id="1" name=""/>
+        <p:cNvGrpSpPr/>
+        <p:nvPr/>
+      </p:nvGrpSpPr>
+      <p:grpSpPr/>
+      <p:sp>
+        <p:nvSpPr>
+          <p:cNvPr id="2" name="Rectangle 1"/>
+          <p:cNvSpPr/>
+          <p:nvPr/>
+        </p:nvSpPr>
+        <p:spPr>
+          <a:xfrm>
+            <a:off x="0" y="0"/>
+            <a:ext cx="201168" cy="6858000"/>
+          </a:xfrm>
+          <a:prstGeom prst="rect">
+            <a:avLst/>
+          </a:prstGeom>
+          <a:solidFill>
             <a:srgbClr val="4E79A7"/>
           </a:solidFill>
           <a:ln>
@@ -7017,7 +7543,7 @@
 </p:sld>
 </file>
 
-<file path=ppt/slides/slide2.xml><?xml version="1.0" encoding="utf-8"?>
+<file path=ppt/slides/slide21.xml><?xml version="1.0" encoding="utf-8"?>
 <p:sld xmlns:a="http://schemas.openxmlformats.org/drawingml/2006/main" xmlns:p="http://schemas.openxmlformats.org/presentationml/2006/main" xmlns:r="http://schemas.openxmlformats.org/officeDocument/2006/relationships">
   <p:cSld>
     <p:bg>
@@ -7108,7 +7634,7 @@
                 </a:solidFill>
                 <a:latin typeface="Calibri"/>
               </a:rPr>
-              <a:t>THE PROBLEM</a:t>
+              <a:t>VERDICT</a:t>
             </a:r>
           </a:p>
           <a:p>
@@ -7120,21 +7646,1519 @@
                 </a:solidFill>
                 <a:latin typeface="Calibri"/>
               </a:rPr>
-              <a:t>Why synthetic data?</a:t>
-            </a:r>
-          </a:p>
-        </p:txBody>
-      </p:sp>
-      <p:sp>
-        <p:nvSpPr>
-          <p:cNvPr id="4" name="TextBox 3"/>
+              <a:t>Results at 2,000 seeds · ~12 txns — SDV vs DP</a:t>
+            </a:r>
+          </a:p>
+        </p:txBody>
+      </p:sp>
+      <p:graphicFrame>
+        <p:nvGraphicFramePr>
+          <p:cNvPr id="4" name="Table 3"/>
+          <p:cNvGraphicFramePr>
+            <a:graphicFrameLocks noGrp="1"/>
+          </p:cNvGraphicFramePr>
+          <p:nvPr/>
+        </p:nvGraphicFramePr>
+        <p:xfrm>
+          <a:off x="640080" y="1737360"/>
+          <a:ext cx="8412480" cy="3840480"/>
+        </p:xfrm>
+        <a:graphic>
+          <a:graphicData uri="http://schemas.openxmlformats.org/drawingml/2006/table">
+            <a:tbl>
+              <a:tblPr firstRow="1" bandRow="1">
+                <a:tableStyleId>{5C22544A-7EE6-4342-B048-85BDC9FD1C3A}</a:tableStyleId>
+              </a:tblPr>
+              <a:tblGrid>
+                <a:gridCol w="2286000"/>
+                <a:gridCol w="868680"/>
+                <a:gridCol w="868680"/>
+                <a:gridCol w="868680"/>
+                <a:gridCol w="868680"/>
+                <a:gridCol w="868680"/>
+                <a:gridCol w="1783080"/>
+              </a:tblGrid>
+              <a:tr h="426720">
+                <a:tc>
+                  <a:txBody>
+                    <a:bodyPr/>
+                    <a:lstStyle/>
+                    <a:p>
+                      <a:pPr algn="l"/>
+                      <a:r>
+                        <a:rPr sz="1200" b="1" i="0">
+                          <a:solidFill>
+                            <a:srgbClr val="FFFFFF"/>
+                          </a:solidFill>
+                          <a:latin typeface="Calibri"/>
+                        </a:rPr>
+                        <a:t>Metric</a:t>
+                      </a:r>
+                    </a:p>
+                  </a:txBody>
+                  <a:tcPr marT="25400" marB="25400" marL="76200" marR="76200" anchor="ctr">
+                    <a:solidFill>
+                      <a:srgbClr val="4E79A7"/>
+                    </a:solidFill>
+                  </a:tcPr>
+                </a:tc>
+                <a:tc>
+                  <a:txBody>
+                    <a:bodyPr/>
+                    <a:lstStyle/>
+                    <a:p>
+                      <a:pPr algn="ctr"/>
+                      <a:r>
+                        <a:rPr sz="1200" b="1" i="0">
+                          <a:solidFill>
+                            <a:srgbClr val="FFFFFF"/>
+                          </a:solidFill>
+                          <a:latin typeface="Calibri"/>
+                        </a:rPr>
+                        <a:t>M1</a:t>
+                      </a:r>
+                    </a:p>
+                  </a:txBody>
+                  <a:tcPr marT="25400" marB="25400" marL="76200" marR="76200" anchor="ctr">
+                    <a:solidFill>
+                      <a:srgbClr val="4E79A7"/>
+                    </a:solidFill>
+                  </a:tcPr>
+                </a:tc>
+                <a:tc>
+                  <a:txBody>
+                    <a:bodyPr/>
+                    <a:lstStyle/>
+                    <a:p>
+                      <a:pPr algn="ctr"/>
+                      <a:r>
+                        <a:rPr sz="1200" b="1" i="0">
+                          <a:solidFill>
+                            <a:srgbClr val="FFFFFF"/>
+                          </a:solidFill>
+                          <a:latin typeface="Calibri"/>
+                        </a:rPr>
+                        <a:t>M2</a:t>
+                      </a:r>
+                    </a:p>
+                  </a:txBody>
+                  <a:tcPr marT="25400" marB="25400" marL="76200" marR="76200" anchor="ctr">
+                    <a:solidFill>
+                      <a:srgbClr val="4E79A7"/>
+                    </a:solidFill>
+                  </a:tcPr>
+                </a:tc>
+                <a:tc>
+                  <a:txBody>
+                    <a:bodyPr/>
+                    <a:lstStyle/>
+                    <a:p>
+                      <a:pPr algn="ctr"/>
+                      <a:r>
+                        <a:rPr sz="1200" b="1" i="0">
+                          <a:solidFill>
+                            <a:srgbClr val="FFFFFF"/>
+                          </a:solidFill>
+                          <a:latin typeface="Calibri"/>
+                        </a:rPr>
+                        <a:t>M3</a:t>
+                      </a:r>
+                    </a:p>
+                  </a:txBody>
+                  <a:tcPr marT="25400" marB="25400" marL="76200" marR="76200" anchor="ctr">
+                    <a:solidFill>
+                      <a:srgbClr val="4E79A7"/>
+                    </a:solidFill>
+                  </a:tcPr>
+                </a:tc>
+                <a:tc>
+                  <a:txBody>
+                    <a:bodyPr/>
+                    <a:lstStyle/>
+                    <a:p>
+                      <a:pPr algn="ctr"/>
+                      <a:r>
+                        <a:rPr sz="1200" b="1" i="0">
+                          <a:solidFill>
+                            <a:srgbClr val="FFFFFF"/>
+                          </a:solidFill>
+                          <a:latin typeface="Calibri"/>
+                        </a:rPr>
+                        <a:t>M4</a:t>
+                      </a:r>
+                    </a:p>
+                  </a:txBody>
+                  <a:tcPr marT="25400" marB="25400" marL="76200" marR="76200" anchor="ctr">
+                    <a:solidFill>
+                      <a:srgbClr val="4E79A7"/>
+                    </a:solidFill>
+                  </a:tcPr>
+                </a:tc>
+                <a:tc>
+                  <a:txBody>
+                    <a:bodyPr/>
+                    <a:lstStyle/>
+                    <a:p>
+                      <a:pPr algn="ctr"/>
+                      <a:r>
+                        <a:rPr sz="1200" b="1" i="0">
+                          <a:solidFill>
+                            <a:srgbClr val="FFFFFF"/>
+                          </a:solidFill>
+                          <a:latin typeface="Calibri"/>
+                        </a:rPr>
+                        <a:t>M5</a:t>
+                      </a:r>
+                    </a:p>
+                  </a:txBody>
+                  <a:tcPr marT="25400" marB="25400" marL="76200" marR="76200" anchor="ctr">
+                    <a:solidFill>
+                      <a:srgbClr val="4E79A7"/>
+                    </a:solidFill>
+                  </a:tcPr>
+                </a:tc>
+                <a:tc>
+                  <a:txBody>
+                    <a:bodyPr/>
+                    <a:lstStyle/>
+                    <a:p>
+                      <a:pPr algn="ctr"/>
+                      <a:r>
+                        <a:rPr sz="1200" b="1" i="0">
+                          <a:solidFill>
+                            <a:srgbClr val="FFFFFF"/>
+                          </a:solidFill>
+                          <a:latin typeface="Calibri"/>
+                        </a:rPr>
+                        <a:t>Winner</a:t>
+                      </a:r>
+                    </a:p>
+                  </a:txBody>
+                  <a:tcPr marT="25400" marB="25400" marL="76200" marR="76200" anchor="ctr">
+                    <a:solidFill>
+                      <a:srgbClr val="4E79A7"/>
+                    </a:solidFill>
+                  </a:tcPr>
+                </a:tc>
+              </a:tr>
+              <a:tr h="426720">
+                <a:tc>
+                  <a:txBody>
+                    <a:bodyPr/>
+                    <a:lstStyle/>
+                    <a:p>
+                      <a:pPr algn="l"/>
+                      <a:r>
+                        <a:rPr sz="1200" b="1" i="0">
+                          <a:solidFill>
+                            <a:srgbClr val="1F2A37"/>
+                          </a:solidFill>
+                          <a:latin typeface="Calibri"/>
+                        </a:rPr>
+                        <a:t>Overall quality</a:t>
+                      </a:r>
+                    </a:p>
+                  </a:txBody>
+                  <a:tcPr marT="25400" marB="25400" marL="76200" marR="76200" anchor="ctr">
+                    <a:solidFill>
+                      <a:srgbClr val="FFFFFF"/>
+                    </a:solidFill>
+                  </a:tcPr>
+                </a:tc>
+                <a:tc>
+                  <a:txBody>
+                    <a:bodyPr/>
+                    <a:lstStyle/>
+                    <a:p>
+                      <a:pPr algn="ctr"/>
+                      <a:r>
+                        <a:rPr sz="1200" b="0" i="0">
+                          <a:solidFill>
+                            <a:srgbClr val="1F2A37"/>
+                          </a:solidFill>
+                          <a:latin typeface="Calibri"/>
+                        </a:rPr>
+                        <a:t>0.888</a:t>
+                      </a:r>
+                    </a:p>
+                  </a:txBody>
+                  <a:tcPr marT="25400" marB="25400" marL="76200" marR="76200" anchor="ctr">
+                    <a:solidFill>
+                      <a:srgbClr val="FFFFFF"/>
+                    </a:solidFill>
+                  </a:tcPr>
+                </a:tc>
+                <a:tc>
+                  <a:txBody>
+                    <a:bodyPr/>
+                    <a:lstStyle/>
+                    <a:p>
+                      <a:pPr algn="ctr"/>
+                      <a:r>
+                        <a:rPr sz="1200" b="0" i="0">
+                          <a:solidFill>
+                            <a:srgbClr val="1F2A37"/>
+                          </a:solidFill>
+                          <a:latin typeface="Calibri"/>
+                        </a:rPr>
+                        <a:t>0.854</a:t>
+                      </a:r>
+                    </a:p>
+                  </a:txBody>
+                  <a:tcPr marT="25400" marB="25400" marL="76200" marR="76200" anchor="ctr">
+                    <a:solidFill>
+                      <a:srgbClr val="FFFFFF"/>
+                    </a:solidFill>
+                  </a:tcPr>
+                </a:tc>
+                <a:tc>
+                  <a:txBody>
+                    <a:bodyPr/>
+                    <a:lstStyle/>
+                    <a:p>
+                      <a:pPr algn="ctr"/>
+                      <a:r>
+                        <a:rPr sz="1200" b="0" i="0">
+                          <a:solidFill>
+                            <a:srgbClr val="1F2A37"/>
+                          </a:solidFill>
+                          <a:latin typeface="Calibri"/>
+                        </a:rPr>
+                        <a:t>0.647</a:t>
+                      </a:r>
+                    </a:p>
+                  </a:txBody>
+                  <a:tcPr marT="25400" marB="25400" marL="76200" marR="76200" anchor="ctr">
+                    <a:solidFill>
+                      <a:srgbClr val="FFFFFF"/>
+                    </a:solidFill>
+                  </a:tcPr>
+                </a:tc>
+                <a:tc>
+                  <a:txBody>
+                    <a:bodyPr/>
+                    <a:lstStyle/>
+                    <a:p>
+                      <a:pPr algn="ctr"/>
+                      <a:r>
+                        <a:rPr sz="1200" b="0" i="0">
+                          <a:solidFill>
+                            <a:srgbClr val="1F2A37"/>
+                          </a:solidFill>
+                          <a:latin typeface="Calibri"/>
+                        </a:rPr>
+                        <a:t>0.887</a:t>
+                      </a:r>
+                    </a:p>
+                  </a:txBody>
+                  <a:tcPr marT="25400" marB="25400" marL="76200" marR="76200" anchor="ctr">
+                    <a:solidFill>
+                      <a:srgbClr val="FFFFFF"/>
+                    </a:solidFill>
+                  </a:tcPr>
+                </a:tc>
+                <a:tc>
+                  <a:txBody>
+                    <a:bodyPr/>
+                    <a:lstStyle/>
+                    <a:p>
+                      <a:pPr algn="ctr"/>
+                      <a:r>
+                        <a:rPr sz="1200" b="0" i="0">
+                          <a:solidFill>
+                            <a:srgbClr val="1F2A37"/>
+                          </a:solidFill>
+                          <a:latin typeface="Calibri"/>
+                        </a:rPr>
+                        <a:t>0.861</a:t>
+                      </a:r>
+                    </a:p>
+                  </a:txBody>
+                  <a:tcPr marT="25400" marB="25400" marL="76200" marR="76200" anchor="ctr">
+                    <a:solidFill>
+                      <a:srgbClr val="FFFFFF"/>
+                    </a:solidFill>
+                  </a:tcPr>
+                </a:tc>
+                <a:tc>
+                  <a:txBody>
+                    <a:bodyPr/>
+                    <a:lstStyle/>
+                    <a:p>
+                      <a:pPr algn="ctr"/>
+                      <a:r>
+                        <a:rPr sz="1200" b="0" i="0">
+                          <a:solidFill>
+                            <a:srgbClr val="1F2A37"/>
+                          </a:solidFill>
+                          <a:latin typeface="Calibri"/>
+                        </a:rPr>
+                        <a:t>M1≈M4</a:t>
+                      </a:r>
+                    </a:p>
+                  </a:txBody>
+                  <a:tcPr marT="25400" marB="25400" marL="76200" marR="76200" anchor="ctr">
+                    <a:solidFill>
+                      <a:srgbClr val="FFFFFF"/>
+                    </a:solidFill>
+                  </a:tcPr>
+                </a:tc>
+              </a:tr>
+              <a:tr h="426720">
+                <a:tc>
+                  <a:txBody>
+                    <a:bodyPr/>
+                    <a:lstStyle/>
+                    <a:p>
+                      <a:pPr algn="l"/>
+                      <a:r>
+                        <a:rPr sz="1200" b="1" i="0">
+                          <a:solidFill>
+                            <a:srgbClr val="1F2A37"/>
+                          </a:solidFill>
+                          <a:latin typeface="Calibri"/>
+                        </a:rPr>
+                        <a:t>Diagnostic / FK</a:t>
+                      </a:r>
+                    </a:p>
+                  </a:txBody>
+                  <a:tcPr marT="25400" marB="25400" marL="76200" marR="76200" anchor="ctr">
+                    <a:solidFill>
+                      <a:srgbClr val="F3F5F7"/>
+                    </a:solidFill>
+                  </a:tcPr>
+                </a:tc>
+                <a:tc>
+                  <a:txBody>
+                    <a:bodyPr/>
+                    <a:lstStyle/>
+                    <a:p>
+                      <a:pPr algn="ctr"/>
+                      <a:r>
+                        <a:rPr sz="1200" b="0" i="0">
+                          <a:solidFill>
+                            <a:srgbClr val="1F2A37"/>
+                          </a:solidFill>
+                          <a:latin typeface="Calibri"/>
+                        </a:rPr>
+                        <a:t>1.000</a:t>
+                      </a:r>
+                    </a:p>
+                  </a:txBody>
+                  <a:tcPr marT="25400" marB="25400" marL="76200" marR="76200" anchor="ctr">
+                    <a:solidFill>
+                      <a:srgbClr val="F3F5F7"/>
+                    </a:solidFill>
+                  </a:tcPr>
+                </a:tc>
+                <a:tc>
+                  <a:txBody>
+                    <a:bodyPr/>
+                    <a:lstStyle/>
+                    <a:p>
+                      <a:pPr algn="ctr"/>
+                      <a:r>
+                        <a:rPr sz="1200" b="0" i="0">
+                          <a:solidFill>
+                            <a:srgbClr val="1F2A37"/>
+                          </a:solidFill>
+                          <a:latin typeface="Calibri"/>
+                        </a:rPr>
+                        <a:t>1.000</a:t>
+                      </a:r>
+                    </a:p>
+                  </a:txBody>
+                  <a:tcPr marT="25400" marB="25400" marL="76200" marR="76200" anchor="ctr">
+                    <a:solidFill>
+                      <a:srgbClr val="F3F5F7"/>
+                    </a:solidFill>
+                  </a:tcPr>
+                </a:tc>
+                <a:tc>
+                  <a:txBody>
+                    <a:bodyPr/>
+                    <a:lstStyle/>
+                    <a:p>
+                      <a:pPr algn="ctr"/>
+                      <a:r>
+                        <a:rPr sz="1200" b="0" i="0">
+                          <a:solidFill>
+                            <a:srgbClr val="1F2A37"/>
+                          </a:solidFill>
+                          <a:latin typeface="Calibri"/>
+                        </a:rPr>
+                        <a:t>0.744</a:t>
+                      </a:r>
+                    </a:p>
+                  </a:txBody>
+                  <a:tcPr marT="25400" marB="25400" marL="76200" marR="76200" anchor="ctr">
+                    <a:solidFill>
+                      <a:srgbClr val="F3F5F7"/>
+                    </a:solidFill>
+                  </a:tcPr>
+                </a:tc>
+                <a:tc>
+                  <a:txBody>
+                    <a:bodyPr/>
+                    <a:lstStyle/>
+                    <a:p>
+                      <a:pPr algn="ctr"/>
+                      <a:r>
+                        <a:rPr sz="1200" b="0" i="0">
+                          <a:solidFill>
+                            <a:srgbClr val="1F2A37"/>
+                          </a:solidFill>
+                          <a:latin typeface="Calibri"/>
+                        </a:rPr>
+                        <a:t>1.000</a:t>
+                      </a:r>
+                    </a:p>
+                  </a:txBody>
+                  <a:tcPr marT="25400" marB="25400" marL="76200" marR="76200" anchor="ctr">
+                    <a:solidFill>
+                      <a:srgbClr val="F3F5F7"/>
+                    </a:solidFill>
+                  </a:tcPr>
+                </a:tc>
+                <a:tc>
+                  <a:txBody>
+                    <a:bodyPr/>
+                    <a:lstStyle/>
+                    <a:p>
+                      <a:pPr algn="ctr"/>
+                      <a:r>
+                        <a:rPr sz="1200" b="0" i="0">
+                          <a:solidFill>
+                            <a:srgbClr val="1F2A37"/>
+                          </a:solidFill>
+                          <a:latin typeface="Calibri"/>
+                        </a:rPr>
+                        <a:t>1.000</a:t>
+                      </a:r>
+                    </a:p>
+                  </a:txBody>
+                  <a:tcPr marT="25400" marB="25400" marL="76200" marR="76200" anchor="ctr">
+                    <a:solidFill>
+                      <a:srgbClr val="F3F5F7"/>
+                    </a:solidFill>
+                  </a:tcPr>
+                </a:tc>
+                <a:tc>
+                  <a:txBody>
+                    <a:bodyPr/>
+                    <a:lstStyle/>
+                    <a:p>
+                      <a:pPr algn="ctr"/>
+                      <a:r>
+                        <a:rPr sz="1200" b="0" i="0">
+                          <a:solidFill>
+                            <a:srgbClr val="1F2A37"/>
+                          </a:solidFill>
+                          <a:latin typeface="Calibri"/>
+                        </a:rPr>
+                        <a:t>tie</a:t>
+                      </a:r>
+                    </a:p>
+                  </a:txBody>
+                  <a:tcPr marT="25400" marB="25400" marL="76200" marR="76200" anchor="ctr">
+                    <a:solidFill>
+                      <a:srgbClr val="F3F5F7"/>
+                    </a:solidFill>
+                  </a:tcPr>
+                </a:tc>
+              </a:tr>
+              <a:tr h="426720">
+                <a:tc>
+                  <a:txBody>
+                    <a:bodyPr/>
+                    <a:lstStyle/>
+                    <a:p>
+                      <a:pPr algn="l"/>
+                      <a:r>
+                        <a:rPr sz="1200" b="1" i="0">
+                          <a:solidFill>
+                            <a:srgbClr val="1F2A37"/>
+                          </a:solidFill>
+                          <a:latin typeface="Calibri"/>
+                        </a:rPr>
+                        <a:t>Cust. pair trends</a:t>
+                      </a:r>
+                    </a:p>
+                  </a:txBody>
+                  <a:tcPr marT="25400" marB="25400" marL="76200" marR="76200" anchor="ctr">
+                    <a:solidFill>
+                      <a:srgbClr val="FFFFFF"/>
+                    </a:solidFill>
+                  </a:tcPr>
+                </a:tc>
+                <a:tc>
+                  <a:txBody>
+                    <a:bodyPr/>
+                    <a:lstStyle/>
+                    <a:p>
+                      <a:pPr algn="ctr"/>
+                      <a:r>
+                        <a:rPr sz="1200" b="0" i="0">
+                          <a:solidFill>
+                            <a:srgbClr val="1F2A37"/>
+                          </a:solidFill>
+                          <a:latin typeface="Calibri"/>
+                        </a:rPr>
+                        <a:t>0.737</a:t>
+                      </a:r>
+                    </a:p>
+                  </a:txBody>
+                  <a:tcPr marT="25400" marB="25400" marL="76200" marR="76200" anchor="ctr">
+                    <a:solidFill>
+                      <a:srgbClr val="FFFFFF"/>
+                    </a:solidFill>
+                  </a:tcPr>
+                </a:tc>
+                <a:tc>
+                  <a:txBody>
+                    <a:bodyPr/>
+                    <a:lstStyle/>
+                    <a:p>
+                      <a:pPr algn="ctr"/>
+                      <a:r>
+                        <a:rPr sz="1200" b="0" i="0">
+                          <a:solidFill>
+                            <a:srgbClr val="1F2A37"/>
+                          </a:solidFill>
+                          <a:latin typeface="Calibri"/>
+                        </a:rPr>
+                        <a:t>0.567</a:t>
+                      </a:r>
+                    </a:p>
+                  </a:txBody>
+                  <a:tcPr marT="25400" marB="25400" marL="76200" marR="76200" anchor="ctr">
+                    <a:solidFill>
+                      <a:srgbClr val="FFFFFF"/>
+                    </a:solidFill>
+                  </a:tcPr>
+                </a:tc>
+                <a:tc>
+                  <a:txBody>
+                    <a:bodyPr/>
+                    <a:lstStyle/>
+                    <a:p>
+                      <a:pPr algn="ctr"/>
+                      <a:r>
+                        <a:rPr sz="1200" b="0" i="0">
+                          <a:solidFill>
+                            <a:srgbClr val="1F2A37"/>
+                          </a:solidFill>
+                          <a:latin typeface="Calibri"/>
+                        </a:rPr>
+                        <a:t>0.547</a:t>
+                      </a:r>
+                    </a:p>
+                  </a:txBody>
+                  <a:tcPr marT="25400" marB="25400" marL="76200" marR="76200" anchor="ctr">
+                    <a:solidFill>
+                      <a:srgbClr val="FFFFFF"/>
+                    </a:solidFill>
+                  </a:tcPr>
+                </a:tc>
+                <a:tc>
+                  <a:txBody>
+                    <a:bodyPr/>
+                    <a:lstStyle/>
+                    <a:p>
+                      <a:pPr algn="ctr"/>
+                      <a:r>
+                        <a:rPr sz="1200" b="0" i="0">
+                          <a:solidFill>
+                            <a:srgbClr val="1F2A37"/>
+                          </a:solidFill>
+                          <a:latin typeface="Calibri"/>
+                        </a:rPr>
+                        <a:t>0.780</a:t>
+                      </a:r>
+                    </a:p>
+                  </a:txBody>
+                  <a:tcPr marT="25400" marB="25400" marL="76200" marR="76200" anchor="ctr">
+                    <a:solidFill>
+                      <a:srgbClr val="FFFFFF"/>
+                    </a:solidFill>
+                  </a:tcPr>
+                </a:tc>
+                <a:tc>
+                  <a:txBody>
+                    <a:bodyPr/>
+                    <a:lstStyle/>
+                    <a:p>
+                      <a:pPr algn="ctr"/>
+                      <a:r>
+                        <a:rPr sz="1200" b="0" i="0">
+                          <a:solidFill>
+                            <a:srgbClr val="1F2A37"/>
+                          </a:solidFill>
+                          <a:latin typeface="Calibri"/>
+                        </a:rPr>
+                        <a:t>0.850</a:t>
+                      </a:r>
+                    </a:p>
+                  </a:txBody>
+                  <a:tcPr marT="25400" marB="25400" marL="76200" marR="76200" anchor="ctr">
+                    <a:solidFill>
+                      <a:srgbClr val="FFFFFF"/>
+                    </a:solidFill>
+                  </a:tcPr>
+                </a:tc>
+                <a:tc>
+                  <a:txBody>
+                    <a:bodyPr/>
+                    <a:lstStyle/>
+                    <a:p>
+                      <a:pPr algn="ctr"/>
+                      <a:r>
+                        <a:rPr sz="1200" b="0" i="0">
+                          <a:solidFill>
+                            <a:srgbClr val="1F2A37"/>
+                          </a:solidFill>
+                          <a:latin typeface="Calibri"/>
+                        </a:rPr>
+                        <a:t>M5</a:t>
+                      </a:r>
+                    </a:p>
+                  </a:txBody>
+                  <a:tcPr marT="25400" marB="25400" marL="76200" marR="76200" anchor="ctr">
+                    <a:solidFill>
+                      <a:srgbClr val="FFFFFF"/>
+                    </a:solidFill>
+                  </a:tcPr>
+                </a:tc>
+              </a:tr>
+              <a:tr h="426720">
+                <a:tc>
+                  <a:txBody>
+                    <a:bodyPr/>
+                    <a:lstStyle/>
+                    <a:p>
+                      <a:pPr algn="l"/>
+                      <a:r>
+                        <a:rPr sz="1200" b="1" i="0">
+                          <a:solidFill>
+                            <a:srgbClr val="1F2A37"/>
+                          </a:solidFill>
+                          <a:latin typeface="Calibri"/>
+                        </a:rPr>
+                        <a:t>Txn. column shapes</a:t>
+                      </a:r>
+                    </a:p>
+                  </a:txBody>
+                  <a:tcPr marT="25400" marB="25400" marL="76200" marR="76200" anchor="ctr">
+                    <a:solidFill>
+                      <a:srgbClr val="F3F5F7"/>
+                    </a:solidFill>
+                  </a:tcPr>
+                </a:tc>
+                <a:tc>
+                  <a:txBody>
+                    <a:bodyPr/>
+                    <a:lstStyle/>
+                    <a:p>
+                      <a:pPr algn="ctr"/>
+                      <a:r>
+                        <a:rPr sz="1200" b="0" i="0">
+                          <a:solidFill>
+                            <a:srgbClr val="1F2A37"/>
+                          </a:solidFill>
+                          <a:latin typeface="Calibri"/>
+                        </a:rPr>
+                        <a:t>0.865</a:t>
+                      </a:r>
+                    </a:p>
+                  </a:txBody>
+                  <a:tcPr marT="25400" marB="25400" marL="76200" marR="76200" anchor="ctr">
+                    <a:solidFill>
+                      <a:srgbClr val="F3F5F7"/>
+                    </a:solidFill>
+                  </a:tcPr>
+                </a:tc>
+                <a:tc>
+                  <a:txBody>
+                    <a:bodyPr/>
+                    <a:lstStyle/>
+                    <a:p>
+                      <a:pPr algn="ctr"/>
+                      <a:r>
+                        <a:rPr sz="1200" b="0" i="0">
+                          <a:solidFill>
+                            <a:srgbClr val="1F2A37"/>
+                          </a:solidFill>
+                          <a:latin typeface="Calibri"/>
+                        </a:rPr>
+                        <a:t>0.908</a:t>
+                      </a:r>
+                    </a:p>
+                  </a:txBody>
+                  <a:tcPr marT="25400" marB="25400" marL="76200" marR="76200" anchor="ctr">
+                    <a:solidFill>
+                      <a:srgbClr val="F3F5F7"/>
+                    </a:solidFill>
+                  </a:tcPr>
+                </a:tc>
+                <a:tc>
+                  <a:txBody>
+                    <a:bodyPr/>
+                    <a:lstStyle/>
+                    <a:p>
+                      <a:pPr algn="ctr"/>
+                      <a:r>
+                        <a:rPr sz="1200" b="0" i="0">
+                          <a:solidFill>
+                            <a:srgbClr val="1F2A37"/>
+                          </a:solidFill>
+                          <a:latin typeface="Calibri"/>
+                        </a:rPr>
+                        <a:t>0.783</a:t>
+                      </a:r>
+                    </a:p>
+                  </a:txBody>
+                  <a:tcPr marT="25400" marB="25400" marL="76200" marR="76200" anchor="ctr">
+                    <a:solidFill>
+                      <a:srgbClr val="F3F5F7"/>
+                    </a:solidFill>
+                  </a:tcPr>
+                </a:tc>
+                <a:tc>
+                  <a:txBody>
+                    <a:bodyPr/>
+                    <a:lstStyle/>
+                    <a:p>
+                      <a:pPr algn="ctr"/>
+                      <a:r>
+                        <a:rPr sz="1200" b="0" i="0">
+                          <a:solidFill>
+                            <a:srgbClr val="1F2A37"/>
+                          </a:solidFill>
+                          <a:latin typeface="Calibri"/>
+                        </a:rPr>
+                        <a:t>0.826</a:t>
+                      </a:r>
+                    </a:p>
+                  </a:txBody>
+                  <a:tcPr marT="25400" marB="25400" marL="76200" marR="76200" anchor="ctr">
+                    <a:solidFill>
+                      <a:srgbClr val="F3F5F7"/>
+                    </a:solidFill>
+                  </a:tcPr>
+                </a:tc>
+                <a:tc>
+                  <a:txBody>
+                    <a:bodyPr/>
+                    <a:lstStyle/>
+                    <a:p>
+                      <a:pPr algn="ctr"/>
+                      <a:r>
+                        <a:rPr sz="1200" b="0" i="0">
+                          <a:solidFill>
+                            <a:srgbClr val="1F2A37"/>
+                          </a:solidFill>
+                          <a:latin typeface="Calibri"/>
+                        </a:rPr>
+                        <a:t>0.856</a:t>
+                      </a:r>
+                    </a:p>
+                  </a:txBody>
+                  <a:tcPr marT="25400" marB="25400" marL="76200" marR="76200" anchor="ctr">
+                    <a:solidFill>
+                      <a:srgbClr val="F3F5F7"/>
+                    </a:solidFill>
+                  </a:tcPr>
+                </a:tc>
+                <a:tc>
+                  <a:txBody>
+                    <a:bodyPr/>
+                    <a:lstStyle/>
+                    <a:p>
+                      <a:pPr algn="ctr"/>
+                      <a:r>
+                        <a:rPr sz="1200" b="0" i="0">
+                          <a:solidFill>
+                            <a:srgbClr val="1F2A37"/>
+                          </a:solidFill>
+                          <a:latin typeface="Calibri"/>
+                        </a:rPr>
+                        <a:t>M2</a:t>
+                      </a:r>
+                    </a:p>
+                  </a:txBody>
+                  <a:tcPr marT="25400" marB="25400" marL="76200" marR="76200" anchor="ctr">
+                    <a:solidFill>
+                      <a:srgbClr val="F3F5F7"/>
+                    </a:solidFill>
+                  </a:tcPr>
+                </a:tc>
+              </a:tr>
+              <a:tr h="426720">
+                <a:tc>
+                  <a:txBody>
+                    <a:bodyPr/>
+                    <a:lstStyle/>
+                    <a:p>
+                      <a:pPr algn="l"/>
+                      <a:r>
+                        <a:rPr sz="1200" b="1" i="0">
+                          <a:solidFill>
+                            <a:srgbClr val="1F2A37"/>
+                          </a:solidFill>
+                          <a:latin typeface="Calibri"/>
+                        </a:rPr>
+                        <a:t>Cross-table MAD ↓</a:t>
+                      </a:r>
+                    </a:p>
+                  </a:txBody>
+                  <a:tcPr marT="25400" marB="25400" marL="76200" marR="76200" anchor="ctr">
+                    <a:solidFill>
+                      <a:srgbClr val="FFFFFF"/>
+                    </a:solidFill>
+                  </a:tcPr>
+                </a:tc>
+                <a:tc>
+                  <a:txBody>
+                    <a:bodyPr/>
+                    <a:lstStyle/>
+                    <a:p>
+                      <a:pPr algn="ctr"/>
+                      <a:r>
+                        <a:rPr sz="1200" b="0" i="0">
+                          <a:solidFill>
+                            <a:srgbClr val="1F2A37"/>
+                          </a:solidFill>
+                          <a:latin typeface="Calibri"/>
+                        </a:rPr>
+                        <a:t>0.379</a:t>
+                      </a:r>
+                    </a:p>
+                  </a:txBody>
+                  <a:tcPr marT="25400" marB="25400" marL="76200" marR="76200" anchor="ctr">
+                    <a:solidFill>
+                      <a:srgbClr val="FFFFFF"/>
+                    </a:solidFill>
+                  </a:tcPr>
+                </a:tc>
+                <a:tc>
+                  <a:txBody>
+                    <a:bodyPr/>
+                    <a:lstStyle/>
+                    <a:p>
+                      <a:pPr algn="ctr"/>
+                      <a:r>
+                        <a:rPr sz="1200" b="0" i="0">
+                          <a:solidFill>
+                            <a:srgbClr val="1F2A37"/>
+                          </a:solidFill>
+                          <a:latin typeface="Calibri"/>
+                        </a:rPr>
+                        <a:t>0.394</a:t>
+                      </a:r>
+                    </a:p>
+                  </a:txBody>
+                  <a:tcPr marT="25400" marB="25400" marL="76200" marR="76200" anchor="ctr">
+                    <a:solidFill>
+                      <a:srgbClr val="FFFFFF"/>
+                    </a:solidFill>
+                  </a:tcPr>
+                </a:tc>
+                <a:tc>
+                  <a:txBody>
+                    <a:bodyPr/>
+                    <a:lstStyle/>
+                    <a:p>
+                      <a:pPr algn="ctr"/>
+                      <a:r>
+                        <a:rPr sz="1200" b="0" i="0">
+                          <a:solidFill>
+                            <a:srgbClr val="1F2A37"/>
+                          </a:solidFill>
+                          <a:latin typeface="Calibri"/>
+                        </a:rPr>
+                        <a:t>0.296</a:t>
+                      </a:r>
+                    </a:p>
+                  </a:txBody>
+                  <a:tcPr marT="25400" marB="25400" marL="76200" marR="76200" anchor="ctr">
+                    <a:solidFill>
+                      <a:srgbClr val="FFFFFF"/>
+                    </a:solidFill>
+                  </a:tcPr>
+                </a:tc>
+                <a:tc>
+                  <a:txBody>
+                    <a:bodyPr/>
+                    <a:lstStyle/>
+                    <a:p>
+                      <a:pPr algn="ctr"/>
+                      <a:r>
+                        <a:rPr sz="1200" b="0" i="0">
+                          <a:solidFill>
+                            <a:srgbClr val="1F2A37"/>
+                          </a:solidFill>
+                          <a:latin typeface="Calibri"/>
+                        </a:rPr>
+                        <a:t>0.392</a:t>
+                      </a:r>
+                    </a:p>
+                  </a:txBody>
+                  <a:tcPr marT="25400" marB="25400" marL="76200" marR="76200" anchor="ctr">
+                    <a:solidFill>
+                      <a:srgbClr val="FFFFFF"/>
+                    </a:solidFill>
+                  </a:tcPr>
+                </a:tc>
+                <a:tc>
+                  <a:txBody>
+                    <a:bodyPr/>
+                    <a:lstStyle/>
+                    <a:p>
+                      <a:pPr algn="ctr"/>
+                      <a:r>
+                        <a:rPr sz="1200" b="0" i="0">
+                          <a:solidFill>
+                            <a:srgbClr val="1F2A37"/>
+                          </a:solidFill>
+                          <a:latin typeface="Calibri"/>
+                        </a:rPr>
+                        <a:t>0.387</a:t>
+                      </a:r>
+                    </a:p>
+                  </a:txBody>
+                  <a:tcPr marT="25400" marB="25400" marL="76200" marR="76200" anchor="ctr">
+                    <a:solidFill>
+                      <a:srgbClr val="FFFFFF"/>
+                    </a:solidFill>
+                  </a:tcPr>
+                </a:tc>
+                <a:tc>
+                  <a:txBody>
+                    <a:bodyPr/>
+                    <a:lstStyle/>
+                    <a:p>
+                      <a:pPr algn="ctr"/>
+                      <a:r>
+                        <a:rPr sz="1200" b="0" i="0">
+                          <a:solidFill>
+                            <a:srgbClr val="1F2A37"/>
+                          </a:solidFill>
+                          <a:latin typeface="Calibri"/>
+                        </a:rPr>
+                        <a:t>M3</a:t>
+                      </a:r>
+                    </a:p>
+                  </a:txBody>
+                  <a:tcPr marT="25400" marB="25400" marL="76200" marR="76200" anchor="ctr">
+                    <a:solidFill>
+                      <a:srgbClr val="FFFFFF"/>
+                    </a:solidFill>
+                  </a:tcPr>
+                </a:tc>
+              </a:tr>
+              <a:tr h="426720">
+                <a:tc>
+                  <a:txBody>
+                    <a:bodyPr/>
+                    <a:lstStyle/>
+                    <a:p>
+                      <a:pPr algn="l"/>
+                      <a:r>
+                        <a:rPr sz="1200" b="1" i="0">
+                          <a:solidFill>
+                            <a:srgbClr val="1F2A37"/>
+                          </a:solidFill>
+                          <a:latin typeface="Calibri"/>
+                        </a:rPr>
+                        <a:t>Autocorr MAE ↓</a:t>
+                      </a:r>
+                    </a:p>
+                  </a:txBody>
+                  <a:tcPr marT="25400" marB="25400" marL="76200" marR="76200" anchor="ctr">
+                    <a:solidFill>
+                      <a:srgbClr val="F3F5F7"/>
+                    </a:solidFill>
+                  </a:tcPr>
+                </a:tc>
+                <a:tc>
+                  <a:txBody>
+                    <a:bodyPr/>
+                    <a:lstStyle/>
+                    <a:p>
+                      <a:pPr algn="ctr"/>
+                      <a:r>
+                        <a:rPr sz="1200" b="0" i="0">
+                          <a:solidFill>
+                            <a:srgbClr val="1F2A37"/>
+                          </a:solidFill>
+                          <a:latin typeface="Calibri"/>
+                        </a:rPr>
+                        <a:t>0.079</a:t>
+                      </a:r>
+                    </a:p>
+                  </a:txBody>
+                  <a:tcPr marT="25400" marB="25400" marL="76200" marR="76200" anchor="ctr">
+                    <a:solidFill>
+                      <a:srgbClr val="F3F5F7"/>
+                    </a:solidFill>
+                  </a:tcPr>
+                </a:tc>
+                <a:tc>
+                  <a:txBody>
+                    <a:bodyPr/>
+                    <a:lstStyle/>
+                    <a:p>
+                      <a:pPr algn="ctr"/>
+                      <a:r>
+                        <a:rPr sz="1200" b="0" i="0">
+                          <a:solidFill>
+                            <a:srgbClr val="1F2A37"/>
+                          </a:solidFill>
+                          <a:latin typeface="Calibri"/>
+                        </a:rPr>
+                        <a:t>0.011</a:t>
+                      </a:r>
+                    </a:p>
+                  </a:txBody>
+                  <a:tcPr marT="25400" marB="25400" marL="76200" marR="76200" anchor="ctr">
+                    <a:solidFill>
+                      <a:srgbClr val="F3F5F7"/>
+                    </a:solidFill>
+                  </a:tcPr>
+                </a:tc>
+                <a:tc>
+                  <a:txBody>
+                    <a:bodyPr/>
+                    <a:lstStyle/>
+                    <a:p>
+                      <a:pPr algn="ctr"/>
+                      <a:r>
+                        <a:rPr sz="1200" b="0" i="0">
+                          <a:solidFill>
+                            <a:srgbClr val="1F2A37"/>
+                          </a:solidFill>
+                          <a:latin typeface="Calibri"/>
+                        </a:rPr>
+                        <a:t>0.041</a:t>
+                      </a:r>
+                    </a:p>
+                  </a:txBody>
+                  <a:tcPr marT="25400" marB="25400" marL="76200" marR="76200" anchor="ctr">
+                    <a:solidFill>
+                      <a:srgbClr val="F3F5F7"/>
+                    </a:solidFill>
+                  </a:tcPr>
+                </a:tc>
+                <a:tc>
+                  <a:txBody>
+                    <a:bodyPr/>
+                    <a:lstStyle/>
+                    <a:p>
+                      <a:pPr algn="ctr"/>
+                      <a:r>
+                        <a:rPr sz="1200" b="0" i="0">
+                          <a:solidFill>
+                            <a:srgbClr val="1F2A37"/>
+                          </a:solidFill>
+                          <a:latin typeface="Calibri"/>
+                        </a:rPr>
+                        <a:t>0.028</a:t>
+                      </a:r>
+                    </a:p>
+                  </a:txBody>
+                  <a:tcPr marT="25400" marB="25400" marL="76200" marR="76200" anchor="ctr">
+                    <a:solidFill>
+                      <a:srgbClr val="F3F5F7"/>
+                    </a:solidFill>
+                  </a:tcPr>
+                </a:tc>
+                <a:tc>
+                  <a:txBody>
+                    <a:bodyPr/>
+                    <a:lstStyle/>
+                    <a:p>
+                      <a:pPr algn="ctr"/>
+                      <a:r>
+                        <a:rPr sz="1200" b="0" i="0">
+                          <a:solidFill>
+                            <a:srgbClr val="1F2A37"/>
+                          </a:solidFill>
+                          <a:latin typeface="Calibri"/>
+                        </a:rPr>
+                        <a:t>0.569</a:t>
+                      </a:r>
+                    </a:p>
+                  </a:txBody>
+                  <a:tcPr marT="25400" marB="25400" marL="76200" marR="76200" anchor="ctr">
+                    <a:solidFill>
+                      <a:srgbClr val="F3F5F7"/>
+                    </a:solidFill>
+                  </a:tcPr>
+                </a:tc>
+                <a:tc>
+                  <a:txBody>
+                    <a:bodyPr/>
+                    <a:lstStyle/>
+                    <a:p>
+                      <a:pPr algn="ctr"/>
+                      <a:r>
+                        <a:rPr sz="1200" b="0" i="0">
+                          <a:solidFill>
+                            <a:srgbClr val="1F2A37"/>
+                          </a:solidFill>
+                          <a:latin typeface="Calibri"/>
+                        </a:rPr>
+                        <a:t>M2</a:t>
+                      </a:r>
+                    </a:p>
+                  </a:txBody>
+                  <a:tcPr marT="25400" marB="25400" marL="76200" marR="76200" anchor="ctr">
+                    <a:solidFill>
+                      <a:srgbClr val="F3F5F7"/>
+                    </a:solidFill>
+                  </a:tcPr>
+                </a:tc>
+              </a:tr>
+              <a:tr h="426720">
+                <a:tc>
+                  <a:txBody>
+                    <a:bodyPr/>
+                    <a:lstStyle/>
+                    <a:p>
+                      <a:pPr algn="l"/>
+                      <a:r>
+                        <a:rPr sz="1200" b="1" i="0">
+                          <a:solidFill>
+                            <a:srgbClr val="1F2A37"/>
+                          </a:solidFill>
+                          <a:latin typeface="Calibri"/>
+                        </a:rPr>
+                        <a:t>Diff. privacy</a:t>
+                      </a:r>
+                    </a:p>
+                  </a:txBody>
+                  <a:tcPr marT="25400" marB="25400" marL="76200" marR="76200" anchor="ctr">
+                    <a:solidFill>
+                      <a:srgbClr val="FFFFFF"/>
+                    </a:solidFill>
+                  </a:tcPr>
+                </a:tc>
+                <a:tc>
+                  <a:txBody>
+                    <a:bodyPr/>
+                    <a:lstStyle/>
+                    <a:p>
+                      <a:pPr algn="ctr"/>
+                      <a:r>
+                        <a:rPr sz="1200" b="0" i="0">
+                          <a:solidFill>
+                            <a:srgbClr val="1F2A37"/>
+                          </a:solidFill>
+                          <a:latin typeface="Calibri"/>
+                        </a:rPr>
+                        <a:t>✗</a:t>
+                      </a:r>
+                    </a:p>
+                  </a:txBody>
+                  <a:tcPr marT="25400" marB="25400" marL="76200" marR="76200" anchor="ctr">
+                    <a:solidFill>
+                      <a:srgbClr val="FFFFFF"/>
+                    </a:solidFill>
+                  </a:tcPr>
+                </a:tc>
+                <a:tc>
+                  <a:txBody>
+                    <a:bodyPr/>
+                    <a:lstStyle/>
+                    <a:p>
+                      <a:pPr algn="ctr"/>
+                      <a:r>
+                        <a:rPr sz="1200" b="0" i="0">
+                          <a:solidFill>
+                            <a:srgbClr val="1F2A37"/>
+                          </a:solidFill>
+                          <a:latin typeface="Calibri"/>
+                        </a:rPr>
+                        <a:t>✗</a:t>
+                      </a:r>
+                    </a:p>
+                  </a:txBody>
+                  <a:tcPr marT="25400" marB="25400" marL="76200" marR="76200" anchor="ctr">
+                    <a:solidFill>
+                      <a:srgbClr val="FFFFFF"/>
+                    </a:solidFill>
+                  </a:tcPr>
+                </a:tc>
+                <a:tc>
+                  <a:txBody>
+                    <a:bodyPr/>
+                    <a:lstStyle/>
+                    <a:p>
+                      <a:pPr algn="ctr"/>
+                      <a:r>
+                        <a:rPr sz="1200" b="0" i="0">
+                          <a:solidFill>
+                            <a:srgbClr val="1F2A37"/>
+                          </a:solidFill>
+                          <a:latin typeface="Calibri"/>
+                        </a:rPr>
+                        <a:t>✗</a:t>
+                      </a:r>
+                    </a:p>
+                  </a:txBody>
+                  <a:tcPr marT="25400" marB="25400" marL="76200" marR="76200" anchor="ctr">
+                    <a:solidFill>
+                      <a:srgbClr val="FFFFFF"/>
+                    </a:solidFill>
+                  </a:tcPr>
+                </a:tc>
+                <a:tc>
+                  <a:txBody>
+                    <a:bodyPr/>
+                    <a:lstStyle/>
+                    <a:p>
+                      <a:pPr algn="ctr"/>
+                      <a:r>
+                        <a:rPr sz="1200" b="0" i="0">
+                          <a:solidFill>
+                            <a:srgbClr val="1F2A37"/>
+                          </a:solidFill>
+                          <a:latin typeface="Calibri"/>
+                        </a:rPr>
+                        <a:t>✗</a:t>
+                      </a:r>
+                    </a:p>
+                  </a:txBody>
+                  <a:tcPr marT="25400" marB="25400" marL="76200" marR="76200" anchor="ctr">
+                    <a:solidFill>
+                      <a:srgbClr val="FFFFFF"/>
+                    </a:solidFill>
+                  </a:tcPr>
+                </a:tc>
+                <a:tc>
+                  <a:txBody>
+                    <a:bodyPr/>
+                    <a:lstStyle/>
+                    <a:p>
+                      <a:pPr algn="ctr"/>
+                      <a:r>
+                        <a:rPr sz="1200" b="0" i="0">
+                          <a:solidFill>
+                            <a:srgbClr val="1F2A37"/>
+                          </a:solidFill>
+                          <a:latin typeface="Calibri"/>
+                        </a:rPr>
+                        <a:t>✓</a:t>
+                      </a:r>
+                    </a:p>
+                  </a:txBody>
+                  <a:tcPr marT="25400" marB="25400" marL="76200" marR="76200" anchor="ctr">
+                    <a:solidFill>
+                      <a:srgbClr val="FFFFFF"/>
+                    </a:solidFill>
+                  </a:tcPr>
+                </a:tc>
+                <a:tc>
+                  <a:txBody>
+                    <a:bodyPr/>
+                    <a:lstStyle/>
+                    <a:p>
+                      <a:pPr algn="ctr"/>
+                      <a:r>
+                        <a:rPr sz="1200" b="0" i="0">
+                          <a:solidFill>
+                            <a:srgbClr val="1F2A37"/>
+                          </a:solidFill>
+                          <a:latin typeface="Calibri"/>
+                        </a:rPr>
+                        <a:t>M5</a:t>
+                      </a:r>
+                    </a:p>
+                  </a:txBody>
+                  <a:tcPr marT="25400" marB="25400" marL="76200" marR="76200" anchor="ctr">
+                    <a:solidFill>
+                      <a:srgbClr val="FFFFFF"/>
+                    </a:solidFill>
+                  </a:tcPr>
+                </a:tc>
+              </a:tr>
+              <a:tr h="426720">
+                <a:tc>
+                  <a:txBody>
+                    <a:bodyPr/>
+                    <a:lstStyle/>
+                    <a:p>
+                      <a:pPr algn="l"/>
+                      <a:r>
+                        <a:rPr sz="1200" b="1" i="0">
+                          <a:solidFill>
+                            <a:srgbClr val="1F2A37"/>
+                          </a:solidFill>
+                          <a:latin typeface="Calibri"/>
+                        </a:rPr>
+                        <a:t>DCR protection ↑</a:t>
+                      </a:r>
+                    </a:p>
+                  </a:txBody>
+                  <a:tcPr marT="25400" marB="25400" marL="76200" marR="76200" anchor="ctr">
+                    <a:solidFill>
+                      <a:srgbClr val="F3F5F7"/>
+                    </a:solidFill>
+                  </a:tcPr>
+                </a:tc>
+                <a:tc>
+                  <a:txBody>
+                    <a:bodyPr/>
+                    <a:lstStyle/>
+                    <a:p>
+                      <a:pPr algn="ctr"/>
+                      <a:r>
+                        <a:rPr sz="1200" b="0" i="0">
+                          <a:solidFill>
+                            <a:srgbClr val="1F2A37"/>
+                          </a:solidFill>
+                          <a:latin typeface="Calibri"/>
+                        </a:rPr>
+                        <a:t>0.61</a:t>
+                      </a:r>
+                    </a:p>
+                  </a:txBody>
+                  <a:tcPr marT="25400" marB="25400" marL="76200" marR="76200" anchor="ctr">
+                    <a:solidFill>
+                      <a:srgbClr val="F3F5F7"/>
+                    </a:solidFill>
+                  </a:tcPr>
+                </a:tc>
+                <a:tc>
+                  <a:txBody>
+                    <a:bodyPr/>
+                    <a:lstStyle/>
+                    <a:p>
+                      <a:pPr algn="ctr"/>
+                      <a:r>
+                        <a:rPr sz="1200" b="0" i="0">
+                          <a:solidFill>
+                            <a:srgbClr val="1F2A37"/>
+                          </a:solidFill>
+                          <a:latin typeface="Calibri"/>
+                        </a:rPr>
+                        <a:t>0.69</a:t>
+                      </a:r>
+                    </a:p>
+                  </a:txBody>
+                  <a:tcPr marT="25400" marB="25400" marL="76200" marR="76200" anchor="ctr">
+                    <a:solidFill>
+                      <a:srgbClr val="F3F5F7"/>
+                    </a:solidFill>
+                  </a:tcPr>
+                </a:tc>
+                <a:tc>
+                  <a:txBody>
+                    <a:bodyPr/>
+                    <a:lstStyle/>
+                    <a:p>
+                      <a:pPr algn="ctr"/>
+                      <a:r>
+                        <a:rPr sz="1200" b="0" i="0">
+                          <a:solidFill>
+                            <a:srgbClr val="1F2A37"/>
+                          </a:solidFill>
+                          <a:latin typeface="Calibri"/>
+                        </a:rPr>
+                        <a:t>0.74</a:t>
+                      </a:r>
+                    </a:p>
+                  </a:txBody>
+                  <a:tcPr marT="25400" marB="25400" marL="76200" marR="76200" anchor="ctr">
+                    <a:solidFill>
+                      <a:srgbClr val="F3F5F7"/>
+                    </a:solidFill>
+                  </a:tcPr>
+                </a:tc>
+                <a:tc>
+                  <a:txBody>
+                    <a:bodyPr/>
+                    <a:lstStyle/>
+                    <a:p>
+                      <a:pPr algn="ctr"/>
+                      <a:r>
+                        <a:rPr sz="1200" b="0" i="0">
+                          <a:solidFill>
+                            <a:srgbClr val="1F2A37"/>
+                          </a:solidFill>
+                          <a:latin typeface="Calibri"/>
+                        </a:rPr>
+                        <a:t>0.65</a:t>
+                      </a:r>
+                    </a:p>
+                  </a:txBody>
+                  <a:tcPr marT="25400" marB="25400" marL="76200" marR="76200" anchor="ctr">
+                    <a:solidFill>
+                      <a:srgbClr val="F3F5F7"/>
+                    </a:solidFill>
+                  </a:tcPr>
+                </a:tc>
+                <a:tc>
+                  <a:txBody>
+                    <a:bodyPr/>
+                    <a:lstStyle/>
+                    <a:p>
+                      <a:pPr algn="ctr"/>
+                      <a:r>
+                        <a:rPr sz="1200" b="0" i="0">
+                          <a:solidFill>
+                            <a:srgbClr val="1F2A37"/>
+                          </a:solidFill>
+                          <a:latin typeface="Calibri"/>
+                        </a:rPr>
+                        <a:t>0.57</a:t>
+                      </a:r>
+                    </a:p>
+                  </a:txBody>
+                  <a:tcPr marT="25400" marB="25400" marL="76200" marR="76200" anchor="ctr">
+                    <a:solidFill>
+                      <a:srgbClr val="F3F5F7"/>
+                    </a:solidFill>
+                  </a:tcPr>
+                </a:tc>
+                <a:tc>
+                  <a:txBody>
+                    <a:bodyPr/>
+                    <a:lstStyle/>
+                    <a:p>
+                      <a:pPr algn="ctr"/>
+                      <a:r>
+                        <a:rPr sz="1200" b="0" i="0">
+                          <a:solidFill>
+                            <a:srgbClr val="1F2A37"/>
+                          </a:solidFill>
+                          <a:latin typeface="Calibri"/>
+                        </a:rPr>
+                        <a:t>M3</a:t>
+                      </a:r>
+                    </a:p>
+                  </a:txBody>
+                  <a:tcPr marT="25400" marB="25400" marL="76200" marR="76200" anchor="ctr">
+                    <a:solidFill>
+                      <a:srgbClr val="F3F5F7"/>
+                    </a:solidFill>
+                  </a:tcPr>
+                </a:tc>
+              </a:tr>
+            </a:tbl>
+          </a:graphicData>
+        </a:graphic>
+      </p:graphicFrame>
+      <p:sp>
+        <p:nvSpPr>
+          <p:cNvPr id="5" name="TextBox 4"/>
           <p:cNvSpPr txBox="1"/>
           <p:nvPr/>
         </p:nvSpPr>
         <p:spPr>
           <a:xfrm>
-            <a:off x="777240" y="1737360"/>
-            <a:ext cx="10607040" cy="4572000"/>
+            <a:off x="9281160" y="1737360"/>
+            <a:ext cx="2651760" cy="3931920"/>
           </a:xfrm>
           <a:prstGeom prst="rect">
             <a:avLst/>
@@ -7147,99 +9171,107 @@
           </a:bodyPr>
           <a:lstStyle/>
           <a:p>
+            <a:pPr algn="l"/>
+            <a:r>
+              <a:rPr sz="1600" b="1" i="0">
+                <a:solidFill>
+                  <a:srgbClr val="4E79A7"/>
+                </a:solidFill>
+                <a:latin typeface="Calibri"/>
+              </a:rPr>
+              <a:t>Pick by need</a:t>
+            </a:r>
+          </a:p>
+          <a:p>
             <a:pPr algn="l">
               <a:spcAft>
-                <a:spcPts val="1200"/>
+                <a:spcPts val="700"/>
               </a:spcAft>
             </a:pPr>
             <a:r>
-              <a:rPr sz="1800" b="0" i="0">
+              <a:rPr sz="1300" b="0" i="0">
                 <a:solidFill>
                   <a:srgbClr val="1F2A37"/>
                 </a:solidFill>
                 <a:latin typeface="Calibri"/>
               </a:rPr>
-              <a:t>•  Real customer + transaction data is sensitive, regulated, and scarce.</a:t>
+              <a:t>• M1 ≈ M4 — best all-round fidelity</a:t>
             </a:r>
           </a:p>
           <a:p>
             <a:pPr algn="l">
               <a:spcAft>
-                <a:spcPts val="1200"/>
+                <a:spcPts val="700"/>
               </a:spcAft>
             </a:pPr>
             <a:r>
-              <a:rPr sz="1800" b="0" i="0">
+              <a:rPr sz="1300" b="0" i="0">
                 <a:solidFill>
                   <a:srgbClr val="1F2A37"/>
                 </a:solidFill>
                 <a:latin typeface="Calibri"/>
               </a:rPr>
-              <a:t>•  Teams still need realistic data to build &amp; test models, demos, and pipelines.</a:t>
+              <a:t>• M1 — demographic correlations (recommender)</a:t>
             </a:r>
           </a:p>
           <a:p>
             <a:pPr algn="l">
               <a:spcAft>
-                <a:spcPts val="1200"/>
+                <a:spcPts val="700"/>
               </a:spcAft>
             </a:pPr>
             <a:r>
-              <a:rPr sz="1800" b="1" i="0">
+              <a:rPr sz="1300" b="0" i="0">
                 <a:solidFill>
                   <a:srgbClr val="1F2A37"/>
                 </a:solidFill>
                 <a:latin typeface="Calibri"/>
               </a:rPr>
-              <a:t>•  Naïve synthesis preserves single-column shapes but breaks what matters:</a:t>
-            </a:r>
-          </a:p>
-          <a:p>
-            <a:pPr algn="l" lvl="1">
+              <a:t>• M2 — transaction shapes &amp; timing</a:t>
+            </a:r>
+          </a:p>
+          <a:p>
+            <a:pPr algn="l">
               <a:spcAft>
-                <a:spcPts val="1200"/>
+                <a:spcPts val="700"/>
               </a:spcAft>
             </a:pPr>
             <a:r>
-              <a:rPr sz="1600" b="0" i="0">
-                <a:solidFill>
-                  <a:srgbClr val="5B6670"/>
-                </a:solidFill>
-                <a:latin typeface="Calibri"/>
-              </a:rPr>
-              <a:t>–  cross-table correlations — does income still predict the products bought?</a:t>
-            </a:r>
-          </a:p>
-          <a:p>
-            <a:pPr algn="l" lvl="1">
+              <a:rPr sz="1300" b="0" i="0">
+                <a:solidFill>
+                  <a:srgbClr val="1F2A37"/>
+                </a:solidFill>
+                <a:latin typeface="Calibri"/>
+              </a:rPr>
+              <a:t>• M5 — the only privacy guarantee</a:t>
+            </a:r>
+          </a:p>
+          <a:p>
+            <a:pPr algn="l">
               <a:spcAft>
-                <a:spcPts val="1200"/>
+                <a:spcPts val="700"/>
               </a:spcAft>
             </a:pPr>
             <a:r>
-              <a:rPr sz="1600" b="0" i="0">
-                <a:solidFill>
-                  <a:srgbClr val="5B6670"/>
-                </a:solidFill>
-                <a:latin typeface="Calibri"/>
-              </a:rPr>
-              <a:t>–  business rules — a product's category, a valid credit score, whole-number counts.</a:t>
-            </a:r>
-          </a:p>
-          <a:p>
-            <a:pPr algn="l">
-              <a:spcAft>
-                <a:spcPts val="1200"/>
-              </a:spcAft>
-            </a:pPr>
-            <a:r>
-              <a:rPr sz="1800" b="0" i="0">
+              <a:rPr sz="1300" b="0" i="0">
                 <a:solidFill>
                   <a:srgbClr val="1F2A37"/>
                 </a:solidFill>
                 <a:latin typeface="Calibri"/>
               </a:rPr>
-              <a:t>•  Goal: data that is statistically faithful AND provably valid — then prove it's useful.</a:t>
+              <a:t>• M3 — cross-table &amp; DCR, low utility</a:t>
+            </a:r>
+          </a:p>
+          <a:p>
+            <a:pPr algn="l"/>
+            <a:r>
+              <a:rPr sz="1200" b="0" i="1">
+                <a:solidFill>
+                  <a:srgbClr val="B07AA1"/>
+                </a:solidFill>
+                <a:latin typeface="Calibri"/>
+              </a:rPr>
+              <a:t>More data closed M5's quality lead; 12 txns/cust exposed its temporal gap.</a:t>
             </a:r>
           </a:p>
         </p:txBody>
@@ -7252,7 +9284,7 @@
 </p:sld>
 </file>
 
-<file path=ppt/slides/slide20.xml><?xml version="1.0" encoding="utf-8"?>
+<file path=ppt/slides/slide22.xml><?xml version="1.0" encoding="utf-8"?>
 <p:sld xmlns:a="http://schemas.openxmlformats.org/drawingml/2006/main" xmlns:p="http://schemas.openxmlformats.org/presentationml/2006/main" xmlns:r="http://schemas.openxmlformats.org/officeDocument/2006/relationships">
   <p:cSld>
     <p:bg>
@@ -7343,1747 +9375,6 @@
                 </a:solidFill>
                 <a:latin typeface="Calibri"/>
               </a:rPr>
-              <a:t>VERDICT</a:t>
-            </a:r>
-          </a:p>
-          <a:p>
-            <a:pPr algn="l"/>
-            <a:r>
-              <a:rPr sz="3200" b="1" i="0">
-                <a:solidFill>
-                  <a:srgbClr val="1F2A37"/>
-                </a:solidFill>
-                <a:latin typeface="Calibri"/>
-              </a:rPr>
-              <a:t>Results at 2,000 seeds · ~12 txns — SDV vs DP</a:t>
-            </a:r>
-          </a:p>
-        </p:txBody>
-      </p:sp>
-      <p:graphicFrame>
-        <p:nvGraphicFramePr>
-          <p:cNvPr id="4" name="Table 3"/>
-          <p:cNvGraphicFramePr>
-            <a:graphicFrameLocks noGrp="1"/>
-          </p:cNvGraphicFramePr>
-          <p:nvPr/>
-        </p:nvGraphicFramePr>
-        <p:xfrm>
-          <a:off x="640080" y="1737360"/>
-          <a:ext cx="8412480" cy="3840480"/>
-        </p:xfrm>
-        <a:graphic>
-          <a:graphicData uri="http://schemas.openxmlformats.org/drawingml/2006/table">
-            <a:tbl>
-              <a:tblPr firstRow="1" bandRow="1">
-                <a:tableStyleId>{5C22544A-7EE6-4342-B048-85BDC9FD1C3A}</a:tableStyleId>
-              </a:tblPr>
-              <a:tblGrid>
-                <a:gridCol w="2286000"/>
-                <a:gridCol w="868680"/>
-                <a:gridCol w="868680"/>
-                <a:gridCol w="868680"/>
-                <a:gridCol w="868680"/>
-                <a:gridCol w="868680"/>
-                <a:gridCol w="1783080"/>
-              </a:tblGrid>
-              <a:tr h="426720">
-                <a:tc>
-                  <a:txBody>
-                    <a:bodyPr/>
-                    <a:lstStyle/>
-                    <a:p>
-                      <a:pPr algn="l"/>
-                      <a:r>
-                        <a:rPr sz="1200" b="1" i="0">
-                          <a:solidFill>
-                            <a:srgbClr val="FFFFFF"/>
-                          </a:solidFill>
-                          <a:latin typeface="Calibri"/>
-                        </a:rPr>
-                        <a:t>Metric</a:t>
-                      </a:r>
-                    </a:p>
-                  </a:txBody>
-                  <a:tcPr marT="25400" marB="25400" marL="76200" marR="76200" anchor="ctr">
-                    <a:solidFill>
-                      <a:srgbClr val="4E79A7"/>
-                    </a:solidFill>
-                  </a:tcPr>
-                </a:tc>
-                <a:tc>
-                  <a:txBody>
-                    <a:bodyPr/>
-                    <a:lstStyle/>
-                    <a:p>
-                      <a:pPr algn="ctr"/>
-                      <a:r>
-                        <a:rPr sz="1200" b="1" i="0">
-                          <a:solidFill>
-                            <a:srgbClr val="FFFFFF"/>
-                          </a:solidFill>
-                          <a:latin typeface="Calibri"/>
-                        </a:rPr>
-                        <a:t>M1</a:t>
-                      </a:r>
-                    </a:p>
-                  </a:txBody>
-                  <a:tcPr marT="25400" marB="25400" marL="76200" marR="76200" anchor="ctr">
-                    <a:solidFill>
-                      <a:srgbClr val="4E79A7"/>
-                    </a:solidFill>
-                  </a:tcPr>
-                </a:tc>
-                <a:tc>
-                  <a:txBody>
-                    <a:bodyPr/>
-                    <a:lstStyle/>
-                    <a:p>
-                      <a:pPr algn="ctr"/>
-                      <a:r>
-                        <a:rPr sz="1200" b="1" i="0">
-                          <a:solidFill>
-                            <a:srgbClr val="FFFFFF"/>
-                          </a:solidFill>
-                          <a:latin typeface="Calibri"/>
-                        </a:rPr>
-                        <a:t>M2</a:t>
-                      </a:r>
-                    </a:p>
-                  </a:txBody>
-                  <a:tcPr marT="25400" marB="25400" marL="76200" marR="76200" anchor="ctr">
-                    <a:solidFill>
-                      <a:srgbClr val="4E79A7"/>
-                    </a:solidFill>
-                  </a:tcPr>
-                </a:tc>
-                <a:tc>
-                  <a:txBody>
-                    <a:bodyPr/>
-                    <a:lstStyle/>
-                    <a:p>
-                      <a:pPr algn="ctr"/>
-                      <a:r>
-                        <a:rPr sz="1200" b="1" i="0">
-                          <a:solidFill>
-                            <a:srgbClr val="FFFFFF"/>
-                          </a:solidFill>
-                          <a:latin typeface="Calibri"/>
-                        </a:rPr>
-                        <a:t>M3</a:t>
-                      </a:r>
-                    </a:p>
-                  </a:txBody>
-                  <a:tcPr marT="25400" marB="25400" marL="76200" marR="76200" anchor="ctr">
-                    <a:solidFill>
-                      <a:srgbClr val="4E79A7"/>
-                    </a:solidFill>
-                  </a:tcPr>
-                </a:tc>
-                <a:tc>
-                  <a:txBody>
-                    <a:bodyPr/>
-                    <a:lstStyle/>
-                    <a:p>
-                      <a:pPr algn="ctr"/>
-                      <a:r>
-                        <a:rPr sz="1200" b="1" i="0">
-                          <a:solidFill>
-                            <a:srgbClr val="FFFFFF"/>
-                          </a:solidFill>
-                          <a:latin typeface="Calibri"/>
-                        </a:rPr>
-                        <a:t>M4</a:t>
-                      </a:r>
-                    </a:p>
-                  </a:txBody>
-                  <a:tcPr marT="25400" marB="25400" marL="76200" marR="76200" anchor="ctr">
-                    <a:solidFill>
-                      <a:srgbClr val="4E79A7"/>
-                    </a:solidFill>
-                  </a:tcPr>
-                </a:tc>
-                <a:tc>
-                  <a:txBody>
-                    <a:bodyPr/>
-                    <a:lstStyle/>
-                    <a:p>
-                      <a:pPr algn="ctr"/>
-                      <a:r>
-                        <a:rPr sz="1200" b="1" i="0">
-                          <a:solidFill>
-                            <a:srgbClr val="FFFFFF"/>
-                          </a:solidFill>
-                          <a:latin typeface="Calibri"/>
-                        </a:rPr>
-                        <a:t>M5</a:t>
-                      </a:r>
-                    </a:p>
-                  </a:txBody>
-                  <a:tcPr marT="25400" marB="25400" marL="76200" marR="76200" anchor="ctr">
-                    <a:solidFill>
-                      <a:srgbClr val="4E79A7"/>
-                    </a:solidFill>
-                  </a:tcPr>
-                </a:tc>
-                <a:tc>
-                  <a:txBody>
-                    <a:bodyPr/>
-                    <a:lstStyle/>
-                    <a:p>
-                      <a:pPr algn="ctr"/>
-                      <a:r>
-                        <a:rPr sz="1200" b="1" i="0">
-                          <a:solidFill>
-                            <a:srgbClr val="FFFFFF"/>
-                          </a:solidFill>
-                          <a:latin typeface="Calibri"/>
-                        </a:rPr>
-                        <a:t>Winner</a:t>
-                      </a:r>
-                    </a:p>
-                  </a:txBody>
-                  <a:tcPr marT="25400" marB="25400" marL="76200" marR="76200" anchor="ctr">
-                    <a:solidFill>
-                      <a:srgbClr val="4E79A7"/>
-                    </a:solidFill>
-                  </a:tcPr>
-                </a:tc>
-              </a:tr>
-              <a:tr h="426720">
-                <a:tc>
-                  <a:txBody>
-                    <a:bodyPr/>
-                    <a:lstStyle/>
-                    <a:p>
-                      <a:pPr algn="l"/>
-                      <a:r>
-                        <a:rPr sz="1200" b="1" i="0">
-                          <a:solidFill>
-                            <a:srgbClr val="1F2A37"/>
-                          </a:solidFill>
-                          <a:latin typeface="Calibri"/>
-                        </a:rPr>
-                        <a:t>Overall quality</a:t>
-                      </a:r>
-                    </a:p>
-                  </a:txBody>
-                  <a:tcPr marT="25400" marB="25400" marL="76200" marR="76200" anchor="ctr">
-                    <a:solidFill>
-                      <a:srgbClr val="FFFFFF"/>
-                    </a:solidFill>
-                  </a:tcPr>
-                </a:tc>
-                <a:tc>
-                  <a:txBody>
-                    <a:bodyPr/>
-                    <a:lstStyle/>
-                    <a:p>
-                      <a:pPr algn="ctr"/>
-                      <a:r>
-                        <a:rPr sz="1200" b="0" i="0">
-                          <a:solidFill>
-                            <a:srgbClr val="1F2A37"/>
-                          </a:solidFill>
-                          <a:latin typeface="Calibri"/>
-                        </a:rPr>
-                        <a:t>0.888</a:t>
-                      </a:r>
-                    </a:p>
-                  </a:txBody>
-                  <a:tcPr marT="25400" marB="25400" marL="76200" marR="76200" anchor="ctr">
-                    <a:solidFill>
-                      <a:srgbClr val="FFFFFF"/>
-                    </a:solidFill>
-                  </a:tcPr>
-                </a:tc>
-                <a:tc>
-                  <a:txBody>
-                    <a:bodyPr/>
-                    <a:lstStyle/>
-                    <a:p>
-                      <a:pPr algn="ctr"/>
-                      <a:r>
-                        <a:rPr sz="1200" b="0" i="0">
-                          <a:solidFill>
-                            <a:srgbClr val="1F2A37"/>
-                          </a:solidFill>
-                          <a:latin typeface="Calibri"/>
-                        </a:rPr>
-                        <a:t>0.854</a:t>
-                      </a:r>
-                    </a:p>
-                  </a:txBody>
-                  <a:tcPr marT="25400" marB="25400" marL="76200" marR="76200" anchor="ctr">
-                    <a:solidFill>
-                      <a:srgbClr val="FFFFFF"/>
-                    </a:solidFill>
-                  </a:tcPr>
-                </a:tc>
-                <a:tc>
-                  <a:txBody>
-                    <a:bodyPr/>
-                    <a:lstStyle/>
-                    <a:p>
-                      <a:pPr algn="ctr"/>
-                      <a:r>
-                        <a:rPr sz="1200" b="0" i="0">
-                          <a:solidFill>
-                            <a:srgbClr val="1F2A37"/>
-                          </a:solidFill>
-                          <a:latin typeface="Calibri"/>
-                        </a:rPr>
-                        <a:t>0.647</a:t>
-                      </a:r>
-                    </a:p>
-                  </a:txBody>
-                  <a:tcPr marT="25400" marB="25400" marL="76200" marR="76200" anchor="ctr">
-                    <a:solidFill>
-                      <a:srgbClr val="FFFFFF"/>
-                    </a:solidFill>
-                  </a:tcPr>
-                </a:tc>
-                <a:tc>
-                  <a:txBody>
-                    <a:bodyPr/>
-                    <a:lstStyle/>
-                    <a:p>
-                      <a:pPr algn="ctr"/>
-                      <a:r>
-                        <a:rPr sz="1200" b="0" i="0">
-                          <a:solidFill>
-                            <a:srgbClr val="1F2A37"/>
-                          </a:solidFill>
-                          <a:latin typeface="Calibri"/>
-                        </a:rPr>
-                        <a:t>0.887</a:t>
-                      </a:r>
-                    </a:p>
-                  </a:txBody>
-                  <a:tcPr marT="25400" marB="25400" marL="76200" marR="76200" anchor="ctr">
-                    <a:solidFill>
-                      <a:srgbClr val="FFFFFF"/>
-                    </a:solidFill>
-                  </a:tcPr>
-                </a:tc>
-                <a:tc>
-                  <a:txBody>
-                    <a:bodyPr/>
-                    <a:lstStyle/>
-                    <a:p>
-                      <a:pPr algn="ctr"/>
-                      <a:r>
-                        <a:rPr sz="1200" b="0" i="0">
-                          <a:solidFill>
-                            <a:srgbClr val="1F2A37"/>
-                          </a:solidFill>
-                          <a:latin typeface="Calibri"/>
-                        </a:rPr>
-                        <a:t>0.861</a:t>
-                      </a:r>
-                    </a:p>
-                  </a:txBody>
-                  <a:tcPr marT="25400" marB="25400" marL="76200" marR="76200" anchor="ctr">
-                    <a:solidFill>
-                      <a:srgbClr val="FFFFFF"/>
-                    </a:solidFill>
-                  </a:tcPr>
-                </a:tc>
-                <a:tc>
-                  <a:txBody>
-                    <a:bodyPr/>
-                    <a:lstStyle/>
-                    <a:p>
-                      <a:pPr algn="ctr"/>
-                      <a:r>
-                        <a:rPr sz="1200" b="0" i="0">
-                          <a:solidFill>
-                            <a:srgbClr val="1F2A37"/>
-                          </a:solidFill>
-                          <a:latin typeface="Calibri"/>
-                        </a:rPr>
-                        <a:t>M1≈M4</a:t>
-                      </a:r>
-                    </a:p>
-                  </a:txBody>
-                  <a:tcPr marT="25400" marB="25400" marL="76200" marR="76200" anchor="ctr">
-                    <a:solidFill>
-                      <a:srgbClr val="FFFFFF"/>
-                    </a:solidFill>
-                  </a:tcPr>
-                </a:tc>
-              </a:tr>
-              <a:tr h="426720">
-                <a:tc>
-                  <a:txBody>
-                    <a:bodyPr/>
-                    <a:lstStyle/>
-                    <a:p>
-                      <a:pPr algn="l"/>
-                      <a:r>
-                        <a:rPr sz="1200" b="1" i="0">
-                          <a:solidFill>
-                            <a:srgbClr val="1F2A37"/>
-                          </a:solidFill>
-                          <a:latin typeface="Calibri"/>
-                        </a:rPr>
-                        <a:t>Diagnostic / FK</a:t>
-                      </a:r>
-                    </a:p>
-                  </a:txBody>
-                  <a:tcPr marT="25400" marB="25400" marL="76200" marR="76200" anchor="ctr">
-                    <a:solidFill>
-                      <a:srgbClr val="F3F5F7"/>
-                    </a:solidFill>
-                  </a:tcPr>
-                </a:tc>
-                <a:tc>
-                  <a:txBody>
-                    <a:bodyPr/>
-                    <a:lstStyle/>
-                    <a:p>
-                      <a:pPr algn="ctr"/>
-                      <a:r>
-                        <a:rPr sz="1200" b="0" i="0">
-                          <a:solidFill>
-                            <a:srgbClr val="1F2A37"/>
-                          </a:solidFill>
-                          <a:latin typeface="Calibri"/>
-                        </a:rPr>
-                        <a:t>1.000</a:t>
-                      </a:r>
-                    </a:p>
-                  </a:txBody>
-                  <a:tcPr marT="25400" marB="25400" marL="76200" marR="76200" anchor="ctr">
-                    <a:solidFill>
-                      <a:srgbClr val="F3F5F7"/>
-                    </a:solidFill>
-                  </a:tcPr>
-                </a:tc>
-                <a:tc>
-                  <a:txBody>
-                    <a:bodyPr/>
-                    <a:lstStyle/>
-                    <a:p>
-                      <a:pPr algn="ctr"/>
-                      <a:r>
-                        <a:rPr sz="1200" b="0" i="0">
-                          <a:solidFill>
-                            <a:srgbClr val="1F2A37"/>
-                          </a:solidFill>
-                          <a:latin typeface="Calibri"/>
-                        </a:rPr>
-                        <a:t>1.000</a:t>
-                      </a:r>
-                    </a:p>
-                  </a:txBody>
-                  <a:tcPr marT="25400" marB="25400" marL="76200" marR="76200" anchor="ctr">
-                    <a:solidFill>
-                      <a:srgbClr val="F3F5F7"/>
-                    </a:solidFill>
-                  </a:tcPr>
-                </a:tc>
-                <a:tc>
-                  <a:txBody>
-                    <a:bodyPr/>
-                    <a:lstStyle/>
-                    <a:p>
-                      <a:pPr algn="ctr"/>
-                      <a:r>
-                        <a:rPr sz="1200" b="0" i="0">
-                          <a:solidFill>
-                            <a:srgbClr val="1F2A37"/>
-                          </a:solidFill>
-                          <a:latin typeface="Calibri"/>
-                        </a:rPr>
-                        <a:t>0.744</a:t>
-                      </a:r>
-                    </a:p>
-                  </a:txBody>
-                  <a:tcPr marT="25400" marB="25400" marL="76200" marR="76200" anchor="ctr">
-                    <a:solidFill>
-                      <a:srgbClr val="F3F5F7"/>
-                    </a:solidFill>
-                  </a:tcPr>
-                </a:tc>
-                <a:tc>
-                  <a:txBody>
-                    <a:bodyPr/>
-                    <a:lstStyle/>
-                    <a:p>
-                      <a:pPr algn="ctr"/>
-                      <a:r>
-                        <a:rPr sz="1200" b="0" i="0">
-                          <a:solidFill>
-                            <a:srgbClr val="1F2A37"/>
-                          </a:solidFill>
-                          <a:latin typeface="Calibri"/>
-                        </a:rPr>
-                        <a:t>1.000</a:t>
-                      </a:r>
-                    </a:p>
-                  </a:txBody>
-                  <a:tcPr marT="25400" marB="25400" marL="76200" marR="76200" anchor="ctr">
-                    <a:solidFill>
-                      <a:srgbClr val="F3F5F7"/>
-                    </a:solidFill>
-                  </a:tcPr>
-                </a:tc>
-                <a:tc>
-                  <a:txBody>
-                    <a:bodyPr/>
-                    <a:lstStyle/>
-                    <a:p>
-                      <a:pPr algn="ctr"/>
-                      <a:r>
-                        <a:rPr sz="1200" b="0" i="0">
-                          <a:solidFill>
-                            <a:srgbClr val="1F2A37"/>
-                          </a:solidFill>
-                          <a:latin typeface="Calibri"/>
-                        </a:rPr>
-                        <a:t>1.000</a:t>
-                      </a:r>
-                    </a:p>
-                  </a:txBody>
-                  <a:tcPr marT="25400" marB="25400" marL="76200" marR="76200" anchor="ctr">
-                    <a:solidFill>
-                      <a:srgbClr val="F3F5F7"/>
-                    </a:solidFill>
-                  </a:tcPr>
-                </a:tc>
-                <a:tc>
-                  <a:txBody>
-                    <a:bodyPr/>
-                    <a:lstStyle/>
-                    <a:p>
-                      <a:pPr algn="ctr"/>
-                      <a:r>
-                        <a:rPr sz="1200" b="0" i="0">
-                          <a:solidFill>
-                            <a:srgbClr val="1F2A37"/>
-                          </a:solidFill>
-                          <a:latin typeface="Calibri"/>
-                        </a:rPr>
-                        <a:t>tie</a:t>
-                      </a:r>
-                    </a:p>
-                  </a:txBody>
-                  <a:tcPr marT="25400" marB="25400" marL="76200" marR="76200" anchor="ctr">
-                    <a:solidFill>
-                      <a:srgbClr val="F3F5F7"/>
-                    </a:solidFill>
-                  </a:tcPr>
-                </a:tc>
-              </a:tr>
-              <a:tr h="426720">
-                <a:tc>
-                  <a:txBody>
-                    <a:bodyPr/>
-                    <a:lstStyle/>
-                    <a:p>
-                      <a:pPr algn="l"/>
-                      <a:r>
-                        <a:rPr sz="1200" b="1" i="0">
-                          <a:solidFill>
-                            <a:srgbClr val="1F2A37"/>
-                          </a:solidFill>
-                          <a:latin typeface="Calibri"/>
-                        </a:rPr>
-                        <a:t>Cust. pair trends</a:t>
-                      </a:r>
-                    </a:p>
-                  </a:txBody>
-                  <a:tcPr marT="25400" marB="25400" marL="76200" marR="76200" anchor="ctr">
-                    <a:solidFill>
-                      <a:srgbClr val="FFFFFF"/>
-                    </a:solidFill>
-                  </a:tcPr>
-                </a:tc>
-                <a:tc>
-                  <a:txBody>
-                    <a:bodyPr/>
-                    <a:lstStyle/>
-                    <a:p>
-                      <a:pPr algn="ctr"/>
-                      <a:r>
-                        <a:rPr sz="1200" b="0" i="0">
-                          <a:solidFill>
-                            <a:srgbClr val="1F2A37"/>
-                          </a:solidFill>
-                          <a:latin typeface="Calibri"/>
-                        </a:rPr>
-                        <a:t>0.737</a:t>
-                      </a:r>
-                    </a:p>
-                  </a:txBody>
-                  <a:tcPr marT="25400" marB="25400" marL="76200" marR="76200" anchor="ctr">
-                    <a:solidFill>
-                      <a:srgbClr val="FFFFFF"/>
-                    </a:solidFill>
-                  </a:tcPr>
-                </a:tc>
-                <a:tc>
-                  <a:txBody>
-                    <a:bodyPr/>
-                    <a:lstStyle/>
-                    <a:p>
-                      <a:pPr algn="ctr"/>
-                      <a:r>
-                        <a:rPr sz="1200" b="0" i="0">
-                          <a:solidFill>
-                            <a:srgbClr val="1F2A37"/>
-                          </a:solidFill>
-                          <a:latin typeface="Calibri"/>
-                        </a:rPr>
-                        <a:t>0.567</a:t>
-                      </a:r>
-                    </a:p>
-                  </a:txBody>
-                  <a:tcPr marT="25400" marB="25400" marL="76200" marR="76200" anchor="ctr">
-                    <a:solidFill>
-                      <a:srgbClr val="FFFFFF"/>
-                    </a:solidFill>
-                  </a:tcPr>
-                </a:tc>
-                <a:tc>
-                  <a:txBody>
-                    <a:bodyPr/>
-                    <a:lstStyle/>
-                    <a:p>
-                      <a:pPr algn="ctr"/>
-                      <a:r>
-                        <a:rPr sz="1200" b="0" i="0">
-                          <a:solidFill>
-                            <a:srgbClr val="1F2A37"/>
-                          </a:solidFill>
-                          <a:latin typeface="Calibri"/>
-                        </a:rPr>
-                        <a:t>0.547</a:t>
-                      </a:r>
-                    </a:p>
-                  </a:txBody>
-                  <a:tcPr marT="25400" marB="25400" marL="76200" marR="76200" anchor="ctr">
-                    <a:solidFill>
-                      <a:srgbClr val="FFFFFF"/>
-                    </a:solidFill>
-                  </a:tcPr>
-                </a:tc>
-                <a:tc>
-                  <a:txBody>
-                    <a:bodyPr/>
-                    <a:lstStyle/>
-                    <a:p>
-                      <a:pPr algn="ctr"/>
-                      <a:r>
-                        <a:rPr sz="1200" b="0" i="0">
-                          <a:solidFill>
-                            <a:srgbClr val="1F2A37"/>
-                          </a:solidFill>
-                          <a:latin typeface="Calibri"/>
-                        </a:rPr>
-                        <a:t>0.780</a:t>
-                      </a:r>
-                    </a:p>
-                  </a:txBody>
-                  <a:tcPr marT="25400" marB="25400" marL="76200" marR="76200" anchor="ctr">
-                    <a:solidFill>
-                      <a:srgbClr val="FFFFFF"/>
-                    </a:solidFill>
-                  </a:tcPr>
-                </a:tc>
-                <a:tc>
-                  <a:txBody>
-                    <a:bodyPr/>
-                    <a:lstStyle/>
-                    <a:p>
-                      <a:pPr algn="ctr"/>
-                      <a:r>
-                        <a:rPr sz="1200" b="0" i="0">
-                          <a:solidFill>
-                            <a:srgbClr val="1F2A37"/>
-                          </a:solidFill>
-                          <a:latin typeface="Calibri"/>
-                        </a:rPr>
-                        <a:t>0.850</a:t>
-                      </a:r>
-                    </a:p>
-                  </a:txBody>
-                  <a:tcPr marT="25400" marB="25400" marL="76200" marR="76200" anchor="ctr">
-                    <a:solidFill>
-                      <a:srgbClr val="FFFFFF"/>
-                    </a:solidFill>
-                  </a:tcPr>
-                </a:tc>
-                <a:tc>
-                  <a:txBody>
-                    <a:bodyPr/>
-                    <a:lstStyle/>
-                    <a:p>
-                      <a:pPr algn="ctr"/>
-                      <a:r>
-                        <a:rPr sz="1200" b="0" i="0">
-                          <a:solidFill>
-                            <a:srgbClr val="1F2A37"/>
-                          </a:solidFill>
-                          <a:latin typeface="Calibri"/>
-                        </a:rPr>
-                        <a:t>M5</a:t>
-                      </a:r>
-                    </a:p>
-                  </a:txBody>
-                  <a:tcPr marT="25400" marB="25400" marL="76200" marR="76200" anchor="ctr">
-                    <a:solidFill>
-                      <a:srgbClr val="FFFFFF"/>
-                    </a:solidFill>
-                  </a:tcPr>
-                </a:tc>
-              </a:tr>
-              <a:tr h="426720">
-                <a:tc>
-                  <a:txBody>
-                    <a:bodyPr/>
-                    <a:lstStyle/>
-                    <a:p>
-                      <a:pPr algn="l"/>
-                      <a:r>
-                        <a:rPr sz="1200" b="1" i="0">
-                          <a:solidFill>
-                            <a:srgbClr val="1F2A37"/>
-                          </a:solidFill>
-                          <a:latin typeface="Calibri"/>
-                        </a:rPr>
-                        <a:t>Txn. column shapes</a:t>
-                      </a:r>
-                    </a:p>
-                  </a:txBody>
-                  <a:tcPr marT="25400" marB="25400" marL="76200" marR="76200" anchor="ctr">
-                    <a:solidFill>
-                      <a:srgbClr val="F3F5F7"/>
-                    </a:solidFill>
-                  </a:tcPr>
-                </a:tc>
-                <a:tc>
-                  <a:txBody>
-                    <a:bodyPr/>
-                    <a:lstStyle/>
-                    <a:p>
-                      <a:pPr algn="ctr"/>
-                      <a:r>
-                        <a:rPr sz="1200" b="0" i="0">
-                          <a:solidFill>
-                            <a:srgbClr val="1F2A37"/>
-                          </a:solidFill>
-                          <a:latin typeface="Calibri"/>
-                        </a:rPr>
-                        <a:t>0.865</a:t>
-                      </a:r>
-                    </a:p>
-                  </a:txBody>
-                  <a:tcPr marT="25400" marB="25400" marL="76200" marR="76200" anchor="ctr">
-                    <a:solidFill>
-                      <a:srgbClr val="F3F5F7"/>
-                    </a:solidFill>
-                  </a:tcPr>
-                </a:tc>
-                <a:tc>
-                  <a:txBody>
-                    <a:bodyPr/>
-                    <a:lstStyle/>
-                    <a:p>
-                      <a:pPr algn="ctr"/>
-                      <a:r>
-                        <a:rPr sz="1200" b="0" i="0">
-                          <a:solidFill>
-                            <a:srgbClr val="1F2A37"/>
-                          </a:solidFill>
-                          <a:latin typeface="Calibri"/>
-                        </a:rPr>
-                        <a:t>0.908</a:t>
-                      </a:r>
-                    </a:p>
-                  </a:txBody>
-                  <a:tcPr marT="25400" marB="25400" marL="76200" marR="76200" anchor="ctr">
-                    <a:solidFill>
-                      <a:srgbClr val="F3F5F7"/>
-                    </a:solidFill>
-                  </a:tcPr>
-                </a:tc>
-                <a:tc>
-                  <a:txBody>
-                    <a:bodyPr/>
-                    <a:lstStyle/>
-                    <a:p>
-                      <a:pPr algn="ctr"/>
-                      <a:r>
-                        <a:rPr sz="1200" b="0" i="0">
-                          <a:solidFill>
-                            <a:srgbClr val="1F2A37"/>
-                          </a:solidFill>
-                          <a:latin typeface="Calibri"/>
-                        </a:rPr>
-                        <a:t>0.783</a:t>
-                      </a:r>
-                    </a:p>
-                  </a:txBody>
-                  <a:tcPr marT="25400" marB="25400" marL="76200" marR="76200" anchor="ctr">
-                    <a:solidFill>
-                      <a:srgbClr val="F3F5F7"/>
-                    </a:solidFill>
-                  </a:tcPr>
-                </a:tc>
-                <a:tc>
-                  <a:txBody>
-                    <a:bodyPr/>
-                    <a:lstStyle/>
-                    <a:p>
-                      <a:pPr algn="ctr"/>
-                      <a:r>
-                        <a:rPr sz="1200" b="0" i="0">
-                          <a:solidFill>
-                            <a:srgbClr val="1F2A37"/>
-                          </a:solidFill>
-                          <a:latin typeface="Calibri"/>
-                        </a:rPr>
-                        <a:t>0.826</a:t>
-                      </a:r>
-                    </a:p>
-                  </a:txBody>
-                  <a:tcPr marT="25400" marB="25400" marL="76200" marR="76200" anchor="ctr">
-                    <a:solidFill>
-                      <a:srgbClr val="F3F5F7"/>
-                    </a:solidFill>
-                  </a:tcPr>
-                </a:tc>
-                <a:tc>
-                  <a:txBody>
-                    <a:bodyPr/>
-                    <a:lstStyle/>
-                    <a:p>
-                      <a:pPr algn="ctr"/>
-                      <a:r>
-                        <a:rPr sz="1200" b="0" i="0">
-                          <a:solidFill>
-                            <a:srgbClr val="1F2A37"/>
-                          </a:solidFill>
-                          <a:latin typeface="Calibri"/>
-                        </a:rPr>
-                        <a:t>0.856</a:t>
-                      </a:r>
-                    </a:p>
-                  </a:txBody>
-                  <a:tcPr marT="25400" marB="25400" marL="76200" marR="76200" anchor="ctr">
-                    <a:solidFill>
-                      <a:srgbClr val="F3F5F7"/>
-                    </a:solidFill>
-                  </a:tcPr>
-                </a:tc>
-                <a:tc>
-                  <a:txBody>
-                    <a:bodyPr/>
-                    <a:lstStyle/>
-                    <a:p>
-                      <a:pPr algn="ctr"/>
-                      <a:r>
-                        <a:rPr sz="1200" b="0" i="0">
-                          <a:solidFill>
-                            <a:srgbClr val="1F2A37"/>
-                          </a:solidFill>
-                          <a:latin typeface="Calibri"/>
-                        </a:rPr>
-                        <a:t>M2</a:t>
-                      </a:r>
-                    </a:p>
-                  </a:txBody>
-                  <a:tcPr marT="25400" marB="25400" marL="76200" marR="76200" anchor="ctr">
-                    <a:solidFill>
-                      <a:srgbClr val="F3F5F7"/>
-                    </a:solidFill>
-                  </a:tcPr>
-                </a:tc>
-              </a:tr>
-              <a:tr h="426720">
-                <a:tc>
-                  <a:txBody>
-                    <a:bodyPr/>
-                    <a:lstStyle/>
-                    <a:p>
-                      <a:pPr algn="l"/>
-                      <a:r>
-                        <a:rPr sz="1200" b="1" i="0">
-                          <a:solidFill>
-                            <a:srgbClr val="1F2A37"/>
-                          </a:solidFill>
-                          <a:latin typeface="Calibri"/>
-                        </a:rPr>
-                        <a:t>Cross-table MAD ↓</a:t>
-                      </a:r>
-                    </a:p>
-                  </a:txBody>
-                  <a:tcPr marT="25400" marB="25400" marL="76200" marR="76200" anchor="ctr">
-                    <a:solidFill>
-                      <a:srgbClr val="FFFFFF"/>
-                    </a:solidFill>
-                  </a:tcPr>
-                </a:tc>
-                <a:tc>
-                  <a:txBody>
-                    <a:bodyPr/>
-                    <a:lstStyle/>
-                    <a:p>
-                      <a:pPr algn="ctr"/>
-                      <a:r>
-                        <a:rPr sz="1200" b="0" i="0">
-                          <a:solidFill>
-                            <a:srgbClr val="1F2A37"/>
-                          </a:solidFill>
-                          <a:latin typeface="Calibri"/>
-                        </a:rPr>
-                        <a:t>0.379</a:t>
-                      </a:r>
-                    </a:p>
-                  </a:txBody>
-                  <a:tcPr marT="25400" marB="25400" marL="76200" marR="76200" anchor="ctr">
-                    <a:solidFill>
-                      <a:srgbClr val="FFFFFF"/>
-                    </a:solidFill>
-                  </a:tcPr>
-                </a:tc>
-                <a:tc>
-                  <a:txBody>
-                    <a:bodyPr/>
-                    <a:lstStyle/>
-                    <a:p>
-                      <a:pPr algn="ctr"/>
-                      <a:r>
-                        <a:rPr sz="1200" b="0" i="0">
-                          <a:solidFill>
-                            <a:srgbClr val="1F2A37"/>
-                          </a:solidFill>
-                          <a:latin typeface="Calibri"/>
-                        </a:rPr>
-                        <a:t>0.394</a:t>
-                      </a:r>
-                    </a:p>
-                  </a:txBody>
-                  <a:tcPr marT="25400" marB="25400" marL="76200" marR="76200" anchor="ctr">
-                    <a:solidFill>
-                      <a:srgbClr val="FFFFFF"/>
-                    </a:solidFill>
-                  </a:tcPr>
-                </a:tc>
-                <a:tc>
-                  <a:txBody>
-                    <a:bodyPr/>
-                    <a:lstStyle/>
-                    <a:p>
-                      <a:pPr algn="ctr"/>
-                      <a:r>
-                        <a:rPr sz="1200" b="0" i="0">
-                          <a:solidFill>
-                            <a:srgbClr val="1F2A37"/>
-                          </a:solidFill>
-                          <a:latin typeface="Calibri"/>
-                        </a:rPr>
-                        <a:t>0.296</a:t>
-                      </a:r>
-                    </a:p>
-                  </a:txBody>
-                  <a:tcPr marT="25400" marB="25400" marL="76200" marR="76200" anchor="ctr">
-                    <a:solidFill>
-                      <a:srgbClr val="FFFFFF"/>
-                    </a:solidFill>
-                  </a:tcPr>
-                </a:tc>
-                <a:tc>
-                  <a:txBody>
-                    <a:bodyPr/>
-                    <a:lstStyle/>
-                    <a:p>
-                      <a:pPr algn="ctr"/>
-                      <a:r>
-                        <a:rPr sz="1200" b="0" i="0">
-                          <a:solidFill>
-                            <a:srgbClr val="1F2A37"/>
-                          </a:solidFill>
-                          <a:latin typeface="Calibri"/>
-                        </a:rPr>
-                        <a:t>0.392</a:t>
-                      </a:r>
-                    </a:p>
-                  </a:txBody>
-                  <a:tcPr marT="25400" marB="25400" marL="76200" marR="76200" anchor="ctr">
-                    <a:solidFill>
-                      <a:srgbClr val="FFFFFF"/>
-                    </a:solidFill>
-                  </a:tcPr>
-                </a:tc>
-                <a:tc>
-                  <a:txBody>
-                    <a:bodyPr/>
-                    <a:lstStyle/>
-                    <a:p>
-                      <a:pPr algn="ctr"/>
-                      <a:r>
-                        <a:rPr sz="1200" b="0" i="0">
-                          <a:solidFill>
-                            <a:srgbClr val="1F2A37"/>
-                          </a:solidFill>
-                          <a:latin typeface="Calibri"/>
-                        </a:rPr>
-                        <a:t>0.387</a:t>
-                      </a:r>
-                    </a:p>
-                  </a:txBody>
-                  <a:tcPr marT="25400" marB="25400" marL="76200" marR="76200" anchor="ctr">
-                    <a:solidFill>
-                      <a:srgbClr val="FFFFFF"/>
-                    </a:solidFill>
-                  </a:tcPr>
-                </a:tc>
-                <a:tc>
-                  <a:txBody>
-                    <a:bodyPr/>
-                    <a:lstStyle/>
-                    <a:p>
-                      <a:pPr algn="ctr"/>
-                      <a:r>
-                        <a:rPr sz="1200" b="0" i="0">
-                          <a:solidFill>
-                            <a:srgbClr val="1F2A37"/>
-                          </a:solidFill>
-                          <a:latin typeface="Calibri"/>
-                        </a:rPr>
-                        <a:t>M3</a:t>
-                      </a:r>
-                    </a:p>
-                  </a:txBody>
-                  <a:tcPr marT="25400" marB="25400" marL="76200" marR="76200" anchor="ctr">
-                    <a:solidFill>
-                      <a:srgbClr val="FFFFFF"/>
-                    </a:solidFill>
-                  </a:tcPr>
-                </a:tc>
-              </a:tr>
-              <a:tr h="426720">
-                <a:tc>
-                  <a:txBody>
-                    <a:bodyPr/>
-                    <a:lstStyle/>
-                    <a:p>
-                      <a:pPr algn="l"/>
-                      <a:r>
-                        <a:rPr sz="1200" b="1" i="0">
-                          <a:solidFill>
-                            <a:srgbClr val="1F2A37"/>
-                          </a:solidFill>
-                          <a:latin typeface="Calibri"/>
-                        </a:rPr>
-                        <a:t>Autocorr MAE ↓</a:t>
-                      </a:r>
-                    </a:p>
-                  </a:txBody>
-                  <a:tcPr marT="25400" marB="25400" marL="76200" marR="76200" anchor="ctr">
-                    <a:solidFill>
-                      <a:srgbClr val="F3F5F7"/>
-                    </a:solidFill>
-                  </a:tcPr>
-                </a:tc>
-                <a:tc>
-                  <a:txBody>
-                    <a:bodyPr/>
-                    <a:lstStyle/>
-                    <a:p>
-                      <a:pPr algn="ctr"/>
-                      <a:r>
-                        <a:rPr sz="1200" b="0" i="0">
-                          <a:solidFill>
-                            <a:srgbClr val="1F2A37"/>
-                          </a:solidFill>
-                          <a:latin typeface="Calibri"/>
-                        </a:rPr>
-                        <a:t>0.079</a:t>
-                      </a:r>
-                    </a:p>
-                  </a:txBody>
-                  <a:tcPr marT="25400" marB="25400" marL="76200" marR="76200" anchor="ctr">
-                    <a:solidFill>
-                      <a:srgbClr val="F3F5F7"/>
-                    </a:solidFill>
-                  </a:tcPr>
-                </a:tc>
-                <a:tc>
-                  <a:txBody>
-                    <a:bodyPr/>
-                    <a:lstStyle/>
-                    <a:p>
-                      <a:pPr algn="ctr"/>
-                      <a:r>
-                        <a:rPr sz="1200" b="0" i="0">
-                          <a:solidFill>
-                            <a:srgbClr val="1F2A37"/>
-                          </a:solidFill>
-                          <a:latin typeface="Calibri"/>
-                        </a:rPr>
-                        <a:t>0.011</a:t>
-                      </a:r>
-                    </a:p>
-                  </a:txBody>
-                  <a:tcPr marT="25400" marB="25400" marL="76200" marR="76200" anchor="ctr">
-                    <a:solidFill>
-                      <a:srgbClr val="F3F5F7"/>
-                    </a:solidFill>
-                  </a:tcPr>
-                </a:tc>
-                <a:tc>
-                  <a:txBody>
-                    <a:bodyPr/>
-                    <a:lstStyle/>
-                    <a:p>
-                      <a:pPr algn="ctr"/>
-                      <a:r>
-                        <a:rPr sz="1200" b="0" i="0">
-                          <a:solidFill>
-                            <a:srgbClr val="1F2A37"/>
-                          </a:solidFill>
-                          <a:latin typeface="Calibri"/>
-                        </a:rPr>
-                        <a:t>0.041</a:t>
-                      </a:r>
-                    </a:p>
-                  </a:txBody>
-                  <a:tcPr marT="25400" marB="25400" marL="76200" marR="76200" anchor="ctr">
-                    <a:solidFill>
-                      <a:srgbClr val="F3F5F7"/>
-                    </a:solidFill>
-                  </a:tcPr>
-                </a:tc>
-                <a:tc>
-                  <a:txBody>
-                    <a:bodyPr/>
-                    <a:lstStyle/>
-                    <a:p>
-                      <a:pPr algn="ctr"/>
-                      <a:r>
-                        <a:rPr sz="1200" b="0" i="0">
-                          <a:solidFill>
-                            <a:srgbClr val="1F2A37"/>
-                          </a:solidFill>
-                          <a:latin typeface="Calibri"/>
-                        </a:rPr>
-                        <a:t>0.028</a:t>
-                      </a:r>
-                    </a:p>
-                  </a:txBody>
-                  <a:tcPr marT="25400" marB="25400" marL="76200" marR="76200" anchor="ctr">
-                    <a:solidFill>
-                      <a:srgbClr val="F3F5F7"/>
-                    </a:solidFill>
-                  </a:tcPr>
-                </a:tc>
-                <a:tc>
-                  <a:txBody>
-                    <a:bodyPr/>
-                    <a:lstStyle/>
-                    <a:p>
-                      <a:pPr algn="ctr"/>
-                      <a:r>
-                        <a:rPr sz="1200" b="0" i="0">
-                          <a:solidFill>
-                            <a:srgbClr val="1F2A37"/>
-                          </a:solidFill>
-                          <a:latin typeface="Calibri"/>
-                        </a:rPr>
-                        <a:t>0.569</a:t>
-                      </a:r>
-                    </a:p>
-                  </a:txBody>
-                  <a:tcPr marT="25400" marB="25400" marL="76200" marR="76200" anchor="ctr">
-                    <a:solidFill>
-                      <a:srgbClr val="F3F5F7"/>
-                    </a:solidFill>
-                  </a:tcPr>
-                </a:tc>
-                <a:tc>
-                  <a:txBody>
-                    <a:bodyPr/>
-                    <a:lstStyle/>
-                    <a:p>
-                      <a:pPr algn="ctr"/>
-                      <a:r>
-                        <a:rPr sz="1200" b="0" i="0">
-                          <a:solidFill>
-                            <a:srgbClr val="1F2A37"/>
-                          </a:solidFill>
-                          <a:latin typeface="Calibri"/>
-                        </a:rPr>
-                        <a:t>M2</a:t>
-                      </a:r>
-                    </a:p>
-                  </a:txBody>
-                  <a:tcPr marT="25400" marB="25400" marL="76200" marR="76200" anchor="ctr">
-                    <a:solidFill>
-                      <a:srgbClr val="F3F5F7"/>
-                    </a:solidFill>
-                  </a:tcPr>
-                </a:tc>
-              </a:tr>
-              <a:tr h="426720">
-                <a:tc>
-                  <a:txBody>
-                    <a:bodyPr/>
-                    <a:lstStyle/>
-                    <a:p>
-                      <a:pPr algn="l"/>
-                      <a:r>
-                        <a:rPr sz="1200" b="1" i="0">
-                          <a:solidFill>
-                            <a:srgbClr val="1F2A37"/>
-                          </a:solidFill>
-                          <a:latin typeface="Calibri"/>
-                        </a:rPr>
-                        <a:t>Diff. privacy</a:t>
-                      </a:r>
-                    </a:p>
-                  </a:txBody>
-                  <a:tcPr marT="25400" marB="25400" marL="76200" marR="76200" anchor="ctr">
-                    <a:solidFill>
-                      <a:srgbClr val="FFFFFF"/>
-                    </a:solidFill>
-                  </a:tcPr>
-                </a:tc>
-                <a:tc>
-                  <a:txBody>
-                    <a:bodyPr/>
-                    <a:lstStyle/>
-                    <a:p>
-                      <a:pPr algn="ctr"/>
-                      <a:r>
-                        <a:rPr sz="1200" b="0" i="0">
-                          <a:solidFill>
-                            <a:srgbClr val="1F2A37"/>
-                          </a:solidFill>
-                          <a:latin typeface="Calibri"/>
-                        </a:rPr>
-                        <a:t>✗</a:t>
-                      </a:r>
-                    </a:p>
-                  </a:txBody>
-                  <a:tcPr marT="25400" marB="25400" marL="76200" marR="76200" anchor="ctr">
-                    <a:solidFill>
-                      <a:srgbClr val="FFFFFF"/>
-                    </a:solidFill>
-                  </a:tcPr>
-                </a:tc>
-                <a:tc>
-                  <a:txBody>
-                    <a:bodyPr/>
-                    <a:lstStyle/>
-                    <a:p>
-                      <a:pPr algn="ctr"/>
-                      <a:r>
-                        <a:rPr sz="1200" b="0" i="0">
-                          <a:solidFill>
-                            <a:srgbClr val="1F2A37"/>
-                          </a:solidFill>
-                          <a:latin typeface="Calibri"/>
-                        </a:rPr>
-                        <a:t>✗</a:t>
-                      </a:r>
-                    </a:p>
-                  </a:txBody>
-                  <a:tcPr marT="25400" marB="25400" marL="76200" marR="76200" anchor="ctr">
-                    <a:solidFill>
-                      <a:srgbClr val="FFFFFF"/>
-                    </a:solidFill>
-                  </a:tcPr>
-                </a:tc>
-                <a:tc>
-                  <a:txBody>
-                    <a:bodyPr/>
-                    <a:lstStyle/>
-                    <a:p>
-                      <a:pPr algn="ctr"/>
-                      <a:r>
-                        <a:rPr sz="1200" b="0" i="0">
-                          <a:solidFill>
-                            <a:srgbClr val="1F2A37"/>
-                          </a:solidFill>
-                          <a:latin typeface="Calibri"/>
-                        </a:rPr>
-                        <a:t>✗</a:t>
-                      </a:r>
-                    </a:p>
-                  </a:txBody>
-                  <a:tcPr marT="25400" marB="25400" marL="76200" marR="76200" anchor="ctr">
-                    <a:solidFill>
-                      <a:srgbClr val="FFFFFF"/>
-                    </a:solidFill>
-                  </a:tcPr>
-                </a:tc>
-                <a:tc>
-                  <a:txBody>
-                    <a:bodyPr/>
-                    <a:lstStyle/>
-                    <a:p>
-                      <a:pPr algn="ctr"/>
-                      <a:r>
-                        <a:rPr sz="1200" b="0" i="0">
-                          <a:solidFill>
-                            <a:srgbClr val="1F2A37"/>
-                          </a:solidFill>
-                          <a:latin typeface="Calibri"/>
-                        </a:rPr>
-                        <a:t>✗</a:t>
-                      </a:r>
-                    </a:p>
-                  </a:txBody>
-                  <a:tcPr marT="25400" marB="25400" marL="76200" marR="76200" anchor="ctr">
-                    <a:solidFill>
-                      <a:srgbClr val="FFFFFF"/>
-                    </a:solidFill>
-                  </a:tcPr>
-                </a:tc>
-                <a:tc>
-                  <a:txBody>
-                    <a:bodyPr/>
-                    <a:lstStyle/>
-                    <a:p>
-                      <a:pPr algn="ctr"/>
-                      <a:r>
-                        <a:rPr sz="1200" b="0" i="0">
-                          <a:solidFill>
-                            <a:srgbClr val="1F2A37"/>
-                          </a:solidFill>
-                          <a:latin typeface="Calibri"/>
-                        </a:rPr>
-                        <a:t>✓</a:t>
-                      </a:r>
-                    </a:p>
-                  </a:txBody>
-                  <a:tcPr marT="25400" marB="25400" marL="76200" marR="76200" anchor="ctr">
-                    <a:solidFill>
-                      <a:srgbClr val="FFFFFF"/>
-                    </a:solidFill>
-                  </a:tcPr>
-                </a:tc>
-                <a:tc>
-                  <a:txBody>
-                    <a:bodyPr/>
-                    <a:lstStyle/>
-                    <a:p>
-                      <a:pPr algn="ctr"/>
-                      <a:r>
-                        <a:rPr sz="1200" b="0" i="0">
-                          <a:solidFill>
-                            <a:srgbClr val="1F2A37"/>
-                          </a:solidFill>
-                          <a:latin typeface="Calibri"/>
-                        </a:rPr>
-                        <a:t>M5</a:t>
-                      </a:r>
-                    </a:p>
-                  </a:txBody>
-                  <a:tcPr marT="25400" marB="25400" marL="76200" marR="76200" anchor="ctr">
-                    <a:solidFill>
-                      <a:srgbClr val="FFFFFF"/>
-                    </a:solidFill>
-                  </a:tcPr>
-                </a:tc>
-              </a:tr>
-              <a:tr h="426720">
-                <a:tc>
-                  <a:txBody>
-                    <a:bodyPr/>
-                    <a:lstStyle/>
-                    <a:p>
-                      <a:pPr algn="l"/>
-                      <a:r>
-                        <a:rPr sz="1200" b="1" i="0">
-                          <a:solidFill>
-                            <a:srgbClr val="1F2A37"/>
-                          </a:solidFill>
-                          <a:latin typeface="Calibri"/>
-                        </a:rPr>
-                        <a:t>DCR protection ↑</a:t>
-                      </a:r>
-                    </a:p>
-                  </a:txBody>
-                  <a:tcPr marT="25400" marB="25400" marL="76200" marR="76200" anchor="ctr">
-                    <a:solidFill>
-                      <a:srgbClr val="F3F5F7"/>
-                    </a:solidFill>
-                  </a:tcPr>
-                </a:tc>
-                <a:tc>
-                  <a:txBody>
-                    <a:bodyPr/>
-                    <a:lstStyle/>
-                    <a:p>
-                      <a:pPr algn="ctr"/>
-                      <a:r>
-                        <a:rPr sz="1200" b="0" i="0">
-                          <a:solidFill>
-                            <a:srgbClr val="1F2A37"/>
-                          </a:solidFill>
-                          <a:latin typeface="Calibri"/>
-                        </a:rPr>
-                        <a:t>0.61</a:t>
-                      </a:r>
-                    </a:p>
-                  </a:txBody>
-                  <a:tcPr marT="25400" marB="25400" marL="76200" marR="76200" anchor="ctr">
-                    <a:solidFill>
-                      <a:srgbClr val="F3F5F7"/>
-                    </a:solidFill>
-                  </a:tcPr>
-                </a:tc>
-                <a:tc>
-                  <a:txBody>
-                    <a:bodyPr/>
-                    <a:lstStyle/>
-                    <a:p>
-                      <a:pPr algn="ctr"/>
-                      <a:r>
-                        <a:rPr sz="1200" b="0" i="0">
-                          <a:solidFill>
-                            <a:srgbClr val="1F2A37"/>
-                          </a:solidFill>
-                          <a:latin typeface="Calibri"/>
-                        </a:rPr>
-                        <a:t>0.69</a:t>
-                      </a:r>
-                    </a:p>
-                  </a:txBody>
-                  <a:tcPr marT="25400" marB="25400" marL="76200" marR="76200" anchor="ctr">
-                    <a:solidFill>
-                      <a:srgbClr val="F3F5F7"/>
-                    </a:solidFill>
-                  </a:tcPr>
-                </a:tc>
-                <a:tc>
-                  <a:txBody>
-                    <a:bodyPr/>
-                    <a:lstStyle/>
-                    <a:p>
-                      <a:pPr algn="ctr"/>
-                      <a:r>
-                        <a:rPr sz="1200" b="0" i="0">
-                          <a:solidFill>
-                            <a:srgbClr val="1F2A37"/>
-                          </a:solidFill>
-                          <a:latin typeface="Calibri"/>
-                        </a:rPr>
-                        <a:t>0.74</a:t>
-                      </a:r>
-                    </a:p>
-                  </a:txBody>
-                  <a:tcPr marT="25400" marB="25400" marL="76200" marR="76200" anchor="ctr">
-                    <a:solidFill>
-                      <a:srgbClr val="F3F5F7"/>
-                    </a:solidFill>
-                  </a:tcPr>
-                </a:tc>
-                <a:tc>
-                  <a:txBody>
-                    <a:bodyPr/>
-                    <a:lstStyle/>
-                    <a:p>
-                      <a:pPr algn="ctr"/>
-                      <a:r>
-                        <a:rPr sz="1200" b="0" i="0">
-                          <a:solidFill>
-                            <a:srgbClr val="1F2A37"/>
-                          </a:solidFill>
-                          <a:latin typeface="Calibri"/>
-                        </a:rPr>
-                        <a:t>0.65</a:t>
-                      </a:r>
-                    </a:p>
-                  </a:txBody>
-                  <a:tcPr marT="25400" marB="25400" marL="76200" marR="76200" anchor="ctr">
-                    <a:solidFill>
-                      <a:srgbClr val="F3F5F7"/>
-                    </a:solidFill>
-                  </a:tcPr>
-                </a:tc>
-                <a:tc>
-                  <a:txBody>
-                    <a:bodyPr/>
-                    <a:lstStyle/>
-                    <a:p>
-                      <a:pPr algn="ctr"/>
-                      <a:r>
-                        <a:rPr sz="1200" b="0" i="0">
-                          <a:solidFill>
-                            <a:srgbClr val="1F2A37"/>
-                          </a:solidFill>
-                          <a:latin typeface="Calibri"/>
-                        </a:rPr>
-                        <a:t>0.57</a:t>
-                      </a:r>
-                    </a:p>
-                  </a:txBody>
-                  <a:tcPr marT="25400" marB="25400" marL="76200" marR="76200" anchor="ctr">
-                    <a:solidFill>
-                      <a:srgbClr val="F3F5F7"/>
-                    </a:solidFill>
-                  </a:tcPr>
-                </a:tc>
-                <a:tc>
-                  <a:txBody>
-                    <a:bodyPr/>
-                    <a:lstStyle/>
-                    <a:p>
-                      <a:pPr algn="ctr"/>
-                      <a:r>
-                        <a:rPr sz="1200" b="0" i="0">
-                          <a:solidFill>
-                            <a:srgbClr val="1F2A37"/>
-                          </a:solidFill>
-                          <a:latin typeface="Calibri"/>
-                        </a:rPr>
-                        <a:t>M3</a:t>
-                      </a:r>
-                    </a:p>
-                  </a:txBody>
-                  <a:tcPr marT="25400" marB="25400" marL="76200" marR="76200" anchor="ctr">
-                    <a:solidFill>
-                      <a:srgbClr val="F3F5F7"/>
-                    </a:solidFill>
-                  </a:tcPr>
-                </a:tc>
-              </a:tr>
-            </a:tbl>
-          </a:graphicData>
-        </a:graphic>
-      </p:graphicFrame>
-      <p:sp>
-        <p:nvSpPr>
-          <p:cNvPr id="5" name="TextBox 4"/>
-          <p:cNvSpPr txBox="1"/>
-          <p:nvPr/>
-        </p:nvSpPr>
-        <p:spPr>
-          <a:xfrm>
-            <a:off x="9281160" y="1737360"/>
-            <a:ext cx="2651760" cy="3931920"/>
-          </a:xfrm>
-          <a:prstGeom prst="rect">
-            <a:avLst/>
-          </a:prstGeom>
-          <a:noFill/>
-        </p:spPr>
-        <p:txBody>
-          <a:bodyPr wrap="square">
-            <a:spAutoFit/>
-          </a:bodyPr>
-          <a:lstStyle/>
-          <a:p>
-            <a:pPr algn="l"/>
-            <a:r>
-              <a:rPr sz="1600" b="1" i="0">
-                <a:solidFill>
-                  <a:srgbClr val="4E79A7"/>
-                </a:solidFill>
-                <a:latin typeface="Calibri"/>
-              </a:rPr>
-              <a:t>Pick by need</a:t>
-            </a:r>
-          </a:p>
-          <a:p>
-            <a:pPr algn="l">
-              <a:spcAft>
-                <a:spcPts val="700"/>
-              </a:spcAft>
-            </a:pPr>
-            <a:r>
-              <a:rPr sz="1300" b="0" i="0">
-                <a:solidFill>
-                  <a:srgbClr val="1F2A37"/>
-                </a:solidFill>
-                <a:latin typeface="Calibri"/>
-              </a:rPr>
-              <a:t>• M1 ≈ M4 — best all-round fidelity</a:t>
-            </a:r>
-          </a:p>
-          <a:p>
-            <a:pPr algn="l">
-              <a:spcAft>
-                <a:spcPts val="700"/>
-              </a:spcAft>
-            </a:pPr>
-            <a:r>
-              <a:rPr sz="1300" b="0" i="0">
-                <a:solidFill>
-                  <a:srgbClr val="1F2A37"/>
-                </a:solidFill>
-                <a:latin typeface="Calibri"/>
-              </a:rPr>
-              <a:t>• M1 — demographic correlations (recommender)</a:t>
-            </a:r>
-          </a:p>
-          <a:p>
-            <a:pPr algn="l">
-              <a:spcAft>
-                <a:spcPts val="700"/>
-              </a:spcAft>
-            </a:pPr>
-            <a:r>
-              <a:rPr sz="1300" b="0" i="0">
-                <a:solidFill>
-                  <a:srgbClr val="1F2A37"/>
-                </a:solidFill>
-                <a:latin typeface="Calibri"/>
-              </a:rPr>
-              <a:t>• M2 — transaction shapes &amp; timing</a:t>
-            </a:r>
-          </a:p>
-          <a:p>
-            <a:pPr algn="l">
-              <a:spcAft>
-                <a:spcPts val="700"/>
-              </a:spcAft>
-            </a:pPr>
-            <a:r>
-              <a:rPr sz="1300" b="0" i="0">
-                <a:solidFill>
-                  <a:srgbClr val="1F2A37"/>
-                </a:solidFill>
-                <a:latin typeface="Calibri"/>
-              </a:rPr>
-              <a:t>• M5 — the only privacy guarantee</a:t>
-            </a:r>
-          </a:p>
-          <a:p>
-            <a:pPr algn="l">
-              <a:spcAft>
-                <a:spcPts val="700"/>
-              </a:spcAft>
-            </a:pPr>
-            <a:r>
-              <a:rPr sz="1300" b="0" i="0">
-                <a:solidFill>
-                  <a:srgbClr val="1F2A37"/>
-                </a:solidFill>
-                <a:latin typeface="Calibri"/>
-              </a:rPr>
-              <a:t>• M3 — cross-table &amp; DCR, low utility</a:t>
-            </a:r>
-          </a:p>
-          <a:p>
-            <a:pPr algn="l"/>
-            <a:r>
-              <a:rPr sz="1200" b="0" i="1">
-                <a:solidFill>
-                  <a:srgbClr val="B07AA1"/>
-                </a:solidFill>
-                <a:latin typeface="Calibri"/>
-              </a:rPr>
-              <a:t>More data closed M5's quality lead; 12 txns/cust exposed its temporal gap.</a:t>
-            </a:r>
-          </a:p>
-        </p:txBody>
-      </p:sp>
-    </p:spTree>
-  </p:cSld>
-  <p:clrMapOvr>
-    <a:masterClrMapping/>
-  </p:clrMapOvr>
-</p:sld>
-</file>
-
-<file path=ppt/slides/slide21.xml><?xml version="1.0" encoding="utf-8"?>
-<p:sld xmlns:a="http://schemas.openxmlformats.org/drawingml/2006/main" xmlns:p="http://schemas.openxmlformats.org/presentationml/2006/main" xmlns:r="http://schemas.openxmlformats.org/officeDocument/2006/relationships">
-  <p:cSld>
-    <p:bg>
-      <p:bgPr>
-        <a:solidFill>
-          <a:srgbClr val="FFFFFF"/>
-        </a:solidFill>
-        <a:effectLst/>
-      </p:bgPr>
-    </p:bg>
-    <p:spTree>
-      <p:nvGrpSpPr>
-        <p:cNvPr id="1" name=""/>
-        <p:cNvGrpSpPr/>
-        <p:nvPr/>
-      </p:nvGrpSpPr>
-      <p:grpSpPr/>
-      <p:sp>
-        <p:nvSpPr>
-          <p:cNvPr id="2" name="Rectangle 1"/>
-          <p:cNvSpPr/>
-          <p:nvPr/>
-        </p:nvSpPr>
-        <p:spPr>
-          <a:xfrm>
-            <a:off x="0" y="0"/>
-            <a:ext cx="201168" cy="6858000"/>
-          </a:xfrm>
-          <a:prstGeom prst="rect">
-            <a:avLst/>
-          </a:prstGeom>
-          <a:solidFill>
-            <a:srgbClr val="4E79A7"/>
-          </a:solidFill>
-          <a:ln>
-            <a:noFill/>
-          </a:ln>
-        </p:spPr>
-        <p:style>
-          <a:lnRef idx="1">
-            <a:schemeClr val="accent1"/>
-          </a:lnRef>
-          <a:fillRef idx="3">
-            <a:schemeClr val="accent1"/>
-          </a:fillRef>
-          <a:effectRef idx="2">
-            <a:schemeClr val="accent1"/>
-          </a:effectRef>
-          <a:fontRef idx="minor">
-            <a:schemeClr val="lt1"/>
-          </a:fontRef>
-        </p:style>
-        <p:txBody>
-          <a:bodyPr rtlCol="0" anchor="ctr"/>
-          <a:lstStyle/>
-          <a:p>
-            <a:pPr algn="ctr"/>
-          </a:p>
-        </p:txBody>
-      </p:sp>
-      <p:sp>
-        <p:nvSpPr>
-          <p:cNvPr id="3" name="TextBox 2"/>
-          <p:cNvSpPr txBox="1"/>
-          <p:nvPr/>
-        </p:nvSpPr>
-        <p:spPr>
-          <a:xfrm>
-            <a:off x="548640" y="384048"/>
-            <a:ext cx="11155680" cy="1005840"/>
-          </a:xfrm>
-          <a:prstGeom prst="rect">
-            <a:avLst/>
-          </a:prstGeom>
-          <a:noFill/>
-        </p:spPr>
-        <p:txBody>
-          <a:bodyPr wrap="none">
-            <a:spAutoFit/>
-          </a:bodyPr>
-          <a:lstStyle/>
-          <a:p>
-            <a:pPr algn="l"/>
-            <a:r>
-              <a:rPr sz="1300" b="1" i="0">
-                <a:solidFill>
-                  <a:srgbClr val="4E79A7"/>
-                </a:solidFill>
-                <a:latin typeface="Calibri"/>
-              </a:rPr>
               <a:t>ROBUSTNESS</a:t>
             </a:r>
           </a:p>
@@ -9299,7 +9590,7 @@
 </p:sld>
 </file>
 
-<file path=ppt/slides/slide22.xml><?xml version="1.0" encoding="utf-8"?>
+<file path=ppt/slides/slide23.xml><?xml version="1.0" encoding="utf-8"?>
 <p:sld xmlns:a="http://schemas.openxmlformats.org/drawingml/2006/main" xmlns:p="http://schemas.openxmlformats.org/presentationml/2006/main" xmlns:r="http://schemas.openxmlformats.org/officeDocument/2006/relationships">
   <p:cSld>
     <p:bg>
@@ -9828,7 +10119,7 @@
 </p:sld>
 </file>
 
-<file path=ppt/slides/slide23.xml><?xml version="1.0" encoding="utf-8"?>
+<file path=ppt/slides/slide24.xml><?xml version="1.0" encoding="utf-8"?>
 <p:sld xmlns:a="http://schemas.openxmlformats.org/drawingml/2006/main" xmlns:p="http://schemas.openxmlformats.org/presentationml/2006/main" xmlns:r="http://schemas.openxmlformats.org/officeDocument/2006/relationships">
   <p:cSld>
     <p:bg>

</xml_diff>